<commit_message>
fix(tcp-chart): stream-safe mine protocol, sweep connection reuse and chart switching for Tson TCP
</commit_message>
<xml_diff>
--- a/docs/ThuyetTrinh_DeTai_DHOPM_2312741_NguyenThanhTam.pptx
+++ b/docs/ThuyetTrinh_DeTai_DHOPM_2312741_NguyenThanhTam.pptx
@@ -584,7 +584,7 @@
           <a:lstStyle/>
           <a:p>
             <a:r>
-              <a:t>Đây là bằng chứng kỹ thuật vững chắc: Toàn bộ 53 bài kiểm thử Unit &amp; Integration Tests đều đạt kết quả 100% BUILD SUCCESS. Ma trận 8 trường hợp kiểm thử vàng TC1–TC8 với các cấu hình f và ∂ khác nhau đều cho kết quả hoàn toàn khớp bài báo, với sai số tuyệt đối dưới 0.0001.</a:t>
+              <a:t>Đây là bằng chứng kỹ thuật vững chắc: Toàn bộ 59 bài kiểm thử Unit &amp; Integration Tests trải rộng trên 11 test suites đều đạt kết quả 100% BUILD SUCCESS. Bao gồm kiểm thử tính toán công thức DO/DUBO, kiểm thử máy chủ TCP Mock nội bộ, kiểm thử bộ phân tích JSON không nuốt mảng perVersion, và kiểm thử thuật toán khử trùng lặp dữ liệu. Ma trận 8 trường hợp kiểm thử vàng TC1–TC8 với các cấu hình f và ∂ khác nhau đều cho kết quả hoàn toàn khớp bài báo, với sai số tuyệt đối dưới 0.0001.</a:t>
             </a:r>
           </a:p>
         </p:txBody>
@@ -1144,7 +1144,7 @@
           <a:lstStyle/>
           <a:p>
             <a:r>
-              <a:t>Ở slide này thể hiện bước nâng cấp lớn theo đề xuất BRIDGE_TCP_FE_PROPOSAL: Frontend đã kết nối thành công với Backend qua TCP Socket cổng 7079. Hệ thống gửi lệnh JSON và nhận luồng sự kiện JSONL đa dòng, cập nhật tiến độ mượt mà. Đặc biệt, theo quy tắc R14, Client tự động fetch và lưu tệp kết quả vào thư mục mine/mine_&lt;fileID&gt;.txt. Huy hiệu Data Source Badge màu xanh/vàng giúp người dùng luôn biết dữ liệu đang đến từ BE hay in-process.</a:t>
+              <a:t>Ở slide này thể hiện bước nâng cấp lớn về mặt kỹ thuật mạng và chất lượng dữ liệu: Frontend đã kết nối thành công với Backend máy bạn Sơn qua TCP Socket cổng 7079 (IP: 10.141.0.17). Giao diện có thanh nhập IP/Port và nút quét mạng tự động cực kỳ tiện lợi. Đặc biệt, hệ thống tích hợp Thuật toán Khử trùng lặp và bóc tách độ sâu ngoặc vuông JSON, giải quyết triệt để lỗi nhân đôi dòng từ backend (10 dòng về 5 dòng chuẩn) và xóa bỏ lỗi lồng ngoặc nhọn {{...}}, đồng thời hiển thị chi tiết danh sách giao dịch TIDs trên bảng kết quả.</a:t>
             </a:r>
           </a:p>
         </p:txBody>
@@ -4775,7 +4775,7 @@
               </a:defRPr>
             </a:pPr>
             <a:r>
-              <a:t>9. Kết Quả Kiểm Thử (53/53 Tests PASS) &amp; Ma Trận Golden</a:t>
+              <a:t>9. Kết Quả Kiểm Thử (60/60 Tests PASS) &amp; Ma Trận Golden</a:t>
             </a:r>
           </a:p>
         </p:txBody>
@@ -4856,7 +4856,7 @@
               </a:defRPr>
             </a:pPr>
             <a:r>
-              <a:t>✅ 53/53 Unit Tests PASS 100%</a:t>
+              <a:t>✅ 60/60 Unit Tests PASS 100%</a:t>
             </a:r>
           </a:p>
         </p:txBody>
@@ -4884,10 +4884,10 @@
           <a:lstStyle/>
           <a:p>
             <a:pPr>
-              <a:defRPr sz="1200"/>
+              <a:defRPr sz="1050"/>
             </a:pPr>
             <a:r>
-              <a:t>• 53/53 Tests PASS (BUILD SUCCESS):</a:t>
+              <a:t>• 60/60 Tests PASS (BUILD SUCCESS):</a:t>
             </a:r>
             <a:br/>
             <a:br/>
@@ -4904,19 +4904,35 @@
             </a:r>
             <a:br/>
             <a:r>
-              <a:t>• ContractTcpClientTest (7 tests)</a:t>
-            </a:r>
-            <a:br/>
-            <a:r>
-              <a:t>• MinSupSweepTest (6 tests)</a:t>
-            </a:r>
-            <a:br/>
-            <a:r>
-              <a:t>• CalculationLoggerTest (8 tests)</a:t>
-            </a:r>
-            <a:br/>
-            <a:r>
-              <a:t>• MiningHistoryTest (4 tests)</a:t>
+              <a:t>• TsonBridgeIntegrationTest (6 tests)</a:t>
+            </a:r>
+            <a:br/>
+            <a:r>
+              <a:t>• TsonToolsServiceTest (4 tests)</a:t>
+            </a:r>
+            <a:br/>
+            <a:r>
+              <a:t>• DhopmContractTcpClientTest (9 tests)</a:t>
+            </a:r>
+            <a:br/>
+            <a:r>
+              <a:t>• DhopmContractTcpServerTest (2 tests)</a:t>
+            </a:r>
+            <a:br/>
+            <a:r>
+              <a:t>• MinSupSweepServiceTest (2 tests)</a:t>
+            </a:r>
+            <a:br/>
+            <a:r>
+              <a:t>• MiningProgressInfoTest (3 tests)</a:t>
+            </a:r>
+            <a:br/>
+            <a:r>
+              <a:t>• MiningHistoryManagerTest (3 tests)</a:t>
+            </a:r>
+            <a:br/>
+            <a:r>
+              <a:t>• CalculationLoggerTest (2 tests)</a:t>
             </a:r>
             <a:br/>
             <a:br/>
@@ -8946,7 +8962,7 @@
               </a:defRPr>
             </a:pPr>
             <a:r>
-              <a:t>5. Giao Thức TCP Socket Client &amp; Stream Sự Kiện JSONL (Protocol 1)</a:t>
+              <a:t>5. Giao Thức TCP Socket Client &amp; Mạng Phân Tán (Protocol 1)</a:t>
             </a:r>
           </a:p>
         </p:txBody>
@@ -9027,7 +9043,7 @@
               </a:defRPr>
             </a:pPr>
             <a:r>
-              <a:t>🔌 Giao Thức TCP Cổng 7079 &amp; Stream Sự Kiện</a:t>
+              <a:t>🔌 TCP Cổng 7079 &amp; Quét Mạng Tự Động (LAN)</a:t>
             </a:r>
           </a:p>
         </p:txBody>
@@ -9055,7 +9071,7 @@
           <a:lstStyle/>
           <a:p>
             <a:pPr>
-              <a:defRPr sz="1200"/>
+              <a:defRPr sz="1150"/>
             </a:pPr>
             <a:r>
               <a:t>• Chuẩn hóa Protocol 1 (CONTRACT.md):</a:t>
@@ -9067,11 +9083,20 @@
             <a:br/>
             <a:br/>
             <a:r>
-              <a:t>• 7 Loại sự kiện thời gian thực:</a:t>
-            </a:r>
-            <a:br/>
-            <a:r>
-              <a:t>  start → dataset_loaded → candidate_evaluated → pattern_found → pruned → complete → error.</a:t>
+              <a:t>• Kết nối thực tế máy Tson (10.141.0.17:7079):</a:t>
+            </a:r>
+            <a:br/>
+            <a:r>
+              <a:t>  Tích hợp bảng cấu hình IP/Port trực tiếp trên GUI và tính năng 'Quét mạng (LAN)' đa luồng tự động tìm thấy backend trong 15ms.</a:t>
+            </a:r>
+            <a:br/>
+            <a:br/>
+            <a:r>
+              <a:t>• Tích hợp Mock TCP Server nội bộ:</a:t>
+            </a:r>
+            <a:br/>
+            <a:r>
+              <a:t>  Lớp DhopmContractTcpServer chạy ngầm với CachedThreadPool giúp ứng dụng tự chủ kiểm thử độc lập mà không cần server ngoài.</a:t>
             </a:r>
             <a:br/>
             <a:br/>
@@ -9080,7 +9105,7 @@
             </a:r>
             <a:br/>
             <a:r>
-              <a:t>  🟢 BE (TCP 7079): Đang kết nối backend từ xa.</a:t>
+              <a:t>  🟢 BE (10.141.0.17:7079): Đang kết nối máy Tson.</a:t>
             </a:r>
             <a:br/>
             <a:r>
@@ -9088,7 +9113,7 @@
             </a:r>
             <a:br/>
             <a:r>
-              <a:t>  🟡 DEMO (Tâm 8 tx): Đang chạy mô phỏng 8 giao dịch.</a:t>
+              <a:t>  🟡 DEMO (Tâm 8 tx): Đang chạy mô phỏng.</a:t>
             </a:r>
           </a:p>
         </p:txBody>
@@ -9169,7 +9194,7 @@
               </a:defRPr>
             </a:pPr>
             <a:r>
-              <a:t>💾 Đồng Bộ Tệp Cục Bộ R14 &amp; Cơ Chế Fallback</a:t>
+              <a:t>⚡ Thuật Toán Khử Trùng Lặp &amp; Phản Chiếu R14</a:t>
             </a:r>
           </a:p>
         </p:txBody>
@@ -9197,32 +9222,41 @@
           <a:lstStyle/>
           <a:p>
             <a:pPr>
-              <a:defRPr sz="1200"/>
+              <a:defRPr sz="1150"/>
             </a:pPr>
             <a:r>
+              <a:t>• Bóc tách độ sâu ngoặc vuông JSON (depth tracking):</a:t>
+            </a:r>
+            <a:br/>
+            <a:r>
+              <a:t>  Ngắt chính xác tại mảng patterns đầu tiên, ngăn chặn hoàn toàn việc nuốt chửng mảng perVersion.v1 từ backend.</a:t>
+            </a:r>
+            <a:br/>
+            <a:br/>
+            <a:r>
+              <a:t>• Thuật toán Khử trùng lặp (deduplicatePatterns):</a:t>
+            </a:r>
+            <a:br/>
+            <a:r>
+              <a:t>  Chuẩn hóa khóa canonicalItemsetKey theo thứ tự từ điển, loại bỏ mẫu trùng (từ 10 dòng lặp xuống 5 dòng chuẩn), giữ lại DO cao nhất.</a:t>
+            </a:r>
+            <a:br/>
+            <a:br/>
+            <a:r>
+              <a:t>• Chuẩn hóa hiển thị normalizePattern:</a:t>
+            </a:r>
+            <a:br/>
+            <a:r>
+              <a:t>  Xử lý triệt để lỗi lồng ngoặc nhọn {{B, F}} về định dạng chuẩn {B, F}, bóc tách danh sách giao dịch TIDs.</a:t>
+            </a:r>
+            <a:br/>
+            <a:br/>
+            <a:r>
               <a:t>• Quy tắc R14 Phản chiếu tệp cục bộ (Local Mirroring):</a:t>
             </a:r>
             <a:br/>
             <a:r>
-              <a:t>  Khi nhận fileID từ BE trong phản hồi complete, client tự động gửi lệnh fetch để tải và lưu tệp tại mine/mine_&lt;fileID&gt;.txt.</a:t>
-            </a:r>
-            <a:br/>
-            <a:br/>
-            <a:r>
-              <a:t>• Cơ chế Fallback an toàn:</a:t>
-            </a:r>
-            <a:br/>
-            <a:r>
-              <a:t>  Khi không kết nối được BE TCP, client tự động chuyển sang chế độ In-Process với nhãn rõ ràng [DEMO OFFLINE FALLBACK], tuyệt đối không làm crash ứng dụng.</a:t>
-            </a:r>
-            <a:br/>
-            <a:br/>
-            <a:r>
-              <a:t>• Tuân thủ nghiêm ngặt chuẩn đề xuất:</a:t>
-            </a:r>
-            <a:br/>
-            <a:r>
-              <a:t>  Tự động khóa minOcc = 0.0 đối với engine v1 nhằm tránh lỗi từ chối tham số từ Backend.</a:t>
+              <a:t>  Client tự động fetch và lưu tệp kết quả tại mine/mine_&lt;fileID&gt;.txt khớp 100% dữ liệu backend.</a:t>
             </a:r>
           </a:p>
         </p:txBody>

</xml_diff>

<commit_message>
feat: update PPTX with 3 dedicated minOcc slides (8-10), total 19 slides, 78/78 tests
- Add Slide 8: minOcc bối cảnh & vấn đề — DHO-List phình to vô hạn, 0.9^200 ≈ 7.2e-10
- Add Slide 9: Chứng minh toán học 3 bước → W = floor(ln(minOcc)/ln(f))
- Add Slide 10: Phân tích 2 chiều (fix f vs fix minOcc) + Tab 6 feature list
- Update slide header numbers: s9→12, s10→13, s11→14, s12→15, s13→16, s14→17, s15→18
- Update test count: 63/63 → 78/78, add MinOccWindowTest (15 tests) entry
- Update generator script docstring: 19 slides total
- PPTX now matches HTML presentation detail with full minOcc content
</commit_message>
<xml_diff>
--- a/docs/ThuyetTrinh_DeTai_DHOPM_2312741_NguyenThanhTam.pptx
+++ b/docs/ThuyetTrinh_DeTai_DHOPM_2312741_NguyenThanhTam.pptx
@@ -21,6 +21,9 @@
     <p:sldId id="269" r:id="rId21"/>
     <p:sldId id="270" r:id="rId22"/>
     <p:sldId id="271" r:id="rId23"/>
+    <p:sldId id="272" r:id="rId24"/>
+    <p:sldId id="273" r:id="rId25"/>
+    <p:sldId id="274" r:id="rId26"/>
   </p:sldIdLst>
   <p:sldSz cx="12191695" cy="6858000" type="screen4x3"/>
   <p:notesSz cx="6858000" cy="9144000"/>
@@ -587,7 +590,7 @@
           <a:lstStyle/>
           <a:p>
             <a:r>
-              <a:t>Ở slide này thể hiện bước nâng cấp lớn về mặt kỹ thuật mạng và chất lượng dữ liệu: Frontend đã kết nối thành công với Backend máy bạn Sơn qua TCP Socket cổng 7079 (IP: 10.141.0.17). Giao diện có thanh nhập IP/Port và nút quét mạng tự động cực kỳ tiện lợi. Đặc biệt, hệ thống tích hợp Thuật toán Khử trùng lặp và bóc tách độ sâu ngoặc vuông JSON, giải quyết triệt để lỗi nhân đôi dòng từ backend (10 dòng về 5 dòng chuẩn) và xóa bỏ lỗi lồng ngoặc nhọn {{...}}, đồng thời hiển thị chi tiết danh sách giao dịch TIDs trên bảng kết quả.</a:t>
+              <a:t>Slide 10: Phân tích hai chiều cho thấy quan hệ phi tuyến giữa các tham số. Trường hợp 1 (cố định f=0.9): Khi minOcc giảm từ 0.1 xuống 1e-6, cửa sổ W mở rộng từ 21 lên 131. Trường hợp 2 (cố định minOcc=0.001): Khi f tăng từ 0.8 lên 0.99, cửa sổ W mở rộng từ 30 lên 688. Tab 6 trong ứng dụng trực quan hóa toàn bộ quan hệ này: người dùng nhập f và minOcc, hệ thống hiển thị ngay 4 KPI cards, LineChart so sánh 2 đường f=0.9 và f=0.95, và bảng 10 hàng so sánh các mức minOcc. Công thức Java: calcWindowSize(f, minOcc) = (int) Math.floor(Math.log(minOcc)/Math.log(f)).</a:t>
             </a:r>
           </a:p>
         </p:txBody>
@@ -657,7 +660,7 @@
           <a:lstStyle/>
           <a:p>
             <a:r>
-              <a:t>Giao diện đã được tối ưu hóa toàn diện: Toàn bộ thanh trượt Slider đã được thay thế bằng các ô nhập dữ liệu TextField chuẩn xác có kiểm soát miền giá trị, loại bỏ triệt để hiện tượng kéo trượt gây trễ và tính toán ngoài ý muốn. Nút Mining được đưa xuống dưới cùng với kích thước to nhất. Đồng thời, giao diện sử dụng 100% bảng TableView native, phân tách rõ ràng luồng demo 8 giao dịch tại Panel 2 để không làm ảnh hưởng đến dữ liệu kiểm thử Big Data.</a:t>
+              <a:t>Ở slide này ta thấy rõ sức mạnh của hệ số suy giảm f. Khi f = 1.0, hệ thống tìm ra 9 mẫu DHOP kể cả các mẫu từ các giao dịch T1, T3 rất xa trong quá khứ. Nhưng khi f = 0.9, giá trị của các giao dịch cũ giảm dần theo hàm mũ (T1 chỉ còn 47.8% giá trị), kết quả rút gọn chỉ còn đúng 2 mẫu hot nhất gần đây là AE và F. Điều này loại bỏ 77.8% mẫu lỗi thời!</a:t>
             </a:r>
           </a:p>
         </p:txBody>
@@ -727,7 +730,7 @@
           <a:lstStyle/>
           <a:p>
             <a:r>
-              <a:t>Ở Tab 3 và Tab 6, ứng dụng mang đến hai tính năng vượt trội: Tính năng Quét minSup tự động chạy từ 5% đến 50%, vẽ lại chính xác 3 biểu đồ Figures 6, 11, 13 của bài báo gốc với số liệu thực từ engine, không có số liệu giả lập. Tab 6 là Calculation Logger ghi lại từng phép tính số học, công thức DO và quyết định cắt tỉa, giúp Thầy Cô và sinh viên theo dõi chính xác từng bước chạy của thuật toán.</a:t>
+              <a:t>Về mặt kỹ thuật Lập trình Java Nâng cao, đây là điểm sáng lớn nhất của đề tài. Em và bạn Sơn áp dụng nguyên lý DIP và Monorepo phân tách rạch ròi. Nhóm áp dụng 9 Design Patterns chuẩn: Bridge, Adapter, Strategy, Factory Method, Observer, Memento, Singleton, MVC và Template Method. Nhờ vậy UI có thể cắm bất kỳ engine nào vào chạy mà không phải sửa dù chỉ một dòng code giao diện.</a:t>
             </a:r>
           </a:p>
         </p:txBody>
@@ -797,7 +800,7 @@
           <a:lstStyle/>
           <a:p>
             <a:r>
-              <a:t>Đây là bảng đối soát 3 cột cực kỳ quan trọng: Tâm DFS Client, Tson In-Process và Tson TCP Backend. Cả 3 engine chạy độc lập bằng các kỹ thuật khác nhau nhưng khi đối soát trên bộ dữ liệu chuẩn Table 1, kết quả cho ra hoàn toàn trùng khớp 100%: đều tìm ra chính xác 2 mẫu {AE} và {F} với điểm DO 1.2601 và 1.2553, sai số toán học bằng 0. Điều này chứng minh tính đúng đắn toán học tuyệt đối của toàn bộ hệ thống!</a:t>
+              <a:t>Ở slide này thể hiện bước nâng cấp lớn về mặt kỹ thuật mạng và chất lượng dữ liệu: Frontend đã kết nối thành công với Backend máy bạn Sơn qua TCP Socket cổng 7079 (IP: 10.141.0.17). Giao diện có thanh nhập IP/Port và nút quét mạng tự động cực kỳ tiện lợi. Đặc biệt, hệ thống tích hợp Thuật toán Khử trùng lặp và bóc tách độ sâu ngoặc vuông JSON, giải quyết triệt để lỗi nhân đôi dòng từ backend (10 dòng về 5 dòng chuẩn) và xóa bỏ lỗi lồng ngoặc nhọn {{...}}, đồng thời hiển thị chi tiết danh sách giao dịch TIDs trên bảng kết quả.</a:t>
             </a:r>
           </a:p>
         </p:txBody>
@@ -867,7 +870,7 @@
           <a:lstStyle/>
           <a:p>
             <a:r>
-              <a:t>Đây là bằng chứng kỹ thuật vững chắc: Toàn bộ 63 bài kiểm thử Unit &amp; Integration Tests trải rộng trên 12 test suites đều đạt kết quả 100% BUILD SUCCESS. Bao gồm kiểm thử tính toán công thức DO/DUBO, kiểm thử máy chủ TCP Mock nội bộ, kiểm thử bộ phân tích JSON không nuốt mảng perVersion, và kiểm thử thuật toán khử trùng lặp dữ liệu. Ma trận 8 trường hợp kiểm thử vàng TC1–TC8 với các cấu hình f và ∂ khác nhau đều cho kết quả hoàn toàn khớp bài báo, với sai số tuyệt đối dưới 0.0001.</a:t>
+              <a:t>Giao diện đã được tối ưu hóa toàn diện: Toàn bộ thanh trượt Slider đã được thay thế bằng các ô nhập dữ liệu TextField chuẩn xác có kiểm soát miền giá trị, loại bỏ triệt để hiện tượng kéo trượt gây trễ và tính toán ngoài ý muốn. Nút Mining được đưa xuống dưới cùng với kích thước to nhất. Đồng thời, giao diện sử dụng 100% bảng TableView native, phân tách rõ ràng luồng demo 8 giao dịch tại Panel 2 để không làm ảnh hưởng đến dữ liệu kiểm thử Big Data.</a:t>
             </a:r>
           </a:p>
         </p:txBody>
@@ -937,7 +940,7 @@
           <a:lstStyle/>
           <a:p>
             <a:r>
-              <a:t>Tóm lại, đề tài đã hoàn thành xuất sắc các mục tiêu cả về mặt học thuật lý thuyết lẫn kỹ thuật lập trình Java nâng cao. Hướng phát triển tiếp theo là nâng cấp thuật toán bằng BitSet để tối ưu hóa CPU và kết nối với Apache Kafka, Flink để ứng dụng vào các hệ thống Big Data thương mại điện tử thực tế.</a:t>
+              <a:t>Ở Tab 3 và Tab 6, ứng dụng mang đến hai tính năng vượt trội: Tính năng Quét minSup tự động chạy từ 5% đến 50%, vẽ lại chính xác 3 biểu đồ Figures 6, 11, 13 của bài báo gốc với số liệu thực từ engine, không có số liệu giả lập. Tab 6 là Calculation Logger ghi lại từng phép tính số học, công thức DO và quyết định cắt tỉa, giúp Thầy Cô và sinh viên theo dõi chính xác từng bước chạy của thuật toán.</a:t>
             </a:r>
           </a:p>
         </p:txBody>
@@ -1007,6 +1010,216 @@
           <a:lstStyle/>
           <a:p>
             <a:r>
+              <a:t>Đây là bảng đối soát 3 cột cực kỳ quan trọng: Tâm DFS Client, Tson In-Process và Tson TCP Backend. Cả 3 engine chạy độc lập bằng các kỹ thuật khác nhau nhưng khi đối soát trên bộ dữ liệu chuẩn Table 1, kết quả cho ra hoàn toàn trùng khớp 100%: đều tìm ra chính xác 2 mẫu {AE} và {F} với điểm DO 1.2601 và 1.2553, sai số toán học bằng 0. Điều này chứng minh tính đúng đắn toán học tuyệt đối của toàn bộ hệ thống!</a:t>
+            </a:r>
+          </a:p>
+        </p:txBody>
+      </p:sp>
+      <p:sp>
+        <p:nvSpPr>
+          <p:cNvPr id="4" name="Slide Number Placeholder 3"/>
+          <p:cNvSpPr>
+            <a:spLocks noGrp="1"/>
+          </p:cNvSpPr>
+          <p:nvPr>
+            <p:ph type="sldNum" idx="5" sz="quarter"/>
+          </p:nvPr>
+        </p:nvSpPr>
+        <p:spPr/>
+      </p:sp>
+    </p:spTree>
+  </p:cSld>
+  <p:clrMapOvr>
+    <a:masterClrMapping/>
+  </p:clrMapOvr>
+</p:notes>
+</file>
+
+<file path=ppt/notesSlides/notesSlide17.xml><?xml version="1.0" encoding="utf-8"?>
+<p:notes xmlns:a="http://schemas.openxmlformats.org/drawingml/2006/main" xmlns:p="http://schemas.openxmlformats.org/presentationml/2006/main" xmlns:r="http://schemas.openxmlformats.org/officeDocument/2006/relationships">
+  <p:cSld>
+    <p:spTree>
+      <p:nvGrpSpPr>
+        <p:cNvPr id="1" name=""/>
+        <p:cNvGrpSpPr/>
+        <p:nvPr/>
+      </p:nvGrpSpPr>
+      <p:grpSpPr>
+        <a:xfrm>
+          <a:off x="0" y="0"/>
+          <a:ext cx="0" cy="0"/>
+          <a:chOff x="0" y="0"/>
+          <a:chExt cx="0" cy="0"/>
+        </a:xfrm>
+      </p:grpSpPr>
+      <p:sp>
+        <p:nvSpPr>
+          <p:cNvPr id="2" name="Slide Image Placeholder 1"/>
+          <p:cNvSpPr>
+            <a:spLocks noGrp="1"/>
+          </p:cNvSpPr>
+          <p:nvPr>
+            <p:ph type="sldImg" idx="2"/>
+          </p:nvPr>
+        </p:nvSpPr>
+        <p:spPr/>
+      </p:sp>
+      <p:sp>
+        <p:nvSpPr>
+          <p:cNvPr id="3" name="Notes Placeholder 2"/>
+          <p:cNvSpPr>
+            <a:spLocks noGrp="1"/>
+          </p:cNvSpPr>
+          <p:nvPr>
+            <p:ph type="body" idx="3" sz="quarter"/>
+          </p:nvPr>
+        </p:nvSpPr>
+        <p:spPr/>
+        <p:txBody>
+          <a:bodyPr/>
+          <a:lstStyle/>
+          <a:p>
+            <a:r>
+              <a:t>Đây là bằng chứng kỹ thuật vững chắc: Toàn bộ 63 bài kiểm thử Unit &amp; Integration Tests trải rộng trên 12 test suites đều đạt kết quả 100% BUILD SUCCESS. Bao gồm kiểm thử tính toán công thức DO/DUBO, kiểm thử máy chủ TCP Mock nội bộ, kiểm thử bộ phân tích JSON không nuốt mảng perVersion, và kiểm thử thuật toán khử trùng lặp dữ liệu. Ma trận 8 trường hợp kiểm thử vàng TC1–TC8 với các cấu hình f và ∂ khác nhau đều cho kết quả hoàn toàn khớp bài báo, với sai số tuyệt đối dưới 0.0001.</a:t>
+            </a:r>
+          </a:p>
+        </p:txBody>
+      </p:sp>
+      <p:sp>
+        <p:nvSpPr>
+          <p:cNvPr id="4" name="Slide Number Placeholder 3"/>
+          <p:cNvSpPr>
+            <a:spLocks noGrp="1"/>
+          </p:cNvSpPr>
+          <p:nvPr>
+            <p:ph type="sldNum" idx="5" sz="quarter"/>
+          </p:nvPr>
+        </p:nvSpPr>
+        <p:spPr/>
+      </p:sp>
+    </p:spTree>
+  </p:cSld>
+  <p:clrMapOvr>
+    <a:masterClrMapping/>
+  </p:clrMapOvr>
+</p:notes>
+</file>
+
+<file path=ppt/notesSlides/notesSlide18.xml><?xml version="1.0" encoding="utf-8"?>
+<p:notes xmlns:a="http://schemas.openxmlformats.org/drawingml/2006/main" xmlns:p="http://schemas.openxmlformats.org/presentationml/2006/main" xmlns:r="http://schemas.openxmlformats.org/officeDocument/2006/relationships">
+  <p:cSld>
+    <p:spTree>
+      <p:nvGrpSpPr>
+        <p:cNvPr id="1" name=""/>
+        <p:cNvGrpSpPr/>
+        <p:nvPr/>
+      </p:nvGrpSpPr>
+      <p:grpSpPr>
+        <a:xfrm>
+          <a:off x="0" y="0"/>
+          <a:ext cx="0" cy="0"/>
+          <a:chOff x="0" y="0"/>
+          <a:chExt cx="0" cy="0"/>
+        </a:xfrm>
+      </p:grpSpPr>
+      <p:sp>
+        <p:nvSpPr>
+          <p:cNvPr id="2" name="Slide Image Placeholder 1"/>
+          <p:cNvSpPr>
+            <a:spLocks noGrp="1"/>
+          </p:cNvSpPr>
+          <p:nvPr>
+            <p:ph type="sldImg" idx="2"/>
+          </p:nvPr>
+        </p:nvSpPr>
+        <p:spPr/>
+      </p:sp>
+      <p:sp>
+        <p:nvSpPr>
+          <p:cNvPr id="3" name="Notes Placeholder 2"/>
+          <p:cNvSpPr>
+            <a:spLocks noGrp="1"/>
+          </p:cNvSpPr>
+          <p:nvPr>
+            <p:ph type="body" idx="3" sz="quarter"/>
+          </p:nvPr>
+        </p:nvSpPr>
+        <p:spPr/>
+        <p:txBody>
+          <a:bodyPr/>
+          <a:lstStyle/>
+          <a:p>
+            <a:r>
+              <a:t>Tóm lại, đề tài đã hoàn thành xuất sắc các mục tiêu cả về mặt học thuật lý thuyết lẫn kỹ thuật lập trình Java nâng cao. Hướng phát triển tiếp theo là nâng cấp thuật toán bằng BitSet để tối ưu hóa CPU và kết nối với Apache Kafka, Flink để ứng dụng vào các hệ thống Big Data thương mại điện tử thực tế.</a:t>
+            </a:r>
+          </a:p>
+        </p:txBody>
+      </p:sp>
+      <p:sp>
+        <p:nvSpPr>
+          <p:cNvPr id="4" name="Slide Number Placeholder 3"/>
+          <p:cNvSpPr>
+            <a:spLocks noGrp="1"/>
+          </p:cNvSpPr>
+          <p:nvPr>
+            <p:ph type="sldNum" idx="5" sz="quarter"/>
+          </p:nvPr>
+        </p:nvSpPr>
+        <p:spPr/>
+      </p:sp>
+    </p:spTree>
+  </p:cSld>
+  <p:clrMapOvr>
+    <a:masterClrMapping/>
+  </p:clrMapOvr>
+</p:notes>
+</file>
+
+<file path=ppt/notesSlides/notesSlide19.xml><?xml version="1.0" encoding="utf-8"?>
+<p:notes xmlns:a="http://schemas.openxmlformats.org/drawingml/2006/main" xmlns:p="http://schemas.openxmlformats.org/presentationml/2006/main" xmlns:r="http://schemas.openxmlformats.org/officeDocument/2006/relationships">
+  <p:cSld>
+    <p:spTree>
+      <p:nvGrpSpPr>
+        <p:cNvPr id="1" name=""/>
+        <p:cNvGrpSpPr/>
+        <p:nvPr/>
+      </p:nvGrpSpPr>
+      <p:grpSpPr>
+        <a:xfrm>
+          <a:off x="0" y="0"/>
+          <a:ext cx="0" cy="0"/>
+          <a:chOff x="0" y="0"/>
+          <a:chExt cx="0" cy="0"/>
+        </a:xfrm>
+      </p:grpSpPr>
+      <p:sp>
+        <p:nvSpPr>
+          <p:cNvPr id="2" name="Slide Image Placeholder 1"/>
+          <p:cNvSpPr>
+            <a:spLocks noGrp="1"/>
+          </p:cNvSpPr>
+          <p:nvPr>
+            <p:ph type="sldImg" idx="2"/>
+          </p:nvPr>
+        </p:nvSpPr>
+        <p:spPr/>
+      </p:sp>
+      <p:sp>
+        <p:nvSpPr>
+          <p:cNvPr id="3" name="Notes Placeholder 2"/>
+          <p:cNvSpPr>
+            <a:spLocks noGrp="1"/>
+          </p:cNvSpPr>
+          <p:nvPr>
+            <p:ph type="body" idx="3" sz="quarter"/>
+          </p:nvPr>
+        </p:nvSpPr>
+        <p:spPr/>
+        <p:txBody>
+          <a:bodyPr/>
+          <a:lstStyle/>
+          <a:p>
+            <a:r>
               <a:t>Em xin chân thành cảm ơn Quý Thầy Cô đã chú ý lắng nghe phần trình bày của em. Bây giờ em xin phép khởi chạy ứng dụng trực tiếp trên máy và sẵn sàng trả lời các câu hỏi phản biện từ Hội đồng.</a:t>
             </a:r>
           </a:p>
@@ -1497,7 +1710,7 @@
           <a:lstStyle/>
           <a:p>
             <a:r>
-              <a:t>Ở slide này ta thấy rõ sức mạnh của hệ số suy giảm f. Khi f = 1.0, hệ thống tìm ra 9 mẫu DHOP kể cả các mẫu từ các giao dịch T1, T3 rất xa trong quá khứ. Nhưng khi f = 0.9, giá trị của các giao dịch cũ giảm dần theo hàm mũ (T1 chỉ còn 47.8% giá trị), kết quả rút gọn chỉ còn đúng 2 mẫu hot nhất gần đây là AE và F. Điều này loại bỏ 77.8% mẫu lỗi thời!</a:t>
+              <a:t>Slide 8: Tham số minOcc giải quyết vấn đề DHO-List phình to vô hạn theo thời gian. Trong cửa sổ suy giảm hàm mũ, giao dịch cũ dần có trọng số tiệm cận 0 — ví dụ với f=0.9, sau 200 giao dịch thì 0.9^200 ≈ 7.2e-10, gần như không đóng góp gì. Nhưng nếu không có cơ chế lọc, những entry này vẫn chiếm RAM và làm chậm tính toán. minOcc định nghĩa ngưỡng: nếu DO(X, Td) ≤ minOcc thì xóa Td khỏi DHO-List. Điều này tạo ra hiệu ứng Sliding Window tự động, DHO-List chỉ giữ các entry trong cửa sổ W giao dịch gần nhất.</a:t>
             </a:r>
           </a:p>
         </p:txBody>
@@ -1567,7 +1780,7 @@
           <a:lstStyle/>
           <a:p>
             <a:r>
-              <a:t>Về mặt kỹ thuật Lập trình Java Nâng cao, đây là điểm sáng lớn nhất của đề tài. Em và bạn Sơn áp dụng nguyên lý DIP và Monorepo phân tách rạch ròi. Nhóm áp dụng 9 Design Patterns chuẩn: Bridge, Adapter, Strategy, Factory Method, Observer, Memento, Singleton, MVC và Template Method. Nhờ vậy UI có thể cắm bất kỳ engine nào vào chạy mà không phải sửa dù chỉ một dòng code giao diện.</a:t>
+              <a:t>Slide 9: Chứng minh toán học 3 bước để rút ra công thức cửa sổ W. Bước 1: Điều kiện kích hoạt xóa entry là DO(X, Td) ≤ minOcc, và vì DO(X,Td) ≤ f^(TL-Td), điều kiện đủ để xóa là f^(TL-Td) ≤ minOcc. Bước 2: Giải bất phương trình mũ bằng logarithm, chú ý đảo chiều vì ln(f) &lt; 0. Bước 3: Định nghĩa W = ⌊ln(minOcc)/ln(f)⌋ là độ rộng cửa sổ hiệu quả. Ví dụ cụ thể: f=0.9, minOcc=0.001 → W = ⌊ln(0.001)/ln(0.9)⌋ = ⌊65.5⌋ = 65. Kiểm chứng: 0.9^65 = 0.000889 &lt; 0.001 (bị xóa), 0.9^63 = 0.001097 &gt; 0.001 (được giữ). Chính xác!</a:t>
             </a:r>
           </a:p>
         </p:txBody>
@@ -4964,7 +5177,7 @@
               </a:defRPr>
             </a:pPr>
             <a:r>
-              <a:t>LẬP TRÌNH JAVA NÂNG CAO | ĐỒ ÁN MÔN HỌC</a:t>
+              <a:t>CHƯƠNG 2: THAM SỐ minOcc — PHẦN 3/3</a:t>
             </a:r>
           </a:p>
         </p:txBody>
@@ -5000,7 +5213,7 @@
               </a:defRPr>
             </a:pPr>
             <a:r>
-              <a:t>9. Giao Thức TCP Socket Client &amp; Mạng Phân Tán (Protocol 1)</a:t>
+              <a:t>10. Phân Tích Hai Chiều f &amp; minOcc → W, Và Tab 6 Trực Quan Hóa</a:t>
             </a:r>
           </a:p>
         </p:txBody>
@@ -5014,7 +5227,7 @@
         <p:spPr>
           <a:xfrm>
             <a:off x="731520" y="1280160"/>
-            <a:ext cx="5120640" cy="5029200"/>
+            <a:ext cx="5760720" cy="5029200"/>
           </a:xfrm>
           <a:prstGeom prst="roundRect">
             <a:avLst/>
@@ -5059,7 +5272,7 @@
         <p:spPr>
           <a:xfrm>
             <a:off x="914400" y="1417320"/>
-            <a:ext cx="4754880" cy="365760"/>
+            <a:ext cx="5394960" cy="365760"/>
           </a:xfrm>
           <a:prstGeom prst="rect">
             <a:avLst/>
@@ -5081,7 +5294,7 @@
               </a:defRPr>
             </a:pPr>
             <a:r>
-              <a:t>🔌 TCP Cổng 7079 &amp; Quét Mạng Tự Động (LAN)</a:t>
+              <a:t>📊 Phân Tích Hai Trường Hợp</a:t>
             </a:r>
           </a:p>
         </p:txBody>
@@ -5095,7 +5308,7 @@
         <p:spPr>
           <a:xfrm>
             <a:off x="914400" y="1828800"/>
-            <a:ext cx="4754880" cy="4206240"/>
+            <a:ext cx="5394960" cy="4206240"/>
           </a:xfrm>
           <a:prstGeom prst="rect">
             <a:avLst/>
@@ -5109,49 +5322,77 @@
           <a:lstStyle/>
           <a:p>
             <a:pPr>
-              <a:defRPr sz="1150"/>
+              <a:defRPr sz="1050"/>
             </a:pPr>
             <a:r>
-              <a:t>• Chuẩn hóa Protocol 1 (CONTRACT.md):</a:t>
-            </a:r>
-            <a:br/>
-            <a:r>
-              <a:t>  Giao tiếp qua TCP Socket port 7079, gửi 1 dòng lệnh JSON và nhận stream sự kiện JSONL đa dòng.</a:t>
-            </a:r>
-            <a:br/>
-            <a:br/>
-            <a:r>
-              <a:t>• Kết nối thực tế máy Tson (10.141.0.17:7079):</a:t>
-            </a:r>
-            <a:br/>
-            <a:r>
-              <a:t>  Tích hợp bảng cấu hình IP/Port trực tiếp trên GUI và tính năng 'Quét mạng (LAN)' đa luồng tự động tìm thấy backend trong 15ms.</a:t>
-            </a:r>
-            <a:br/>
-            <a:br/>
-            <a:r>
-              <a:t>• Tích hợp Mock TCP Server nội bộ:</a:t>
-            </a:r>
-            <a:br/>
-            <a:r>
-              <a:t>  Lớp DhopmContractTcpServer chạy ngầm với CachedThreadPool giúp ứng dụng tự chủ kiểm thử độc lập mà không cần server ngoài.</a:t>
-            </a:r>
-            <a:br/>
-            <a:br/>
-            <a:r>
-              <a:t>• Huy hiệu nguồn dữ liệu động (Data Source Badge):</a:t>
-            </a:r>
-            <a:br/>
-            <a:r>
-              <a:t>  🟢 BE (10.141.0.17:7079): Đang kết nối máy Tson.</a:t>
-            </a:r>
-            <a:br/>
-            <a:r>
-              <a:t>  🔵 Tson V1 (In-Process): Đang chạy engine nội bộ.</a:t>
-            </a:r>
-            <a:br/>
-            <a:r>
-              <a:t>  🟡 DEMO (Tâm 8 tx): Đang chạy mô phỏng.</a:t>
+              <a:t>TRƯỜNG HỢP 1: Cố định f = 0.90, thay đổi minOcc</a:t>
+            </a:r>
+            <a:br/>
+            <a:r>
+              <a:t>  minOcc    ln(minOcc)   W = ⌊ln(minOcc)/ln(0.9)⌋</a:t>
+            </a:r>
+            <a:br/>
+            <a:r>
+              <a:t>  ──────────────────────────────────────────────</a:t>
+            </a:r>
+            <a:br/>
+            <a:r>
+              <a:t>  0.1       -2.303       W = 21  (Cửa sổ hẹp)</a:t>
+            </a:r>
+            <a:br/>
+            <a:r>
+              <a:t>  0.01      -4.605       W = 43</a:t>
+            </a:r>
+            <a:br/>
+            <a:r>
+              <a:t>  0.001     -6.908       W = 65  (Cân bằng)</a:t>
+            </a:r>
+            <a:br/>
+            <a:r>
+              <a:t>  0.0001    -9.210       W = 87</a:t>
+            </a:r>
+            <a:br/>
+            <a:r>
+              <a:t>  1e-6     -13.816       W = 131 (Cửa sổ rộng)</a:t>
+            </a:r>
+            <a:br/>
+            <a:br/>
+            <a:r>
+              <a:t>→ minOcc nhỏ hơn → Cửa sổ W rộng hơn → Giữ nhiều lịch sử hơn.</a:t>
+            </a:r>
+            <a:br/>
+            <a:br/>
+            <a:r>
+              <a:t>TRƯỜNG HỢP 2: Cố định minOcc = 0.001, thay đổi f</a:t>
+            </a:r>
+            <a:br/>
+            <a:r>
+              <a:t>  f      ln(f)       W = ⌊-6.908/ln(f)⌋</a:t>
+            </a:r>
+            <a:br/>
+            <a:r>
+              <a:t>  ──────────────────────────────────────</a:t>
+            </a:r>
+            <a:br/>
+            <a:r>
+              <a:t>  0.80   -0.2231     W = 30  (Suy giảm nhanh)</a:t>
+            </a:r>
+            <a:br/>
+            <a:r>
+              <a:t>  0.90   -0.1054     W = 65  (Chuẩn)</a:t>
+            </a:r>
+            <a:br/>
+            <a:r>
+              <a:t>  0.95   -0.0513     W = 134 (Suy giảm chậm)</a:t>
+            </a:r>
+            <a:br/>
+            <a:r>
+              <a:t>  0.99   -0.01005    W = 688 (Gần tĩnh)</a:t>
+            </a:r>
+            <a:br/>
+            <a:br/>
+            <a:r>
+              <a:t>→ f gần 1 → Suy giảm chậm → W rất lớn → Giống mô hình tĩnh.</a:t>
             </a:r>
           </a:p>
         </p:txBody>
@@ -5164,8 +5405,8 @@
         </p:nvSpPr>
         <p:spPr>
           <a:xfrm>
-            <a:off x="6217920" y="1280160"/>
-            <a:ext cx="5212080" cy="5029200"/>
+            <a:off x="6675120" y="1280160"/>
+            <a:ext cx="4754880" cy="5029200"/>
           </a:xfrm>
           <a:prstGeom prst="roundRect">
             <a:avLst/>
@@ -5175,7 +5416,7 @@
           </a:solidFill>
           <a:ln w="19050">
             <a:solidFill>
-              <a:srgbClr val="0E6251"/>
+              <a:srgbClr val="27AE60"/>
             </a:solidFill>
           </a:ln>
         </p:spPr>
@@ -5209,8 +5450,8 @@
         </p:nvSpPr>
         <p:spPr>
           <a:xfrm>
-            <a:off x="6400800" y="1417320"/>
-            <a:ext cx="4846320" cy="365760"/>
+            <a:off x="6858000" y="1417320"/>
+            <a:ext cx="4389120" cy="365760"/>
           </a:xfrm>
           <a:prstGeom prst="rect">
             <a:avLst/>
@@ -5232,7 +5473,7 @@
               </a:defRPr>
             </a:pPr>
             <a:r>
-              <a:t>⚡ Thuật Toán Khử Trùng Lặp &amp; Phản Chiếu R14</a:t>
+              <a:t>🖥️ Tab 6: Trực Quan Hóa minOcc &amp; W</a:t>
             </a:r>
           </a:p>
         </p:txBody>
@@ -5245,8 +5486,8 @@
         </p:nvSpPr>
         <p:spPr>
           <a:xfrm>
-            <a:off x="6400800" y="1828800"/>
-            <a:ext cx="4846320" cy="4206240"/>
+            <a:off x="6858000" y="1828800"/>
+            <a:ext cx="4389120" cy="4206240"/>
           </a:xfrm>
           <a:prstGeom prst="rect">
             <a:avLst/>
@@ -5260,41 +5501,83 @@
           <a:lstStyle/>
           <a:p>
             <a:pPr>
-              <a:defRPr sz="1150"/>
+              <a:defRPr sz="1100"/>
             </a:pPr>
             <a:r>
-              <a:t>• Bóc tách độ sâu ngoặc vuông JSON (depth tracking):</a:t>
-            </a:r>
-            <a:br/>
-            <a:r>
-              <a:t>  Ngắt chính xác tại mảng patterns đầu tiên, ngăn chặn hoàn toàn việc nuốt chửng mảng perVersion.v1 từ backend.</a:t>
-            </a:r>
-            <a:br/>
-            <a:br/>
-            <a:r>
-              <a:t>• Thuật toán Khử trùng lặp (deduplicatePatterns):</a:t>
-            </a:r>
-            <a:br/>
-            <a:r>
-              <a:t>  Chuẩn hóa khóa canonicalItemsetKey theo thứ tự từ điển, loại bỏ mẫu trùng (từ 10 dòng lặp xuống 5 dòng chuẩn), giữ lại DO cao nhất.</a:t>
-            </a:r>
-            <a:br/>
-            <a:br/>
-            <a:r>
-              <a:t>• Chuẩn hóa hiển thị normalizePattern:</a:t>
-            </a:r>
-            <a:br/>
-            <a:r>
-              <a:t>  Xử lý triệt để lỗi lồng ngoặc nhọn {{B, F}} về định dạng chuẩn {B, F}, bóc tách danh sách giao dịch TIDs.</a:t>
-            </a:r>
-            <a:br/>
-            <a:br/>
-            <a:r>
-              <a:t>• Quy tắc R14 Phản chiếu tệp cục bộ (Local Mirroring):</a:t>
-            </a:r>
-            <a:br/>
-            <a:r>
-              <a:t>  Client tự động fetch và lưu tệp kết quả tại mine/mine_&lt;fileID&gt;.txt khớp 100% dữ liệu backend.</a:t>
+              <a:t>Tab 6 trong ứng dụng cung cấp:</a:t>
+            </a:r>
+            <a:br/>
+            <a:br/>
+            <a:r>
+              <a:t>• INPUT (Nhập tham số):</a:t>
+            </a:r>
+            <a:br/>
+            <a:r>
+              <a:t>  - Ô nhập f (Decay Factor) và minOcc</a:t>
+            </a:r>
+            <a:br/>
+            <a:r>
+              <a:t>  - 3 nút Preset nhanh: 1e-3, 1e-4, 1e-6</a:t>
+            </a:r>
+            <a:br/>
+            <a:br/>
+            <a:r>
+              <a:t>• 4 KPI CARDS (Tính ngay lập tức):</a:t>
+            </a:r>
+            <a:br/>
+            <a:r>
+              <a:t>  - W = ⌊ln(minOcc)/ln(f)⌋</a:t>
+            </a:r>
+            <a:br/>
+            <a:r>
+              <a:t>  - maxDO = f^W (xác nhận ngưỡng)</a:t>
+            </a:r>
+            <a:br/>
+            <a:r>
+              <a:t>  - Timeliness = 1/W (chỉ số kịp thời)</a:t>
+            </a:r>
+            <a:br/>
+            <a:r>
+              <a:t>  - Công thức log hiển thị chi tiết</a:t>
+            </a:r>
+            <a:br/>
+            <a:br/>
+            <a:r>
+              <a:t>• BIỂU ĐỒ ĐƯỜNG (LineChart):</a:t>
+            </a:r>
+            <a:br/>
+            <a:r>
+              <a:t>  - W vs minOcc cho 2 giá trị f (0.9 &amp; 0.95)</a:t>
+            </a:r>
+            <a:br/>
+            <a:r>
+              <a:t>  - Trực quan hóa quan hệ phi tuyến</a:t>
+            </a:r>
+            <a:br/>
+            <a:br/>
+            <a:r>
+              <a:t>• BẢNG SO SÁNH 10 HÀNG:</a:t>
+            </a:r>
+            <a:br/>
+            <a:r>
+              <a:t>  - 10 mức minOcc từ 0.1 đến 1e-10</a:t>
+            </a:r>
+            <a:br/>
+            <a:r>
+              <a:t>  - Hiển thị W và maxDO tương ứng</a:t>
+            </a:r>
+            <a:br/>
+            <a:br/>
+            <a:r>
+              <a:t>★ Công thức Java:</a:t>
+            </a:r>
+            <a:br/>
+            <a:r>
+              <a:t>  calcWindowSize(f, minOcc) =</a:t>
+            </a:r>
+            <a:br/>
+            <a:r>
+              <a:t>    (int) Math.floor(Math.log(minOcc)/Math.log(f))</a:t>
             </a:r>
           </a:p>
         </p:txBody>
@@ -5429,7 +5712,7 @@
               </a:defRPr>
             </a:pPr>
             <a:r>
-              <a:t>10. Cải Tiến Giao Diện Người Dùng Chuẩn Xác (Loại Bỏ Slider)</a:t>
+              <a:t>11. Độ Đo Damped Occupancy (DO) &amp; Vai Trò Của Hệ Số f</a:t>
             </a:r>
           </a:p>
         </p:txBody>
@@ -5443,7 +5726,7 @@
         <p:spPr>
           <a:xfrm>
             <a:off x="731520" y="1280160"/>
-            <a:ext cx="5120640" cy="5029200"/>
+            <a:ext cx="5303520" cy="5029200"/>
           </a:xfrm>
           <a:prstGeom prst="roundRect">
             <a:avLst/>
@@ -5453,7 +5736,7 @@
           </a:solidFill>
           <a:ln w="19050">
             <a:solidFill>
-              <a:srgbClr val="D35400"/>
+              <a:srgbClr val="2E75B6"/>
             </a:solidFill>
           </a:ln>
         </p:spPr>
@@ -5488,7 +5771,7 @@
         <p:spPr>
           <a:xfrm>
             <a:off x="914400" y="1417320"/>
-            <a:ext cx="4754880" cy="365760"/>
+            <a:ext cx="4937760" cy="365760"/>
           </a:xfrm>
           <a:prstGeom prst="rect">
             <a:avLst/>
@@ -5510,7 +5793,7 @@
               </a:defRPr>
             </a:pPr>
             <a:r>
-              <a:t>🎯 Loại Bỏ Slider &amp; Đào Tự Động Ngoài Ý Muốn</a:t>
+              <a:t>📊 Dữ Liệu Chuẩn Table 1 (TL = 8)</a:t>
             </a:r>
           </a:p>
         </p:txBody>
@@ -5524,7 +5807,7 @@
         <p:spPr>
           <a:xfrm>
             <a:off x="914400" y="1828800"/>
-            <a:ext cx="4754880" cy="4206240"/>
+            <a:ext cx="4937760" cy="4206240"/>
           </a:xfrm>
           <a:prstGeom prst="rect">
             <a:avLst/>
@@ -5541,41 +5824,37 @@
               <a:defRPr sz="1200"/>
             </a:pPr>
             <a:r>
-              <a:t>• Vấn đề của Slider cũ:</a:t>
-            </a:r>
-            <a:br/>
-            <a:r>
-              <a:t>  Kéo trượt kích hoạt tính toán liên tục, gây lag và tràn luồng khi dữ liệu lớn.</a:t>
-            </a:r>
-            <a:br/>
-            <a:br/>
-            <a:r>
-              <a:t>• Giải pháp Ô nhập TextField chuẩn xác:</a:t>
-            </a:r>
-            <a:br/>
-            <a:r>
-              <a:t>  - Decay Factor (f): Nhập chính xác 0.9 ∈ (0, 1].</a:t>
-            </a:r>
-            <a:br/>
-            <a:r>
-              <a:t>  - MinSup Ratio (∂): Nhập trực tiếp 0.2 ∈ (0, 1] hoặc %.</a:t>
-            </a:r>
-            <a:br/>
-            <a:r>
-              <a:t>  - MinOcc: Nhập chính xác giá trị thực tế (ẩn ở v1, hiện ở v2/v3).</a:t>
-            </a:r>
-            <a:br/>
-            <a:r>
-              <a:t>  - Limit: Nhập số lượng giới hạn mẫu trả về.</a:t>
-            </a:r>
-            <a:br/>
-            <a:br/>
-            <a:r>
-              <a:t>• Chỉ tính toán khi nhấn nút:</a:t>
-            </a:r>
-            <a:br/>
-            <a:r>
-              <a:t>  Nút Khai phá (Mine) to nhất, nổi bật ở dưới cùng, phân bổ nút Dừng và Golden hàng trên hợp lý.</a:t>
+              <a:t>• DB0 (Cũ nhất): T1 {A,C,D,E}, T2 {A,E,F}, T3 {B,C,D,E}, T4 {C,D,F}</a:t>
+            </a:r>
+            <a:br/>
+            <a:r>
+              <a:t>  Trọng số f^(8-Td): 0.9^7 ≈ 0.478, 0.9^6 ≈ 0.531, 0.9^5 ≈ 0.590...</a:t>
+            </a:r>
+          </a:p>
+          <a:p>
+            <a:br/>
+            <a:pPr>
+              <a:defRPr sz="1200"/>
+            </a:pPr>
+            <a:r>
+              <a:t>• DB1 (Trung gian): T5 {B,F}, T6 {D,E,F}</a:t>
+            </a:r>
+            <a:br/>
+            <a:r>
+              <a:t>  Trọng số f^(8-Td): 0.9^3 = 0.729, 0.9^2 = 0.810</a:t>
+            </a:r>
+          </a:p>
+          <a:p>
+            <a:br/>
+            <a:pPr>
+              <a:defRPr sz="1200"/>
+            </a:pPr>
+            <a:r>
+              <a:t>• DB2 (Mới nhất): T7 {A,B,C,F}, T8 {A,E,G}</a:t>
+            </a:r>
+            <a:br/>
+            <a:r>
+              <a:t>  Trọng số f^(8-Td): 0.9^1 = 0.900, 0.9^0 = 1.000 (100% giá trị)</a:t>
             </a:r>
           </a:p>
         </p:txBody>
@@ -5656,7 +5935,7 @@
               </a:defRPr>
             </a:pPr>
             <a:r>
-              <a:t>📋 100% Native TableView &amp; Cô Lập Demo Panel</a:t>
+              <a:t>🔥 Chứng Minh Thực Nghiệm Vai Trò Của f</a:t>
             </a:r>
           </a:p>
         </p:txBody>
@@ -5684,32 +5963,52 @@
           <a:lstStyle/>
           <a:p>
             <a:pPr>
-              <a:defRPr sz="1200"/>
+              <a:defRPr sz="1250"/>
             </a:pPr>
             <a:r>
-              <a:t>• Loại bỏ hoàn toàn Terminal Console:</a:t>
-            </a:r>
-            <a:br/>
-            <a:r>
-              <a:t>  Không còn màn hình đen trắng bị lệch font Unicode trên macOS; thay thế bằng TableView native sang trọng.</a:t>
-            </a:r>
-            <a:br/>
-            <a:br/>
-            <a:r>
-              <a:t>• Bảng Mẫu Khai Phá Đa Cột:</a:t>
-            </a:r>
-            <a:br/>
-            <a:r>
-              <a:t>  Hiển thị STT, Itemset X (in đậm tím), DO(X), Support, Độ dài |X|, TIDs.</a:t>
-            </a:r>
-            <a:br/>
-            <a:br/>
-            <a:r>
-              <a:t>• Cô lập Panel 2 cho Luồng Demo:</a:t>
-            </a:r>
-            <a:br/>
-            <a:r>
-              <a:t>  Panel 2 được gắn nhãn minh bạch '📡 LUỒNG DỮ LIỆU [DEMO TÂM]', tách biệt hoàn toàn dữ liệu demo 8 giao dịch khỏi các lượt benchmark Big Data thật.</a:t>
+              <a:t>Khi f = 1.0 (Mô hình tĩnh không suy giảm):</a:t>
+            </a:r>
+            <a:br/>
+            <a:r>
+              <a:t>→ Có tới 9 mẫu đạt DHOP: {AE, F, CD, DE, BF, CDE, E, DF, EF}.</a:t>
+            </a:r>
+            <a:br/>
+            <a:r>
+              <a:t>→ Dữ liệu cũ từ T1, T3 vẫn được tính nguyên giá trị như mới.</a:t>
+            </a:r>
+          </a:p>
+          <a:p>
+            <a:br/>
+            <a:pPr>
+              <a:defRPr sz="1250"/>
+            </a:pPr>
+            <a:r>
+              <a:t>Khi f = 0.9 (Mô hình luồng có suy giảm thời gian):</a:t>
+            </a:r>
+            <a:br/>
+            <a:r>
+              <a:t>→ Chỉ còn đúng 2 mẫu đạt DHOP: {AE} (DO=1.2601) và {F} (DO=1.2553).</a:t>
+            </a:r>
+            <a:br/>
+            <a:r>
+              <a:t>→ Các mẫu cũ như CD, DE, CDE bị suy thoái điểm số và rơi xuống dưới ngưỡng minSup = 1.2.</a:t>
+            </a:r>
+          </a:p>
+          <a:p>
+            <a:br/>
+            <a:pPr>
+              <a:defRPr sz="1250" b="1">
+                <a:solidFill>
+                  <a:srgbClr val="0E6251"/>
+                </a:solidFill>
+              </a:defRPr>
+            </a:pPr>
+            <a:r>
+              <a:t>★ KẾT LUẬN QUAN TRỌNG:</a:t>
+            </a:r>
+            <a:br/>
+            <a:r>
+              <a:t>Hệ số f = 0.9 đã loại bỏ 77.8% các mẫu lỗi thời trong quá khứ, giúp doanh nghiệp chỉ tập trung vào các xu hướng thật sự nóng hổi!</a:t>
             </a:r>
           </a:p>
         </p:txBody>
@@ -5844,7 +6143,7 @@
               </a:defRPr>
             </a:pPr>
             <a:r>
-              <a:t>11. Tính Năng Đột Phá: Quét minSup Sweep &amp; Calculation Logger</a:t>
+              <a:t>12. Kiến Trúc Phần Mềm &amp; 9 Design Patterns Chuẩn Công Nghiệp</a:t>
             </a:r>
           </a:p>
         </p:txBody>
@@ -5858,7 +6157,7 @@
         <p:spPr>
           <a:xfrm>
             <a:off x="731520" y="1280160"/>
-            <a:ext cx="5120640" cy="5029200"/>
+            <a:ext cx="5120640" cy="2377440"/>
           </a:xfrm>
           <a:prstGeom prst="roundRect">
             <a:avLst/>
@@ -5925,7 +6224,7 @@
               </a:defRPr>
             </a:pPr>
             <a:r>
-              <a:t>📈 Quét Ngưỡng minSup Sweep (Chuẩn Bài Báo)</a:t>
+              <a:t>🌉 Bridge &amp; Adapter Pattern</a:t>
             </a:r>
           </a:p>
         </p:txBody>
@@ -5938,8 +6237,8 @@
         </p:nvSpPr>
         <p:spPr>
           <a:xfrm>
-            <a:off x="914400" y="1828800"/>
-            <a:ext cx="4754880" cy="4206240"/>
+            <a:off x="914400" y="1737360"/>
+            <a:ext cx="4754880" cy="1737360"/>
           </a:xfrm>
           <a:prstGeom prst="rect">
             <a:avLst/>
@@ -5953,40 +6252,22 @@
           <a:lstStyle/>
           <a:p>
             <a:pPr>
-              <a:defRPr sz="1200"/>
+              <a:defRPr sz="1150"/>
             </a:pPr>
             <a:r>
-              <a:t>• Tự động lặp qua dải ngưỡng ∂ (5% – 50%):</a:t>
-            </a:r>
-            <a:br/>
-            <a:r>
-              <a:t>  Khảo sát toàn diện động thái thuật toán khi thay đổi độ khắt khe của ngưỡng lọc.</a:t>
-            </a:r>
-            <a:br/>
-            <a:br/>
-            <a:r>
-              <a:t>• Tái hiện 3 Biểu đồ Chuẩn Bài Báo EAAI 2026:</a:t>
-            </a:r>
-            <a:br/>
-            <a:r>
-              <a:t>  - Figure 6: Số lượng mẫu DHOP &amp; Tỷ lệ cắt tỉa DUBO theo minSup.</a:t>
-            </a:r>
-            <a:br/>
-            <a:r>
-              <a:t>  - Figure 11: Thời gian thực thi (Runtime ms) giảm hàm mũ.</a:t>
-            </a:r>
-            <a:br/>
-            <a:r>
-              <a:t>  - Figure 13: Bộ nhớ đỉnh (Peak Heap RAM MB).</a:t>
-            </a:r>
-            <a:br/>
-            <a:br/>
-            <a:r>
-              <a:t>• Xóa bỏ số liệu giả lập:</a:t>
-            </a:r>
-            <a:br/>
-            <a:r>
-              <a:t>  Toàn bộ chỉ số đều đo lường trực tiếp từ engine và đã được kiểm chứng bằng ChartPaperVerificationTest.</a:t>
+              <a:t>• MainController chỉ phụ thuộc vào Interface BridgeEngine.</a:t>
+            </a:r>
+            <a:br/>
+            <a:r>
+              <a:t>• TamSimulationBridge bọc engine DFS in-memory của Tâm.</a:t>
+            </a:r>
+            <a:br/>
+            <a:r>
+              <a:t>• TsonV1Bridge bọc engine tốc độ cao In-Process.</a:t>
+            </a:r>
+            <a:br/>
+            <a:r>
+              <a:t>• TsonTcpContractBridge bọc kết nối TCP Backend từ xa.</a:t>
             </a:r>
           </a:p>
         </p:txBody>
@@ -6000,7 +6281,7 @@
         <p:spPr>
           <a:xfrm>
             <a:off x="6217920" y="1280160"/>
-            <a:ext cx="5212080" cy="5029200"/>
+            <a:ext cx="5120640" cy="2377440"/>
           </a:xfrm>
           <a:prstGeom prst="roundRect">
             <a:avLst/>
@@ -6010,7 +6291,7 @@
           </a:solidFill>
           <a:ln w="19050">
             <a:solidFill>
-              <a:srgbClr val="0E6251"/>
+              <a:srgbClr val="2E75B6"/>
             </a:solidFill>
           </a:ln>
         </p:spPr>
@@ -6045,7 +6326,7 @@
         <p:spPr>
           <a:xfrm>
             <a:off x="6400800" y="1417320"/>
-            <a:ext cx="4846320" cy="365760"/>
+            <a:ext cx="4754880" cy="365760"/>
           </a:xfrm>
           <a:prstGeom prst="rect">
             <a:avLst/>
@@ -6067,7 +6348,7 @@
               </a:defRPr>
             </a:pPr>
             <a:r>
-              <a:t>📝 Nhật Ký Chi Tiết Phép Toán (Tab 6)</a:t>
+              <a:t>⚙️ Strategy &amp; Factory Method</a:t>
             </a:r>
           </a:p>
         </p:txBody>
@@ -6080,8 +6361,8 @@
         </p:nvSpPr>
         <p:spPr>
           <a:xfrm>
-            <a:off x="6400800" y="1828800"/>
-            <a:ext cx="4846320" cy="4206240"/>
+            <a:off x="6400800" y="1737360"/>
+            <a:ext cx="4754880" cy="1737360"/>
           </a:xfrm>
           <a:prstGeom prst="rect">
             <a:avLst/>
@@ -6095,39 +6376,258 @@
           <a:lstStyle/>
           <a:p>
             <a:pPr>
-              <a:defRPr sz="1200"/>
+              <a:defRPr sz="1150"/>
             </a:pPr>
             <a:r>
-              <a:t>• Ghi nhận chi tiết từng bước tính toán:</a:t>
-            </a:r>
-            <a:br/>
-            <a:r>
-              <a:t>  - Pha 1: Nạp giao dịch &amp; cập nhật trọng số luồng f^(TL-Td).</a:t>
-            </a:r>
-            <a:br/>
-            <a:r>
-              <a:t>  - Pha 2: Tính DO(X) và cận trên DUBO(X).</a:t>
-            </a:r>
-            <a:br/>
-            <a:r>
-              <a:t>  - Pha 3: Duyệt cây đệ quy DFS &amp; quyết định Cắt tỉa (Prune).</a:t>
-            </a:r>
-            <a:br/>
-            <a:br/>
-            <a:r>
-              <a:t>• Công cụ hỗ trợ học tập &amp; giảng dạy:</a:t>
-            </a:r>
-            <a:br/>
-            <a:r>
-              <a:t>  - Tìm kiếm và lọc theo từng pha tính toán.</a:t>
-            </a:r>
-            <a:br/>
-            <a:r>
-              <a:t>  - Sao chép toàn bộ log định dạng chuẩn vào Clipboard.</a:t>
-            </a:r>
-            <a:br/>
-            <a:r>
-              <a:t>  - Ô Inspector giải thích chi tiết lý do mẫu được chọn/bị loại.</a:t>
+              <a:t>• EngineMode (Enum): Định nghĩa chiến lược engine độc lập.</a:t>
+            </a:r>
+            <a:br/>
+            <a:r>
+              <a:t>• EngineFactory: Khởi tạo engine phù hợp tại Runtime.</a:t>
+            </a:r>
+            <a:br/>
+            <a:r>
+              <a:t>• Người dùng hoán đổi linh hoạt giữa Local DFS, In-Process và TCP Socket mà không cần khởi động lại ứng dụng.</a:t>
+            </a:r>
+          </a:p>
+        </p:txBody>
+      </p:sp>
+      <p:sp>
+        <p:nvSpPr>
+          <p:cNvPr id="11" name="Rounded Rectangle 10"/>
+          <p:cNvSpPr/>
+          <p:nvPr/>
+        </p:nvSpPr>
+        <p:spPr>
+          <a:xfrm>
+            <a:off x="731520" y="3931920"/>
+            <a:ext cx="5120640" cy="2377440"/>
+          </a:xfrm>
+          <a:prstGeom prst="roundRect">
+            <a:avLst/>
+          </a:prstGeom>
+          <a:solidFill>
+            <a:srgbClr val="FFFFFF"/>
+          </a:solidFill>
+          <a:ln w="19050">
+            <a:solidFill>
+              <a:srgbClr val="2E75B6"/>
+            </a:solidFill>
+          </a:ln>
+        </p:spPr>
+        <p:style>
+          <a:lnRef idx="1">
+            <a:schemeClr val="accent1"/>
+          </a:lnRef>
+          <a:fillRef idx="3">
+            <a:schemeClr val="accent1"/>
+          </a:fillRef>
+          <a:effectRef idx="2">
+            <a:schemeClr val="accent1"/>
+          </a:effectRef>
+          <a:fontRef idx="minor">
+            <a:schemeClr val="lt1"/>
+          </a:fontRef>
+        </p:style>
+        <p:txBody>
+          <a:bodyPr rtlCol="0" anchor="ctr"/>
+          <a:lstStyle/>
+          <a:p>
+            <a:pPr algn="ctr"/>
+          </a:p>
+        </p:txBody>
+      </p:sp>
+      <p:sp>
+        <p:nvSpPr>
+          <p:cNvPr id="12" name="TextBox 11"/>
+          <p:cNvSpPr txBox="1"/>
+          <p:nvPr/>
+        </p:nvSpPr>
+        <p:spPr>
+          <a:xfrm>
+            <a:off x="914400" y="4069080"/>
+            <a:ext cx="4754880" cy="365760"/>
+          </a:xfrm>
+          <a:prstGeom prst="rect">
+            <a:avLst/>
+          </a:prstGeom>
+          <a:noFill/>
+        </p:spPr>
+        <p:txBody>
+          <a:bodyPr wrap="none">
+            <a:spAutoFit/>
+          </a:bodyPr>
+          <a:lstStyle/>
+          <a:p>
+            <a:pPr>
+              <a:defRPr sz="1350" b="1">
+                <a:solidFill>
+                  <a:srgbClr val="1F4E79"/>
+                </a:solidFill>
+                <a:latin typeface="Arial"/>
+              </a:defRPr>
+            </a:pPr>
+            <a:r>
+              <a:t>📡 Observer Pattern &amp; Memento</a:t>
+            </a:r>
+          </a:p>
+        </p:txBody>
+      </p:sp>
+      <p:sp>
+        <p:nvSpPr>
+          <p:cNvPr id="13" name="TextBox 12"/>
+          <p:cNvSpPr txBox="1"/>
+          <p:nvPr/>
+        </p:nvSpPr>
+        <p:spPr>
+          <a:xfrm>
+            <a:off x="914400" y="4389120"/>
+            <a:ext cx="4754880" cy="1737360"/>
+          </a:xfrm>
+          <a:prstGeom prst="rect">
+            <a:avLst/>
+          </a:prstGeom>
+          <a:noFill/>
+        </p:spPr>
+        <p:txBody>
+          <a:bodyPr wrap="square">
+            <a:spAutoFit/>
+          </a:bodyPr>
+          <a:lstStyle/>
+          <a:p>
+            <a:pPr>
+              <a:defRPr sz="1150"/>
+            </a:pPr>
+            <a:r>
+              <a:t>• MiningProgressListener: Báo cáo tiến độ và sự kiện JSONL.</a:t>
+            </a:r>
+            <a:br/>
+            <a:r>
+              <a:t>• Memento Pattern: Lưu trữ các snapshot lịch sử các lần chạy quét minSup (MiningHistoryManager).</a:t>
+            </a:r>
+            <a:br/>
+            <a:r>
+              <a:t>• Tác vụ chạy nền đa luồng, cập nhật an toàn qua Platform.runLater().</a:t>
+            </a:r>
+          </a:p>
+        </p:txBody>
+      </p:sp>
+      <p:sp>
+        <p:nvSpPr>
+          <p:cNvPr id="14" name="Rounded Rectangle 13"/>
+          <p:cNvSpPr/>
+          <p:nvPr/>
+        </p:nvSpPr>
+        <p:spPr>
+          <a:xfrm>
+            <a:off x="6217920" y="3931920"/>
+            <a:ext cx="5120640" cy="2377440"/>
+          </a:xfrm>
+          <a:prstGeom prst="roundRect">
+            <a:avLst/>
+          </a:prstGeom>
+          <a:solidFill>
+            <a:srgbClr val="FFFFFF"/>
+          </a:solidFill>
+          <a:ln w="19050">
+            <a:solidFill>
+              <a:srgbClr val="2E75B6"/>
+            </a:solidFill>
+          </a:ln>
+        </p:spPr>
+        <p:style>
+          <a:lnRef idx="1">
+            <a:schemeClr val="accent1"/>
+          </a:lnRef>
+          <a:fillRef idx="3">
+            <a:schemeClr val="accent1"/>
+          </a:fillRef>
+          <a:effectRef idx="2">
+            <a:schemeClr val="accent1"/>
+          </a:effectRef>
+          <a:fontRef idx="minor">
+            <a:schemeClr val="lt1"/>
+          </a:fontRef>
+        </p:style>
+        <p:txBody>
+          <a:bodyPr rtlCol="0" anchor="ctr"/>
+          <a:lstStyle/>
+          <a:p>
+            <a:pPr algn="ctr"/>
+          </a:p>
+        </p:txBody>
+      </p:sp>
+      <p:sp>
+        <p:nvSpPr>
+          <p:cNvPr id="15" name="TextBox 14"/>
+          <p:cNvSpPr txBox="1"/>
+          <p:nvPr/>
+        </p:nvSpPr>
+        <p:spPr>
+          <a:xfrm>
+            <a:off x="6400800" y="4069080"/>
+            <a:ext cx="4754880" cy="365760"/>
+          </a:xfrm>
+          <a:prstGeom prst="rect">
+            <a:avLst/>
+          </a:prstGeom>
+          <a:noFill/>
+        </p:spPr>
+        <p:txBody>
+          <a:bodyPr wrap="none">
+            <a:spAutoFit/>
+          </a:bodyPr>
+          <a:lstStyle/>
+          <a:p>
+            <a:pPr>
+              <a:defRPr sz="1350" b="1">
+                <a:solidFill>
+                  <a:srgbClr val="1F4E79"/>
+                </a:solidFill>
+                <a:latin typeface="Arial"/>
+              </a:defRPr>
+            </a:pPr>
+            <a:r>
+              <a:t>🏛️ Monorepo, Singleton &amp; MVC Records</a:t>
+            </a:r>
+          </a:p>
+        </p:txBody>
+      </p:sp>
+      <p:sp>
+        <p:nvSpPr>
+          <p:cNvPr id="16" name="TextBox 15"/>
+          <p:cNvSpPr txBox="1"/>
+          <p:nvPr/>
+        </p:nvSpPr>
+        <p:spPr>
+          <a:xfrm>
+            <a:off x="6400800" y="4389120"/>
+            <a:ext cx="4754880" cy="1737360"/>
+          </a:xfrm>
+          <a:prstGeom prst="rect">
+            <a:avLst/>
+          </a:prstGeom>
+          <a:noFill/>
+        </p:spPr>
+        <p:txBody>
+          <a:bodyPr wrap="square">
+            <a:spAutoFit/>
+          </a:bodyPr>
+          <a:lstStyle/>
+          <a:p>
+            <a:pPr>
+              <a:defRPr sz="1150"/>
+            </a:pPr>
+            <a:r>
+              <a:t>• dhopm-common: Module hợp đồng dùng chung, đảm bảo nguyên lý DIP.</a:t>
+            </a:r>
+            <a:br/>
+            <a:r>
+              <a:t>• Singleton: CalculationLogger và MiningHistoryManager duy nhất.</a:t>
+            </a:r>
+            <a:br/>
+            <a:r>
+              <a:t>• Modern Java Records: Entry, PatternResult, GoldenRow, TopItemStat.</a:t>
             </a:r>
           </a:p>
         </p:txBody>
@@ -6262,7 +6762,7 @@
               </a:defRPr>
             </a:pPr>
             <a:r>
-              <a:t>12. Bảng Đối Soát Toàn Diện 3 Cột (3-Column Reconciliation)</a:t>
+              <a:t>13. Giao Thức TCP Socket Client &amp; Mạng Phân Tán (Protocol 1)</a:t>
             </a:r>
           </a:p>
         </p:txBody>
@@ -6276,7 +6776,7 @@
         <p:spPr>
           <a:xfrm>
             <a:off x="731520" y="1280160"/>
-            <a:ext cx="3291840" cy="5029200"/>
+            <a:ext cx="5120640" cy="5029200"/>
           </a:xfrm>
           <a:prstGeom prst="roundRect">
             <a:avLst/>
@@ -6321,7 +6821,7 @@
         <p:spPr>
           <a:xfrm>
             <a:off x="914400" y="1417320"/>
-            <a:ext cx="2926080" cy="365760"/>
+            <a:ext cx="4754880" cy="365760"/>
           </a:xfrm>
           <a:prstGeom prst="rect">
             <a:avLst/>
@@ -6343,7 +6843,7 @@
               </a:defRPr>
             </a:pPr>
             <a:r>
-              <a:t>1. Tâm DFS Client</a:t>
+              <a:t>🔌 TCP Cổng 7079 &amp; Quét Mạng Tự Động (LAN)</a:t>
             </a:r>
           </a:p>
         </p:txBody>
@@ -6357,7 +6857,7 @@
         <p:spPr>
           <a:xfrm>
             <a:off x="914400" y="1828800"/>
-            <a:ext cx="2926080" cy="4114800"/>
+            <a:ext cx="4754880" cy="4206240"/>
           </a:xfrm>
           <a:prstGeom prst="rect">
             <a:avLst/>
@@ -6371,38 +6871,49 @@
           <a:lstStyle/>
           <a:p>
             <a:pPr>
-              <a:defRPr sz="1200"/>
+              <a:defRPr sz="1150"/>
             </a:pPr>
             <a:r>
-              <a:t>• Bản chất: In-Memory DFS</a:t>
-            </a:r>
-            <a:br/>
-            <a:r>
-              <a:t>• Mục đích: Nghiên cứu, kiểm chứng từng bước đệ quy.</a:t>
-            </a:r>
-            <a:br/>
-            <a:r>
-              <a:t>• Dataset: Table 1 (TL = 8)</a:t>
-            </a:r>
-            <a:br/>
-            <a:r>
-              <a:t>• Kết quả (f=0.9, ∂=0.15):</a:t>
-            </a:r>
-            <a:br/>
-            <a:r>
-              <a:t>  {AE}: DO = 1.2601</a:t>
-            </a:r>
-            <a:br/>
-            <a:r>
-              <a:t>  {F}:  DO = 1.2553</a:t>
-            </a:r>
-            <a:br/>
-            <a:r>
-              <a:t>• Tổng mẫu: 2 DHOPs</a:t>
-            </a:r>
-            <a:br/>
-            <a:r>
-              <a:t>• Đánh giá: Khớp 100% bài báo!</a:t>
+              <a:t>• Chuẩn hóa Protocol 1 (CONTRACT.md):</a:t>
+            </a:r>
+            <a:br/>
+            <a:r>
+              <a:t>  Giao tiếp qua TCP Socket port 7079, gửi 1 dòng lệnh JSON và nhận stream sự kiện JSONL đa dòng.</a:t>
+            </a:r>
+            <a:br/>
+            <a:br/>
+            <a:r>
+              <a:t>• Kết nối thực tế máy Tson (10.141.0.17:7079):</a:t>
+            </a:r>
+            <a:br/>
+            <a:r>
+              <a:t>  Tích hợp bảng cấu hình IP/Port trực tiếp trên GUI và tính năng 'Quét mạng (LAN)' đa luồng tự động tìm thấy backend trong 15ms.</a:t>
+            </a:r>
+            <a:br/>
+            <a:br/>
+            <a:r>
+              <a:t>• Tích hợp Mock TCP Server nội bộ:</a:t>
+            </a:r>
+            <a:br/>
+            <a:r>
+              <a:t>  Lớp DhopmContractTcpServer chạy ngầm với CachedThreadPool giúp ứng dụng tự chủ kiểm thử độc lập mà không cần server ngoài.</a:t>
+            </a:r>
+            <a:br/>
+            <a:br/>
+            <a:r>
+              <a:t>• Huy hiệu nguồn dữ liệu động (Data Source Badge):</a:t>
+            </a:r>
+            <a:br/>
+            <a:r>
+              <a:t>  🟢 BE (10.141.0.17:7079): Đang kết nối máy Tson.</a:t>
+            </a:r>
+            <a:br/>
+            <a:r>
+              <a:t>  🔵 Tson V1 (In-Process): Đang chạy engine nội bộ.</a:t>
+            </a:r>
+            <a:br/>
+            <a:r>
+              <a:t>  🟡 DEMO (Tâm 8 tx): Đang chạy mô phỏng.</a:t>
             </a:r>
           </a:p>
         </p:txBody>
@@ -6415,8 +6926,8 @@
         </p:nvSpPr>
         <p:spPr>
           <a:xfrm>
-            <a:off x="4389120" y="1280160"/>
-            <a:ext cx="3291840" cy="5029200"/>
+            <a:off x="6217920" y="1280160"/>
+            <a:ext cx="5212080" cy="5029200"/>
           </a:xfrm>
           <a:prstGeom prst="roundRect">
             <a:avLst/>
@@ -6426,7 +6937,7 @@
           </a:solidFill>
           <a:ln w="19050">
             <a:solidFill>
-              <a:srgbClr val="27AE60"/>
+              <a:srgbClr val="0E6251"/>
             </a:solidFill>
           </a:ln>
         </p:spPr>
@@ -6460,8 +6971,8 @@
         </p:nvSpPr>
         <p:spPr>
           <a:xfrm>
-            <a:off x="4572000" y="1417320"/>
-            <a:ext cx="2926080" cy="365760"/>
+            <a:off x="6400800" y="1417320"/>
+            <a:ext cx="4846320" cy="365760"/>
           </a:xfrm>
           <a:prstGeom prst="rect">
             <a:avLst/>
@@ -6483,7 +6994,7 @@
               </a:defRPr>
             </a:pPr>
             <a:r>
-              <a:t>2. Tson In-Process</a:t>
+              <a:t>⚡ Thuật Toán Khử Trùng Lặp &amp; Phản Chiếu R14</a:t>
             </a:r>
           </a:p>
         </p:txBody>
@@ -6496,8 +7007,8 @@
         </p:nvSpPr>
         <p:spPr>
           <a:xfrm>
-            <a:off x="4572000" y="1828800"/>
-            <a:ext cx="2926080" cy="4114800"/>
+            <a:off x="6400800" y="1828800"/>
+            <a:ext cx="4846320" cy="4206240"/>
           </a:xfrm>
           <a:prstGeom prst="rect">
             <a:avLst/>
@@ -6511,178 +7022,41 @@
           <a:lstStyle/>
           <a:p>
             <a:pPr>
-              <a:defRPr sz="1200"/>
+              <a:defRPr sz="1150"/>
             </a:pPr>
             <a:r>
-              <a:t>• Bản chất: Engine Java nội bộ</a:t>
-            </a:r>
-            <a:br/>
-            <a:r>
-              <a:t>• Mục đích: Khai phá tốc độ cao offline không cần mạng.</a:t>
-            </a:r>
-            <a:br/>
-            <a:r>
-              <a:t>• Dataset: Table 1 (TL = 8)</a:t>
-            </a:r>
-            <a:br/>
-            <a:r>
-              <a:t>• Kết quả (f=0.9, ∂=0.15):</a:t>
-            </a:r>
-            <a:br/>
-            <a:r>
-              <a:t>  {AE}: DO = 1.2601</a:t>
-            </a:r>
-            <a:br/>
-            <a:r>
-              <a:t>  {F}:  DO = 1.2553</a:t>
-            </a:r>
-            <a:br/>
-            <a:r>
-              <a:t>• Tổng mẫu: 2 DHOPs</a:t>
-            </a:r>
-            <a:br/>
-            <a:r>
-              <a:t>• Đánh giá: Trùng khớp tuyệt đối!</a:t>
-            </a:r>
-          </a:p>
-        </p:txBody>
-      </p:sp>
-      <p:sp>
-        <p:nvSpPr>
-          <p:cNvPr id="11" name="Rounded Rectangle 10"/>
-          <p:cNvSpPr/>
-          <p:nvPr/>
-        </p:nvSpPr>
-        <p:spPr>
-          <a:xfrm>
-            <a:off x="8046720" y="1280160"/>
-            <a:ext cx="3291840" cy="5029200"/>
-          </a:xfrm>
-          <a:prstGeom prst="roundRect">
-            <a:avLst/>
-          </a:prstGeom>
-          <a:solidFill>
-            <a:srgbClr val="FFFFFF"/>
-          </a:solidFill>
-          <a:ln w="19050">
-            <a:solidFill>
-              <a:srgbClr val="8E44AD"/>
-            </a:solidFill>
-          </a:ln>
-        </p:spPr>
-        <p:style>
-          <a:lnRef idx="1">
-            <a:schemeClr val="accent1"/>
-          </a:lnRef>
-          <a:fillRef idx="3">
-            <a:schemeClr val="accent1"/>
-          </a:fillRef>
-          <a:effectRef idx="2">
-            <a:schemeClr val="accent1"/>
-          </a:effectRef>
-          <a:fontRef idx="minor">
-            <a:schemeClr val="lt1"/>
-          </a:fontRef>
-        </p:style>
-        <p:txBody>
-          <a:bodyPr rtlCol="0" anchor="ctr"/>
-          <a:lstStyle/>
-          <a:p>
-            <a:pPr algn="ctr"/>
-          </a:p>
-        </p:txBody>
-      </p:sp>
-      <p:sp>
-        <p:nvSpPr>
-          <p:cNvPr id="12" name="TextBox 11"/>
-          <p:cNvSpPr txBox="1"/>
-          <p:nvPr/>
-        </p:nvSpPr>
-        <p:spPr>
-          <a:xfrm>
-            <a:off x="8229600" y="1417320"/>
-            <a:ext cx="2926080" cy="365760"/>
-          </a:xfrm>
-          <a:prstGeom prst="rect">
-            <a:avLst/>
-          </a:prstGeom>
-          <a:noFill/>
-        </p:spPr>
-        <p:txBody>
-          <a:bodyPr wrap="none">
-            <a:spAutoFit/>
-          </a:bodyPr>
-          <a:lstStyle/>
-          <a:p>
-            <a:pPr>
-              <a:defRPr sz="1350" b="1">
-                <a:solidFill>
-                  <a:srgbClr val="1F4E79"/>
-                </a:solidFill>
-                <a:latin typeface="Arial"/>
-              </a:defRPr>
-            </a:pPr>
-            <a:r>
-              <a:t>3. Tson TCP Backend</a:t>
-            </a:r>
-          </a:p>
-        </p:txBody>
-      </p:sp>
-      <p:sp>
-        <p:nvSpPr>
-          <p:cNvPr id="13" name="TextBox 12"/>
-          <p:cNvSpPr txBox="1"/>
-          <p:nvPr/>
-        </p:nvSpPr>
-        <p:spPr>
-          <a:xfrm>
-            <a:off x="8229600" y="1828800"/>
-            <a:ext cx="2926080" cy="4114800"/>
-          </a:xfrm>
-          <a:prstGeom prst="rect">
-            <a:avLst/>
-          </a:prstGeom>
-          <a:noFill/>
-        </p:spPr>
-        <p:txBody>
-          <a:bodyPr wrap="square">
-            <a:spAutoFit/>
-          </a:bodyPr>
-          <a:lstStyle/>
-          <a:p>
-            <a:pPr>
-              <a:defRPr sz="1200"/>
-            </a:pPr>
-            <a:r>
-              <a:t>• Bản chất: Microservice TCP:7079</a:t>
-            </a:r>
-            <a:br/>
-            <a:r>
-              <a:t>• Mục đích: Xử lý dữ liệu lớn, stream sự kiện JSONL.</a:t>
-            </a:r>
-            <a:br/>
-            <a:r>
-              <a:t>• Dataset: Table 1 (TL = 8)</a:t>
-            </a:r>
-            <a:br/>
-            <a:r>
-              <a:t>• Kết quả (f=0.9, ∂=0.15):</a:t>
-            </a:r>
-            <a:br/>
-            <a:r>
-              <a:t>  {AE}: DO = 1.2601</a:t>
-            </a:r>
-            <a:br/>
-            <a:r>
-              <a:t>  {F}:  DO = 1.2553</a:t>
-            </a:r>
-            <a:br/>
-            <a:r>
-              <a:t>• Tổng mẫu: 2 DHOPs</a:t>
-            </a:r>
-            <a:br/>
-            <a:r>
-              <a:t>• R14: Mirror mine_&lt;id&gt;.txt</a:t>
+              <a:t>• Bóc tách độ sâu ngoặc vuông JSON (depth tracking):</a:t>
+            </a:r>
+            <a:br/>
+            <a:r>
+              <a:t>  Ngắt chính xác tại mảng patterns đầu tiên, ngăn chặn hoàn toàn việc nuốt chửng mảng perVersion.v1 từ backend.</a:t>
+            </a:r>
+            <a:br/>
+            <a:br/>
+            <a:r>
+              <a:t>• Thuật toán Khử trùng lặp (deduplicatePatterns):</a:t>
+            </a:r>
+            <a:br/>
+            <a:r>
+              <a:t>  Chuẩn hóa khóa canonicalItemsetKey theo thứ tự từ điển, loại bỏ mẫu trùng (từ 10 dòng lặp xuống 5 dòng chuẩn), giữ lại DO cao nhất.</a:t>
+            </a:r>
+            <a:br/>
+            <a:br/>
+            <a:r>
+              <a:t>• Chuẩn hóa hiển thị normalizePattern:</a:t>
+            </a:r>
+            <a:br/>
+            <a:r>
+              <a:t>  Xử lý triệt để lỗi lồng ngoặc nhọn {{B, F}} về định dạng chuẩn {B, F}, bóc tách danh sách giao dịch TIDs.</a:t>
+            </a:r>
+            <a:br/>
+            <a:br/>
+            <a:r>
+              <a:t>• Quy tắc R14 Phản chiếu tệp cục bộ (Local Mirroring):</a:t>
+            </a:r>
+            <a:br/>
+            <a:r>
+              <a:t>  Client tự động fetch và lưu tệp kết quả tại mine/mine_&lt;fileID&gt;.txt khớp 100% dữ liệu backend.</a:t>
             </a:r>
           </a:p>
         </p:txBody>
@@ -6817,7 +7191,7 @@
               </a:defRPr>
             </a:pPr>
             <a:r>
-              <a:t>13. Kết Quả Kiểm Thử (63/63 Tests PASS) &amp; Ma Trận Golden</a:t>
+              <a:t>14. Cải Tiến Giao Diện Người Dùng Chuẩn Xác (Loại Bỏ Slider)</a:t>
             </a:r>
           </a:p>
         </p:txBody>
@@ -6831,7 +7205,153 @@
         <p:spPr>
           <a:xfrm>
             <a:off x="731520" y="1280160"/>
-            <a:ext cx="3931920" cy="5029200"/>
+            <a:ext cx="5120640" cy="5029200"/>
+          </a:xfrm>
+          <a:prstGeom prst="roundRect">
+            <a:avLst/>
+          </a:prstGeom>
+          <a:solidFill>
+            <a:srgbClr val="FFFFFF"/>
+          </a:solidFill>
+          <a:ln w="19050">
+            <a:solidFill>
+              <a:srgbClr val="D35400"/>
+            </a:solidFill>
+          </a:ln>
+        </p:spPr>
+        <p:style>
+          <a:lnRef idx="1">
+            <a:schemeClr val="accent1"/>
+          </a:lnRef>
+          <a:fillRef idx="3">
+            <a:schemeClr val="accent1"/>
+          </a:fillRef>
+          <a:effectRef idx="2">
+            <a:schemeClr val="accent1"/>
+          </a:effectRef>
+          <a:fontRef idx="minor">
+            <a:schemeClr val="lt1"/>
+          </a:fontRef>
+        </p:style>
+        <p:txBody>
+          <a:bodyPr rtlCol="0" anchor="ctr"/>
+          <a:lstStyle/>
+          <a:p>
+            <a:pPr algn="ctr"/>
+          </a:p>
+        </p:txBody>
+      </p:sp>
+      <p:sp>
+        <p:nvSpPr>
+          <p:cNvPr id="6" name="TextBox 5"/>
+          <p:cNvSpPr txBox="1"/>
+          <p:nvPr/>
+        </p:nvSpPr>
+        <p:spPr>
+          <a:xfrm>
+            <a:off x="914400" y="1417320"/>
+            <a:ext cx="4754880" cy="365760"/>
+          </a:xfrm>
+          <a:prstGeom prst="rect">
+            <a:avLst/>
+          </a:prstGeom>
+          <a:noFill/>
+        </p:spPr>
+        <p:txBody>
+          <a:bodyPr wrap="none">
+            <a:spAutoFit/>
+          </a:bodyPr>
+          <a:lstStyle/>
+          <a:p>
+            <a:pPr>
+              <a:defRPr sz="1350" b="1">
+                <a:solidFill>
+                  <a:srgbClr val="1F4E79"/>
+                </a:solidFill>
+                <a:latin typeface="Arial"/>
+              </a:defRPr>
+            </a:pPr>
+            <a:r>
+              <a:t>🎯 Loại Bỏ Slider &amp; Đào Tự Động Ngoài Ý Muốn</a:t>
+            </a:r>
+          </a:p>
+        </p:txBody>
+      </p:sp>
+      <p:sp>
+        <p:nvSpPr>
+          <p:cNvPr id="7" name="TextBox 6"/>
+          <p:cNvSpPr txBox="1"/>
+          <p:nvPr/>
+        </p:nvSpPr>
+        <p:spPr>
+          <a:xfrm>
+            <a:off x="914400" y="1828800"/>
+            <a:ext cx="4754880" cy="4206240"/>
+          </a:xfrm>
+          <a:prstGeom prst="rect">
+            <a:avLst/>
+          </a:prstGeom>
+          <a:noFill/>
+        </p:spPr>
+        <p:txBody>
+          <a:bodyPr wrap="square">
+            <a:spAutoFit/>
+          </a:bodyPr>
+          <a:lstStyle/>
+          <a:p>
+            <a:pPr>
+              <a:defRPr sz="1200"/>
+            </a:pPr>
+            <a:r>
+              <a:t>• Vấn đề của Slider cũ:</a:t>
+            </a:r>
+            <a:br/>
+            <a:r>
+              <a:t>  Kéo trượt kích hoạt tính toán liên tục, gây lag và tràn luồng khi dữ liệu lớn.</a:t>
+            </a:r>
+            <a:br/>
+            <a:br/>
+            <a:r>
+              <a:t>• Giải pháp Ô nhập TextField chuẩn xác:</a:t>
+            </a:r>
+            <a:br/>
+            <a:r>
+              <a:t>  - Decay Factor (f): Nhập chính xác 0.9 ∈ (0, 1].</a:t>
+            </a:r>
+            <a:br/>
+            <a:r>
+              <a:t>  - MinSup Ratio (∂): Nhập trực tiếp 0.2 ∈ (0, 1] hoặc %.</a:t>
+            </a:r>
+            <a:br/>
+            <a:r>
+              <a:t>  - MinOcc: Nhập chính xác giá trị thực tế (ẩn ở v1, hiện ở v2/v3).</a:t>
+            </a:r>
+            <a:br/>
+            <a:r>
+              <a:t>  - Limit: Nhập số lượng giới hạn mẫu trả về.</a:t>
+            </a:r>
+            <a:br/>
+            <a:br/>
+            <a:r>
+              <a:t>• Chỉ tính toán khi nhấn nút:</a:t>
+            </a:r>
+            <a:br/>
+            <a:r>
+              <a:t>  Nút Khai phá (Mine) to nhất, nổi bật ở dưới cùng, phân bổ nút Dừng và Golden hàng trên hợp lý.</a:t>
+            </a:r>
+          </a:p>
+        </p:txBody>
+      </p:sp>
+      <p:sp>
+        <p:nvSpPr>
+          <p:cNvPr id="8" name="Rounded Rectangle 7"/>
+          <p:cNvSpPr/>
+          <p:nvPr/>
+        </p:nvSpPr>
+        <p:spPr>
+          <a:xfrm>
+            <a:off x="6217920" y="1280160"/>
+            <a:ext cx="5212080" cy="5029200"/>
           </a:xfrm>
           <a:prstGeom prst="roundRect">
             <a:avLst/>
@@ -6869,14 +7389,14 @@
       </p:sp>
       <p:sp>
         <p:nvSpPr>
-          <p:cNvPr id="6" name="TextBox 5"/>
+          <p:cNvPr id="9" name="TextBox 8"/>
           <p:cNvSpPr txBox="1"/>
           <p:nvPr/>
         </p:nvSpPr>
         <p:spPr>
           <a:xfrm>
-            <a:off x="914400" y="1417320"/>
-            <a:ext cx="3566160" cy="365760"/>
+            <a:off x="6400800" y="1417320"/>
+            <a:ext cx="4846320" cy="365760"/>
           </a:xfrm>
           <a:prstGeom prst="rect">
             <a:avLst/>
@@ -6898,21 +7418,21 @@
               </a:defRPr>
             </a:pPr>
             <a:r>
-              <a:t>✅ 63/63 Unit Tests PASS 100%</a:t>
-            </a:r>
-          </a:p>
-        </p:txBody>
-      </p:sp>
-      <p:sp>
-        <p:nvSpPr>
-          <p:cNvPr id="7" name="TextBox 6"/>
+              <a:t>📋 100% Native TableView &amp; Cô Lập Demo Panel</a:t>
+            </a:r>
+          </a:p>
+        </p:txBody>
+      </p:sp>
+      <p:sp>
+        <p:nvSpPr>
+          <p:cNvPr id="10" name="TextBox 9"/>
           <p:cNvSpPr txBox="1"/>
           <p:nvPr/>
         </p:nvSpPr>
         <p:spPr>
           <a:xfrm>
-            <a:off x="914400" y="1828800"/>
-            <a:ext cx="3566160" cy="4206240"/>
+            <a:off x="6400800" y="1828800"/>
+            <a:ext cx="4846320" cy="4206240"/>
           </a:xfrm>
           <a:prstGeom prst="rect">
             <a:avLst/>
@@ -6926,10 +7446,1252 @@
           <a:lstStyle/>
           <a:p>
             <a:pPr>
+              <a:defRPr sz="1200"/>
+            </a:pPr>
+            <a:r>
+              <a:t>• Loại bỏ hoàn toàn Terminal Console:</a:t>
+            </a:r>
+            <a:br/>
+            <a:r>
+              <a:t>  Không còn màn hình đen trắng bị lệch font Unicode trên macOS; thay thế bằng TableView native sang trọng.</a:t>
+            </a:r>
+            <a:br/>
+            <a:br/>
+            <a:r>
+              <a:t>• Bảng Mẫu Khai Phá Đa Cột:</a:t>
+            </a:r>
+            <a:br/>
+            <a:r>
+              <a:t>  Hiển thị STT, Itemset X (in đậm tím), DO(X), Support, Độ dài |X|, TIDs.</a:t>
+            </a:r>
+            <a:br/>
+            <a:br/>
+            <a:r>
+              <a:t>• Cô lập Panel 2 cho Luồng Demo:</a:t>
+            </a:r>
+            <a:br/>
+            <a:r>
+              <a:t>  Panel 2 được gắn nhãn minh bạch '📡 LUỒNG DỮ LIỆU [DEMO TÂM]', tách biệt hoàn toàn dữ liệu demo 8 giao dịch khỏi các lượt benchmark Big Data thật.</a:t>
+            </a:r>
+          </a:p>
+        </p:txBody>
+      </p:sp>
+    </p:spTree>
+  </p:cSld>
+  <p:clrMapOvr>
+    <a:masterClrMapping/>
+  </p:clrMapOvr>
+</p:sld>
+</file>
+
+<file path=ppt/slides/slide15.xml><?xml version="1.0" encoding="utf-8"?>
+<p:sld xmlns:a="http://schemas.openxmlformats.org/drawingml/2006/main" xmlns:p="http://schemas.openxmlformats.org/presentationml/2006/main" xmlns:r="http://schemas.openxmlformats.org/officeDocument/2006/relationships">
+  <p:cSld>
+    <p:spTree>
+      <p:nvGrpSpPr>
+        <p:cNvPr id="1" name=""/>
+        <p:cNvGrpSpPr/>
+        <p:nvPr/>
+      </p:nvGrpSpPr>
+      <p:grpSpPr/>
+      <p:sp>
+        <p:nvSpPr>
+          <p:cNvPr id="2" name="Rectangle 1"/>
+          <p:cNvSpPr/>
+          <p:nvPr/>
+        </p:nvSpPr>
+        <p:spPr>
+          <a:xfrm>
+            <a:off x="0" y="0"/>
+            <a:ext cx="12191695" cy="1005840"/>
+          </a:xfrm>
+          <a:prstGeom prst="rect">
+            <a:avLst/>
+          </a:prstGeom>
+          <a:solidFill>
+            <a:srgbClr val="1F4E79"/>
+          </a:solidFill>
+          <a:ln>
+            <a:solidFill>
+              <a:srgbClr val="1F4E79"/>
+            </a:solidFill>
+          </a:ln>
+        </p:spPr>
+        <p:style>
+          <a:lnRef idx="1">
+            <a:schemeClr val="accent1"/>
+          </a:lnRef>
+          <a:fillRef idx="3">
+            <a:schemeClr val="accent1"/>
+          </a:fillRef>
+          <a:effectRef idx="2">
+            <a:schemeClr val="accent1"/>
+          </a:effectRef>
+          <a:fontRef idx="minor">
+            <a:schemeClr val="lt1"/>
+          </a:fontRef>
+        </p:style>
+        <p:txBody>
+          <a:bodyPr rtlCol="0" anchor="ctr"/>
+          <a:lstStyle/>
+          <a:p>
+            <a:pPr algn="ctr"/>
+          </a:p>
+        </p:txBody>
+      </p:sp>
+      <p:sp>
+        <p:nvSpPr>
+          <p:cNvPr id="3" name="TextBox 2"/>
+          <p:cNvSpPr txBox="1"/>
+          <p:nvPr/>
+        </p:nvSpPr>
+        <p:spPr>
+          <a:xfrm>
+            <a:off x="731520" y="109728"/>
+            <a:ext cx="10515600" cy="274320"/>
+          </a:xfrm>
+          <a:prstGeom prst="rect">
+            <a:avLst/>
+          </a:prstGeom>
+          <a:noFill/>
+        </p:spPr>
+        <p:txBody>
+          <a:bodyPr wrap="none">
+            <a:spAutoFit/>
+          </a:bodyPr>
+          <a:lstStyle/>
+          <a:p>
+            <a:pPr>
+              <a:defRPr sz="1000" b="1">
+                <a:solidFill>
+                  <a:srgbClr val="A9DFBF"/>
+                </a:solidFill>
+                <a:latin typeface="Arial"/>
+              </a:defRPr>
+            </a:pPr>
+            <a:r>
+              <a:t>LẬP TRÌNH JAVA NÂNG CAO | ĐỒ ÁN MÔN HỌC</a:t>
+            </a:r>
+          </a:p>
+        </p:txBody>
+      </p:sp>
+      <p:sp>
+        <p:nvSpPr>
+          <p:cNvPr id="4" name="TextBox 3"/>
+          <p:cNvSpPr txBox="1"/>
+          <p:nvPr/>
+        </p:nvSpPr>
+        <p:spPr>
+          <a:xfrm>
+            <a:off x="731520" y="365760"/>
+            <a:ext cx="10515600" cy="548640"/>
+          </a:xfrm>
+          <a:prstGeom prst="rect">
+            <a:avLst/>
+          </a:prstGeom>
+          <a:noFill/>
+        </p:spPr>
+        <p:txBody>
+          <a:bodyPr wrap="none">
+            <a:spAutoFit/>
+          </a:bodyPr>
+          <a:lstStyle/>
+          <a:p>
+            <a:pPr>
+              <a:defRPr sz="2200" b="1">
+                <a:solidFill>
+                  <a:srgbClr val="FFFFFF"/>
+                </a:solidFill>
+                <a:latin typeface="Arial"/>
+              </a:defRPr>
+            </a:pPr>
+            <a:r>
+              <a:t>15. Tính Năng Đột Phá: Quét minSup Sweep &amp; Calculation Logger</a:t>
+            </a:r>
+          </a:p>
+        </p:txBody>
+      </p:sp>
+      <p:sp>
+        <p:nvSpPr>
+          <p:cNvPr id="5" name="Rounded Rectangle 4"/>
+          <p:cNvSpPr/>
+          <p:nvPr/>
+        </p:nvSpPr>
+        <p:spPr>
+          <a:xfrm>
+            <a:off x="731520" y="1280160"/>
+            <a:ext cx="5120640" cy="5029200"/>
+          </a:xfrm>
+          <a:prstGeom prst="roundRect">
+            <a:avLst/>
+          </a:prstGeom>
+          <a:solidFill>
+            <a:srgbClr val="FFFFFF"/>
+          </a:solidFill>
+          <a:ln w="19050">
+            <a:solidFill>
+              <a:srgbClr val="2E75B6"/>
+            </a:solidFill>
+          </a:ln>
+        </p:spPr>
+        <p:style>
+          <a:lnRef idx="1">
+            <a:schemeClr val="accent1"/>
+          </a:lnRef>
+          <a:fillRef idx="3">
+            <a:schemeClr val="accent1"/>
+          </a:fillRef>
+          <a:effectRef idx="2">
+            <a:schemeClr val="accent1"/>
+          </a:effectRef>
+          <a:fontRef idx="minor">
+            <a:schemeClr val="lt1"/>
+          </a:fontRef>
+        </p:style>
+        <p:txBody>
+          <a:bodyPr rtlCol="0" anchor="ctr"/>
+          <a:lstStyle/>
+          <a:p>
+            <a:pPr algn="ctr"/>
+          </a:p>
+        </p:txBody>
+      </p:sp>
+      <p:sp>
+        <p:nvSpPr>
+          <p:cNvPr id="6" name="TextBox 5"/>
+          <p:cNvSpPr txBox="1"/>
+          <p:nvPr/>
+        </p:nvSpPr>
+        <p:spPr>
+          <a:xfrm>
+            <a:off x="914400" y="1417320"/>
+            <a:ext cx="4754880" cy="365760"/>
+          </a:xfrm>
+          <a:prstGeom prst="rect">
+            <a:avLst/>
+          </a:prstGeom>
+          <a:noFill/>
+        </p:spPr>
+        <p:txBody>
+          <a:bodyPr wrap="none">
+            <a:spAutoFit/>
+          </a:bodyPr>
+          <a:lstStyle/>
+          <a:p>
+            <a:pPr>
+              <a:defRPr sz="1350" b="1">
+                <a:solidFill>
+                  <a:srgbClr val="1F4E79"/>
+                </a:solidFill>
+                <a:latin typeface="Arial"/>
+              </a:defRPr>
+            </a:pPr>
+            <a:r>
+              <a:t>📈 Quét Ngưỡng minSup Sweep (Chuẩn Bài Báo)</a:t>
+            </a:r>
+          </a:p>
+        </p:txBody>
+      </p:sp>
+      <p:sp>
+        <p:nvSpPr>
+          <p:cNvPr id="7" name="TextBox 6"/>
+          <p:cNvSpPr txBox="1"/>
+          <p:nvPr/>
+        </p:nvSpPr>
+        <p:spPr>
+          <a:xfrm>
+            <a:off x="914400" y="1828800"/>
+            <a:ext cx="4754880" cy="4206240"/>
+          </a:xfrm>
+          <a:prstGeom prst="rect">
+            <a:avLst/>
+          </a:prstGeom>
+          <a:noFill/>
+        </p:spPr>
+        <p:txBody>
+          <a:bodyPr wrap="square">
+            <a:spAutoFit/>
+          </a:bodyPr>
+          <a:lstStyle/>
+          <a:p>
+            <a:pPr>
+              <a:defRPr sz="1200"/>
+            </a:pPr>
+            <a:r>
+              <a:t>• Tự động lặp qua dải ngưỡng ∂ (5% – 50%):</a:t>
+            </a:r>
+            <a:br/>
+            <a:r>
+              <a:t>  Khảo sát toàn diện động thái thuật toán khi thay đổi độ khắt khe của ngưỡng lọc.</a:t>
+            </a:r>
+            <a:br/>
+            <a:br/>
+            <a:r>
+              <a:t>• Tái hiện 3 Biểu đồ Chuẩn Bài Báo EAAI 2026:</a:t>
+            </a:r>
+            <a:br/>
+            <a:r>
+              <a:t>  - Figure 6: Số lượng mẫu DHOP &amp; Tỷ lệ cắt tỉa DUBO theo minSup.</a:t>
+            </a:r>
+            <a:br/>
+            <a:r>
+              <a:t>  - Figure 11: Thời gian thực thi (Runtime ms) giảm hàm mũ.</a:t>
+            </a:r>
+            <a:br/>
+            <a:r>
+              <a:t>  - Figure 13: Bộ nhớ đỉnh (Peak Heap RAM MB).</a:t>
+            </a:r>
+            <a:br/>
+            <a:br/>
+            <a:r>
+              <a:t>• Xóa bỏ số liệu giả lập:</a:t>
+            </a:r>
+            <a:br/>
+            <a:r>
+              <a:t>  Toàn bộ chỉ số đều đo lường trực tiếp từ engine và đã được kiểm chứng bằng ChartPaperVerificationTest.</a:t>
+            </a:r>
+          </a:p>
+        </p:txBody>
+      </p:sp>
+      <p:sp>
+        <p:nvSpPr>
+          <p:cNvPr id="8" name="Rounded Rectangle 7"/>
+          <p:cNvSpPr/>
+          <p:nvPr/>
+        </p:nvSpPr>
+        <p:spPr>
+          <a:xfrm>
+            <a:off x="6217920" y="1280160"/>
+            <a:ext cx="5212080" cy="5029200"/>
+          </a:xfrm>
+          <a:prstGeom prst="roundRect">
+            <a:avLst/>
+          </a:prstGeom>
+          <a:solidFill>
+            <a:srgbClr val="FFFFFF"/>
+          </a:solidFill>
+          <a:ln w="19050">
+            <a:solidFill>
+              <a:srgbClr val="0E6251"/>
+            </a:solidFill>
+          </a:ln>
+        </p:spPr>
+        <p:style>
+          <a:lnRef idx="1">
+            <a:schemeClr val="accent1"/>
+          </a:lnRef>
+          <a:fillRef idx="3">
+            <a:schemeClr val="accent1"/>
+          </a:fillRef>
+          <a:effectRef idx="2">
+            <a:schemeClr val="accent1"/>
+          </a:effectRef>
+          <a:fontRef idx="minor">
+            <a:schemeClr val="lt1"/>
+          </a:fontRef>
+        </p:style>
+        <p:txBody>
+          <a:bodyPr rtlCol="0" anchor="ctr"/>
+          <a:lstStyle/>
+          <a:p>
+            <a:pPr algn="ctr"/>
+          </a:p>
+        </p:txBody>
+      </p:sp>
+      <p:sp>
+        <p:nvSpPr>
+          <p:cNvPr id="9" name="TextBox 8"/>
+          <p:cNvSpPr txBox="1"/>
+          <p:nvPr/>
+        </p:nvSpPr>
+        <p:spPr>
+          <a:xfrm>
+            <a:off x="6400800" y="1417320"/>
+            <a:ext cx="4846320" cy="365760"/>
+          </a:xfrm>
+          <a:prstGeom prst="rect">
+            <a:avLst/>
+          </a:prstGeom>
+          <a:noFill/>
+        </p:spPr>
+        <p:txBody>
+          <a:bodyPr wrap="none">
+            <a:spAutoFit/>
+          </a:bodyPr>
+          <a:lstStyle/>
+          <a:p>
+            <a:pPr>
+              <a:defRPr sz="1350" b="1">
+                <a:solidFill>
+                  <a:srgbClr val="1F4E79"/>
+                </a:solidFill>
+                <a:latin typeface="Arial"/>
+              </a:defRPr>
+            </a:pPr>
+            <a:r>
+              <a:t>📝 Nhật Ký Chi Tiết Phép Toán (Tab 6)</a:t>
+            </a:r>
+          </a:p>
+        </p:txBody>
+      </p:sp>
+      <p:sp>
+        <p:nvSpPr>
+          <p:cNvPr id="10" name="TextBox 9"/>
+          <p:cNvSpPr txBox="1"/>
+          <p:nvPr/>
+        </p:nvSpPr>
+        <p:spPr>
+          <a:xfrm>
+            <a:off x="6400800" y="1828800"/>
+            <a:ext cx="4846320" cy="4206240"/>
+          </a:xfrm>
+          <a:prstGeom prst="rect">
+            <a:avLst/>
+          </a:prstGeom>
+          <a:noFill/>
+        </p:spPr>
+        <p:txBody>
+          <a:bodyPr wrap="square">
+            <a:spAutoFit/>
+          </a:bodyPr>
+          <a:lstStyle/>
+          <a:p>
+            <a:pPr>
+              <a:defRPr sz="1200"/>
+            </a:pPr>
+            <a:r>
+              <a:t>• Ghi nhận chi tiết từng bước tính toán:</a:t>
+            </a:r>
+            <a:br/>
+            <a:r>
+              <a:t>  - Pha 1: Nạp giao dịch &amp; cập nhật trọng số luồng f^(TL-Td).</a:t>
+            </a:r>
+            <a:br/>
+            <a:r>
+              <a:t>  - Pha 2: Tính DO(X) và cận trên DUBO(X).</a:t>
+            </a:r>
+            <a:br/>
+            <a:r>
+              <a:t>  - Pha 3: Duyệt cây đệ quy DFS &amp; quyết định Cắt tỉa (Prune).</a:t>
+            </a:r>
+            <a:br/>
+            <a:br/>
+            <a:r>
+              <a:t>• Công cụ hỗ trợ học tập &amp; giảng dạy:</a:t>
+            </a:r>
+            <a:br/>
+            <a:r>
+              <a:t>  - Tìm kiếm và lọc theo từng pha tính toán.</a:t>
+            </a:r>
+            <a:br/>
+            <a:r>
+              <a:t>  - Sao chép toàn bộ log định dạng chuẩn vào Clipboard.</a:t>
+            </a:r>
+            <a:br/>
+            <a:r>
+              <a:t>  - Ô Inspector giải thích chi tiết lý do mẫu được chọn/bị loại.</a:t>
+            </a:r>
+          </a:p>
+        </p:txBody>
+      </p:sp>
+    </p:spTree>
+  </p:cSld>
+  <p:clrMapOvr>
+    <a:masterClrMapping/>
+  </p:clrMapOvr>
+</p:sld>
+</file>
+
+<file path=ppt/slides/slide16.xml><?xml version="1.0" encoding="utf-8"?>
+<p:sld xmlns:a="http://schemas.openxmlformats.org/drawingml/2006/main" xmlns:p="http://schemas.openxmlformats.org/presentationml/2006/main" xmlns:r="http://schemas.openxmlformats.org/officeDocument/2006/relationships">
+  <p:cSld>
+    <p:spTree>
+      <p:nvGrpSpPr>
+        <p:cNvPr id="1" name=""/>
+        <p:cNvGrpSpPr/>
+        <p:nvPr/>
+      </p:nvGrpSpPr>
+      <p:grpSpPr/>
+      <p:sp>
+        <p:nvSpPr>
+          <p:cNvPr id="2" name="Rectangle 1"/>
+          <p:cNvSpPr/>
+          <p:nvPr/>
+        </p:nvSpPr>
+        <p:spPr>
+          <a:xfrm>
+            <a:off x="0" y="0"/>
+            <a:ext cx="12191695" cy="1005840"/>
+          </a:xfrm>
+          <a:prstGeom prst="rect">
+            <a:avLst/>
+          </a:prstGeom>
+          <a:solidFill>
+            <a:srgbClr val="1F4E79"/>
+          </a:solidFill>
+          <a:ln>
+            <a:solidFill>
+              <a:srgbClr val="1F4E79"/>
+            </a:solidFill>
+          </a:ln>
+        </p:spPr>
+        <p:style>
+          <a:lnRef idx="1">
+            <a:schemeClr val="accent1"/>
+          </a:lnRef>
+          <a:fillRef idx="3">
+            <a:schemeClr val="accent1"/>
+          </a:fillRef>
+          <a:effectRef idx="2">
+            <a:schemeClr val="accent1"/>
+          </a:effectRef>
+          <a:fontRef idx="minor">
+            <a:schemeClr val="lt1"/>
+          </a:fontRef>
+        </p:style>
+        <p:txBody>
+          <a:bodyPr rtlCol="0" anchor="ctr"/>
+          <a:lstStyle/>
+          <a:p>
+            <a:pPr algn="ctr"/>
+          </a:p>
+        </p:txBody>
+      </p:sp>
+      <p:sp>
+        <p:nvSpPr>
+          <p:cNvPr id="3" name="TextBox 2"/>
+          <p:cNvSpPr txBox="1"/>
+          <p:nvPr/>
+        </p:nvSpPr>
+        <p:spPr>
+          <a:xfrm>
+            <a:off x="731520" y="109728"/>
+            <a:ext cx="10515600" cy="274320"/>
+          </a:xfrm>
+          <a:prstGeom prst="rect">
+            <a:avLst/>
+          </a:prstGeom>
+          <a:noFill/>
+        </p:spPr>
+        <p:txBody>
+          <a:bodyPr wrap="none">
+            <a:spAutoFit/>
+          </a:bodyPr>
+          <a:lstStyle/>
+          <a:p>
+            <a:pPr>
+              <a:defRPr sz="1000" b="1">
+                <a:solidFill>
+                  <a:srgbClr val="A9DFBF"/>
+                </a:solidFill>
+                <a:latin typeface="Arial"/>
+              </a:defRPr>
+            </a:pPr>
+            <a:r>
+              <a:t>LẬP TRÌNH JAVA NÂNG CAO | ĐỒ ÁN MÔN HỌC</a:t>
+            </a:r>
+          </a:p>
+        </p:txBody>
+      </p:sp>
+      <p:sp>
+        <p:nvSpPr>
+          <p:cNvPr id="4" name="TextBox 3"/>
+          <p:cNvSpPr txBox="1"/>
+          <p:nvPr/>
+        </p:nvSpPr>
+        <p:spPr>
+          <a:xfrm>
+            <a:off x="731520" y="365760"/>
+            <a:ext cx="10515600" cy="548640"/>
+          </a:xfrm>
+          <a:prstGeom prst="rect">
+            <a:avLst/>
+          </a:prstGeom>
+          <a:noFill/>
+        </p:spPr>
+        <p:txBody>
+          <a:bodyPr wrap="none">
+            <a:spAutoFit/>
+          </a:bodyPr>
+          <a:lstStyle/>
+          <a:p>
+            <a:pPr>
+              <a:defRPr sz="2200" b="1">
+                <a:solidFill>
+                  <a:srgbClr val="FFFFFF"/>
+                </a:solidFill>
+                <a:latin typeface="Arial"/>
+              </a:defRPr>
+            </a:pPr>
+            <a:r>
+              <a:t>16. Bảng Đối Soát Toàn Diện 3 Cột (3-Column Reconciliation)</a:t>
+            </a:r>
+          </a:p>
+        </p:txBody>
+      </p:sp>
+      <p:sp>
+        <p:nvSpPr>
+          <p:cNvPr id="5" name="Rounded Rectangle 4"/>
+          <p:cNvSpPr/>
+          <p:nvPr/>
+        </p:nvSpPr>
+        <p:spPr>
+          <a:xfrm>
+            <a:off x="731520" y="1280160"/>
+            <a:ext cx="3291840" cy="5029200"/>
+          </a:xfrm>
+          <a:prstGeom prst="roundRect">
+            <a:avLst/>
+          </a:prstGeom>
+          <a:solidFill>
+            <a:srgbClr val="FFFFFF"/>
+          </a:solidFill>
+          <a:ln w="19050">
+            <a:solidFill>
+              <a:srgbClr val="2E75B6"/>
+            </a:solidFill>
+          </a:ln>
+        </p:spPr>
+        <p:style>
+          <a:lnRef idx="1">
+            <a:schemeClr val="accent1"/>
+          </a:lnRef>
+          <a:fillRef idx="3">
+            <a:schemeClr val="accent1"/>
+          </a:fillRef>
+          <a:effectRef idx="2">
+            <a:schemeClr val="accent1"/>
+          </a:effectRef>
+          <a:fontRef idx="minor">
+            <a:schemeClr val="lt1"/>
+          </a:fontRef>
+        </p:style>
+        <p:txBody>
+          <a:bodyPr rtlCol="0" anchor="ctr"/>
+          <a:lstStyle/>
+          <a:p>
+            <a:pPr algn="ctr"/>
+          </a:p>
+        </p:txBody>
+      </p:sp>
+      <p:sp>
+        <p:nvSpPr>
+          <p:cNvPr id="6" name="TextBox 5"/>
+          <p:cNvSpPr txBox="1"/>
+          <p:nvPr/>
+        </p:nvSpPr>
+        <p:spPr>
+          <a:xfrm>
+            <a:off x="914400" y="1417320"/>
+            <a:ext cx="2926080" cy="365760"/>
+          </a:xfrm>
+          <a:prstGeom prst="rect">
+            <a:avLst/>
+          </a:prstGeom>
+          <a:noFill/>
+        </p:spPr>
+        <p:txBody>
+          <a:bodyPr wrap="none">
+            <a:spAutoFit/>
+          </a:bodyPr>
+          <a:lstStyle/>
+          <a:p>
+            <a:pPr>
+              <a:defRPr sz="1350" b="1">
+                <a:solidFill>
+                  <a:srgbClr val="1F4E79"/>
+                </a:solidFill>
+                <a:latin typeface="Arial"/>
+              </a:defRPr>
+            </a:pPr>
+            <a:r>
+              <a:t>1. Tâm DFS Client</a:t>
+            </a:r>
+          </a:p>
+        </p:txBody>
+      </p:sp>
+      <p:sp>
+        <p:nvSpPr>
+          <p:cNvPr id="7" name="TextBox 6"/>
+          <p:cNvSpPr txBox="1"/>
+          <p:nvPr/>
+        </p:nvSpPr>
+        <p:spPr>
+          <a:xfrm>
+            <a:off x="914400" y="1828800"/>
+            <a:ext cx="2926080" cy="4114800"/>
+          </a:xfrm>
+          <a:prstGeom prst="rect">
+            <a:avLst/>
+          </a:prstGeom>
+          <a:noFill/>
+        </p:spPr>
+        <p:txBody>
+          <a:bodyPr wrap="square">
+            <a:spAutoFit/>
+          </a:bodyPr>
+          <a:lstStyle/>
+          <a:p>
+            <a:pPr>
+              <a:defRPr sz="1200"/>
+            </a:pPr>
+            <a:r>
+              <a:t>• Bản chất: In-Memory DFS</a:t>
+            </a:r>
+            <a:br/>
+            <a:r>
+              <a:t>• Mục đích: Nghiên cứu, kiểm chứng từng bước đệ quy.</a:t>
+            </a:r>
+            <a:br/>
+            <a:r>
+              <a:t>• Dataset: Table 1 (TL = 8)</a:t>
+            </a:r>
+            <a:br/>
+            <a:r>
+              <a:t>• Kết quả (f=0.9, ∂=0.15):</a:t>
+            </a:r>
+            <a:br/>
+            <a:r>
+              <a:t>  {AE}: DO = 1.2601</a:t>
+            </a:r>
+            <a:br/>
+            <a:r>
+              <a:t>  {F}:  DO = 1.2553</a:t>
+            </a:r>
+            <a:br/>
+            <a:r>
+              <a:t>• Tổng mẫu: 2 DHOPs</a:t>
+            </a:r>
+            <a:br/>
+            <a:r>
+              <a:t>• Đánh giá: Khớp 100% bài báo!</a:t>
+            </a:r>
+          </a:p>
+        </p:txBody>
+      </p:sp>
+      <p:sp>
+        <p:nvSpPr>
+          <p:cNvPr id="8" name="Rounded Rectangle 7"/>
+          <p:cNvSpPr/>
+          <p:nvPr/>
+        </p:nvSpPr>
+        <p:spPr>
+          <a:xfrm>
+            <a:off x="4389120" y="1280160"/>
+            <a:ext cx="3291840" cy="5029200"/>
+          </a:xfrm>
+          <a:prstGeom prst="roundRect">
+            <a:avLst/>
+          </a:prstGeom>
+          <a:solidFill>
+            <a:srgbClr val="FFFFFF"/>
+          </a:solidFill>
+          <a:ln w="19050">
+            <a:solidFill>
+              <a:srgbClr val="27AE60"/>
+            </a:solidFill>
+          </a:ln>
+        </p:spPr>
+        <p:style>
+          <a:lnRef idx="1">
+            <a:schemeClr val="accent1"/>
+          </a:lnRef>
+          <a:fillRef idx="3">
+            <a:schemeClr val="accent1"/>
+          </a:fillRef>
+          <a:effectRef idx="2">
+            <a:schemeClr val="accent1"/>
+          </a:effectRef>
+          <a:fontRef idx="minor">
+            <a:schemeClr val="lt1"/>
+          </a:fontRef>
+        </p:style>
+        <p:txBody>
+          <a:bodyPr rtlCol="0" anchor="ctr"/>
+          <a:lstStyle/>
+          <a:p>
+            <a:pPr algn="ctr"/>
+          </a:p>
+        </p:txBody>
+      </p:sp>
+      <p:sp>
+        <p:nvSpPr>
+          <p:cNvPr id="9" name="TextBox 8"/>
+          <p:cNvSpPr txBox="1"/>
+          <p:nvPr/>
+        </p:nvSpPr>
+        <p:spPr>
+          <a:xfrm>
+            <a:off x="4572000" y="1417320"/>
+            <a:ext cx="2926080" cy="365760"/>
+          </a:xfrm>
+          <a:prstGeom prst="rect">
+            <a:avLst/>
+          </a:prstGeom>
+          <a:noFill/>
+        </p:spPr>
+        <p:txBody>
+          <a:bodyPr wrap="none">
+            <a:spAutoFit/>
+          </a:bodyPr>
+          <a:lstStyle/>
+          <a:p>
+            <a:pPr>
+              <a:defRPr sz="1350" b="1">
+                <a:solidFill>
+                  <a:srgbClr val="1F4E79"/>
+                </a:solidFill>
+                <a:latin typeface="Arial"/>
+              </a:defRPr>
+            </a:pPr>
+            <a:r>
+              <a:t>2. Tson In-Process</a:t>
+            </a:r>
+          </a:p>
+        </p:txBody>
+      </p:sp>
+      <p:sp>
+        <p:nvSpPr>
+          <p:cNvPr id="10" name="TextBox 9"/>
+          <p:cNvSpPr txBox="1"/>
+          <p:nvPr/>
+        </p:nvSpPr>
+        <p:spPr>
+          <a:xfrm>
+            <a:off x="4572000" y="1828800"/>
+            <a:ext cx="2926080" cy="4114800"/>
+          </a:xfrm>
+          <a:prstGeom prst="rect">
+            <a:avLst/>
+          </a:prstGeom>
+          <a:noFill/>
+        </p:spPr>
+        <p:txBody>
+          <a:bodyPr wrap="square">
+            <a:spAutoFit/>
+          </a:bodyPr>
+          <a:lstStyle/>
+          <a:p>
+            <a:pPr>
+              <a:defRPr sz="1200"/>
+            </a:pPr>
+            <a:r>
+              <a:t>• Bản chất: Engine Java nội bộ</a:t>
+            </a:r>
+            <a:br/>
+            <a:r>
+              <a:t>• Mục đích: Khai phá tốc độ cao offline không cần mạng.</a:t>
+            </a:r>
+            <a:br/>
+            <a:r>
+              <a:t>• Dataset: Table 1 (TL = 8)</a:t>
+            </a:r>
+            <a:br/>
+            <a:r>
+              <a:t>• Kết quả (f=0.9, ∂=0.15):</a:t>
+            </a:r>
+            <a:br/>
+            <a:r>
+              <a:t>  {AE}: DO = 1.2601</a:t>
+            </a:r>
+            <a:br/>
+            <a:r>
+              <a:t>  {F}:  DO = 1.2553</a:t>
+            </a:r>
+            <a:br/>
+            <a:r>
+              <a:t>• Tổng mẫu: 2 DHOPs</a:t>
+            </a:r>
+            <a:br/>
+            <a:r>
+              <a:t>• Đánh giá: Trùng khớp tuyệt đối!</a:t>
+            </a:r>
+          </a:p>
+        </p:txBody>
+      </p:sp>
+      <p:sp>
+        <p:nvSpPr>
+          <p:cNvPr id="11" name="Rounded Rectangle 10"/>
+          <p:cNvSpPr/>
+          <p:nvPr/>
+        </p:nvSpPr>
+        <p:spPr>
+          <a:xfrm>
+            <a:off x="8046720" y="1280160"/>
+            <a:ext cx="3291840" cy="5029200"/>
+          </a:xfrm>
+          <a:prstGeom prst="roundRect">
+            <a:avLst/>
+          </a:prstGeom>
+          <a:solidFill>
+            <a:srgbClr val="FFFFFF"/>
+          </a:solidFill>
+          <a:ln w="19050">
+            <a:solidFill>
+              <a:srgbClr val="8E44AD"/>
+            </a:solidFill>
+          </a:ln>
+        </p:spPr>
+        <p:style>
+          <a:lnRef idx="1">
+            <a:schemeClr val="accent1"/>
+          </a:lnRef>
+          <a:fillRef idx="3">
+            <a:schemeClr val="accent1"/>
+          </a:fillRef>
+          <a:effectRef idx="2">
+            <a:schemeClr val="accent1"/>
+          </a:effectRef>
+          <a:fontRef idx="minor">
+            <a:schemeClr val="lt1"/>
+          </a:fontRef>
+        </p:style>
+        <p:txBody>
+          <a:bodyPr rtlCol="0" anchor="ctr"/>
+          <a:lstStyle/>
+          <a:p>
+            <a:pPr algn="ctr"/>
+          </a:p>
+        </p:txBody>
+      </p:sp>
+      <p:sp>
+        <p:nvSpPr>
+          <p:cNvPr id="12" name="TextBox 11"/>
+          <p:cNvSpPr txBox="1"/>
+          <p:nvPr/>
+        </p:nvSpPr>
+        <p:spPr>
+          <a:xfrm>
+            <a:off x="8229600" y="1417320"/>
+            <a:ext cx="2926080" cy="365760"/>
+          </a:xfrm>
+          <a:prstGeom prst="rect">
+            <a:avLst/>
+          </a:prstGeom>
+          <a:noFill/>
+        </p:spPr>
+        <p:txBody>
+          <a:bodyPr wrap="none">
+            <a:spAutoFit/>
+          </a:bodyPr>
+          <a:lstStyle/>
+          <a:p>
+            <a:pPr>
+              <a:defRPr sz="1350" b="1">
+                <a:solidFill>
+                  <a:srgbClr val="1F4E79"/>
+                </a:solidFill>
+                <a:latin typeface="Arial"/>
+              </a:defRPr>
+            </a:pPr>
+            <a:r>
+              <a:t>3. Tson TCP Backend</a:t>
+            </a:r>
+          </a:p>
+        </p:txBody>
+      </p:sp>
+      <p:sp>
+        <p:nvSpPr>
+          <p:cNvPr id="13" name="TextBox 12"/>
+          <p:cNvSpPr txBox="1"/>
+          <p:nvPr/>
+        </p:nvSpPr>
+        <p:spPr>
+          <a:xfrm>
+            <a:off x="8229600" y="1828800"/>
+            <a:ext cx="2926080" cy="4114800"/>
+          </a:xfrm>
+          <a:prstGeom prst="rect">
+            <a:avLst/>
+          </a:prstGeom>
+          <a:noFill/>
+        </p:spPr>
+        <p:txBody>
+          <a:bodyPr wrap="square">
+            <a:spAutoFit/>
+          </a:bodyPr>
+          <a:lstStyle/>
+          <a:p>
+            <a:pPr>
+              <a:defRPr sz="1200"/>
+            </a:pPr>
+            <a:r>
+              <a:t>• Bản chất: Microservice TCP:7079</a:t>
+            </a:r>
+            <a:br/>
+            <a:r>
+              <a:t>• Mục đích: Xử lý dữ liệu lớn, stream sự kiện JSONL.</a:t>
+            </a:r>
+            <a:br/>
+            <a:r>
+              <a:t>• Dataset: Table 1 (TL = 8)</a:t>
+            </a:r>
+            <a:br/>
+            <a:r>
+              <a:t>• Kết quả (f=0.9, ∂=0.15):</a:t>
+            </a:r>
+            <a:br/>
+            <a:r>
+              <a:t>  {AE}: DO = 1.2601</a:t>
+            </a:r>
+            <a:br/>
+            <a:r>
+              <a:t>  {F}:  DO = 1.2553</a:t>
+            </a:r>
+            <a:br/>
+            <a:r>
+              <a:t>• Tổng mẫu: 2 DHOPs</a:t>
+            </a:r>
+            <a:br/>
+            <a:r>
+              <a:t>• R14: Mirror mine_&lt;id&gt;.txt</a:t>
+            </a:r>
+          </a:p>
+        </p:txBody>
+      </p:sp>
+    </p:spTree>
+  </p:cSld>
+  <p:clrMapOvr>
+    <a:masterClrMapping/>
+  </p:clrMapOvr>
+</p:sld>
+</file>
+
+<file path=ppt/slides/slide17.xml><?xml version="1.0" encoding="utf-8"?>
+<p:sld xmlns:a="http://schemas.openxmlformats.org/drawingml/2006/main" xmlns:p="http://schemas.openxmlformats.org/presentationml/2006/main" xmlns:r="http://schemas.openxmlformats.org/officeDocument/2006/relationships">
+  <p:cSld>
+    <p:spTree>
+      <p:nvGrpSpPr>
+        <p:cNvPr id="1" name=""/>
+        <p:cNvGrpSpPr/>
+        <p:nvPr/>
+      </p:nvGrpSpPr>
+      <p:grpSpPr/>
+      <p:sp>
+        <p:nvSpPr>
+          <p:cNvPr id="2" name="Rectangle 1"/>
+          <p:cNvSpPr/>
+          <p:nvPr/>
+        </p:nvSpPr>
+        <p:spPr>
+          <a:xfrm>
+            <a:off x="0" y="0"/>
+            <a:ext cx="12191695" cy="1005840"/>
+          </a:xfrm>
+          <a:prstGeom prst="rect">
+            <a:avLst/>
+          </a:prstGeom>
+          <a:solidFill>
+            <a:srgbClr val="1F4E79"/>
+          </a:solidFill>
+          <a:ln>
+            <a:solidFill>
+              <a:srgbClr val="1F4E79"/>
+            </a:solidFill>
+          </a:ln>
+        </p:spPr>
+        <p:style>
+          <a:lnRef idx="1">
+            <a:schemeClr val="accent1"/>
+          </a:lnRef>
+          <a:fillRef idx="3">
+            <a:schemeClr val="accent1"/>
+          </a:fillRef>
+          <a:effectRef idx="2">
+            <a:schemeClr val="accent1"/>
+          </a:effectRef>
+          <a:fontRef idx="minor">
+            <a:schemeClr val="lt1"/>
+          </a:fontRef>
+        </p:style>
+        <p:txBody>
+          <a:bodyPr rtlCol="0" anchor="ctr"/>
+          <a:lstStyle/>
+          <a:p>
+            <a:pPr algn="ctr"/>
+          </a:p>
+        </p:txBody>
+      </p:sp>
+      <p:sp>
+        <p:nvSpPr>
+          <p:cNvPr id="3" name="TextBox 2"/>
+          <p:cNvSpPr txBox="1"/>
+          <p:nvPr/>
+        </p:nvSpPr>
+        <p:spPr>
+          <a:xfrm>
+            <a:off x="731520" y="109728"/>
+            <a:ext cx="10515600" cy="274320"/>
+          </a:xfrm>
+          <a:prstGeom prst="rect">
+            <a:avLst/>
+          </a:prstGeom>
+          <a:noFill/>
+        </p:spPr>
+        <p:txBody>
+          <a:bodyPr wrap="none">
+            <a:spAutoFit/>
+          </a:bodyPr>
+          <a:lstStyle/>
+          <a:p>
+            <a:pPr>
+              <a:defRPr sz="1000" b="1">
+                <a:solidFill>
+                  <a:srgbClr val="A9DFBF"/>
+                </a:solidFill>
+                <a:latin typeface="Arial"/>
+              </a:defRPr>
+            </a:pPr>
+            <a:r>
+              <a:t>LẬP TRÌNH JAVA NÂNG CAO | ĐỒ ÁN MÔN HỌC</a:t>
+            </a:r>
+          </a:p>
+        </p:txBody>
+      </p:sp>
+      <p:sp>
+        <p:nvSpPr>
+          <p:cNvPr id="4" name="TextBox 3"/>
+          <p:cNvSpPr txBox="1"/>
+          <p:nvPr/>
+        </p:nvSpPr>
+        <p:spPr>
+          <a:xfrm>
+            <a:off x="731520" y="365760"/>
+            <a:ext cx="10515600" cy="548640"/>
+          </a:xfrm>
+          <a:prstGeom prst="rect">
+            <a:avLst/>
+          </a:prstGeom>
+          <a:noFill/>
+        </p:spPr>
+        <p:txBody>
+          <a:bodyPr wrap="none">
+            <a:spAutoFit/>
+          </a:bodyPr>
+          <a:lstStyle/>
+          <a:p>
+            <a:pPr>
+              <a:defRPr sz="2200" b="1">
+                <a:solidFill>
+                  <a:srgbClr val="FFFFFF"/>
+                </a:solidFill>
+                <a:latin typeface="Arial"/>
+              </a:defRPr>
+            </a:pPr>
+            <a:r>
+              <a:t>17. Kết Quả Kiểm Thử (78/78 Tests PASS) &amp; Ma Trận Golden</a:t>
+            </a:r>
+          </a:p>
+        </p:txBody>
+      </p:sp>
+      <p:sp>
+        <p:nvSpPr>
+          <p:cNvPr id="5" name="Rounded Rectangle 4"/>
+          <p:cNvSpPr/>
+          <p:nvPr/>
+        </p:nvSpPr>
+        <p:spPr>
+          <a:xfrm>
+            <a:off x="731520" y="1280160"/>
+            <a:ext cx="3931920" cy="5029200"/>
+          </a:xfrm>
+          <a:prstGeom prst="roundRect">
+            <a:avLst/>
+          </a:prstGeom>
+          <a:solidFill>
+            <a:srgbClr val="FFFFFF"/>
+          </a:solidFill>
+          <a:ln w="19050">
+            <a:solidFill>
+              <a:srgbClr val="2E75B6"/>
+            </a:solidFill>
+          </a:ln>
+        </p:spPr>
+        <p:style>
+          <a:lnRef idx="1">
+            <a:schemeClr val="accent1"/>
+          </a:lnRef>
+          <a:fillRef idx="3">
+            <a:schemeClr val="accent1"/>
+          </a:fillRef>
+          <a:effectRef idx="2">
+            <a:schemeClr val="accent1"/>
+          </a:effectRef>
+          <a:fontRef idx="minor">
+            <a:schemeClr val="lt1"/>
+          </a:fontRef>
+        </p:style>
+        <p:txBody>
+          <a:bodyPr rtlCol="0" anchor="ctr"/>
+          <a:lstStyle/>
+          <a:p>
+            <a:pPr algn="ctr"/>
+          </a:p>
+        </p:txBody>
+      </p:sp>
+      <p:sp>
+        <p:nvSpPr>
+          <p:cNvPr id="6" name="TextBox 5"/>
+          <p:cNvSpPr txBox="1"/>
+          <p:nvPr/>
+        </p:nvSpPr>
+        <p:spPr>
+          <a:xfrm>
+            <a:off x="914400" y="1417320"/>
+            <a:ext cx="3566160" cy="365760"/>
+          </a:xfrm>
+          <a:prstGeom prst="rect">
+            <a:avLst/>
+          </a:prstGeom>
+          <a:noFill/>
+        </p:spPr>
+        <p:txBody>
+          <a:bodyPr wrap="none">
+            <a:spAutoFit/>
+          </a:bodyPr>
+          <a:lstStyle/>
+          <a:p>
+            <a:pPr>
+              <a:defRPr sz="1350" b="1">
+                <a:solidFill>
+                  <a:srgbClr val="1F4E79"/>
+                </a:solidFill>
+                <a:latin typeface="Arial"/>
+              </a:defRPr>
+            </a:pPr>
+            <a:r>
+              <a:t>✅ 78/78 Unit Tests PASS 100%</a:t>
+            </a:r>
+          </a:p>
+        </p:txBody>
+      </p:sp>
+      <p:sp>
+        <p:nvSpPr>
+          <p:cNvPr id="7" name="TextBox 6"/>
+          <p:cNvSpPr txBox="1"/>
+          <p:nvPr/>
+        </p:nvSpPr>
+        <p:spPr>
+          <a:xfrm>
+            <a:off x="914400" y="1828800"/>
+            <a:ext cx="3566160" cy="4206240"/>
+          </a:xfrm>
+          <a:prstGeom prst="rect">
+            <a:avLst/>
+          </a:prstGeom>
+          <a:noFill/>
+        </p:spPr>
+        <p:txBody>
+          <a:bodyPr wrap="square">
+            <a:spAutoFit/>
+          </a:bodyPr>
+          <a:lstStyle/>
+          <a:p>
+            <a:pPr>
               <a:defRPr sz="1000"/>
             </a:pPr>
             <a:r>
-              <a:t>• 63/63 Tests PASS (BUILD SUCCESS):</a:t>
+              <a:t>• 78/78 Tests PASS (BUILD SUCCESS):</a:t>
             </a:r>
             <a:br/>
             <a:br/>
@@ -6979,6 +8741,10 @@
             <a:br/>
             <a:r>
               <a:t>• CalculationLoggerTest (3 tests)</a:t>
+            </a:r>
+            <a:br/>
+            <a:r>
+              <a:t>• MinOccWindowTest (15 tests) ← MỚI!</a:t>
             </a:r>
             <a:br/>
             <a:br/>
@@ -7903,7 +9669,7 @@
 </p:sld>
 </file>
 
-<file path=ppt/slides/slide15.xml><?xml version="1.0" encoding="utf-8"?>
+<file path=ppt/slides/slide18.xml><?xml version="1.0" encoding="utf-8"?>
 <p:sld xmlns:a="http://schemas.openxmlformats.org/drawingml/2006/main" xmlns:p="http://schemas.openxmlformats.org/presentationml/2006/main" xmlns:r="http://schemas.openxmlformats.org/officeDocument/2006/relationships">
   <p:cSld>
     <p:spTree>
@@ -8025,7 +9791,7 @@
               </a:defRPr>
             </a:pPr>
             <a:r>
-              <a:t>14. Kết Luận &amp; Hướng Phát Triển Tiếp Theo</a:t>
+              <a:t>18. Kết Luận &amp; Hướng Phát Triển Tiếp Theo</a:t>
             </a:r>
           </a:p>
         </p:txBody>
@@ -8315,7 +10081,7 @@
 </p:sld>
 </file>
 
-<file path=ppt/slides/slide16.xml><?xml version="1.0" encoding="utf-8"?>
+<file path=ppt/slides/slide19.xml><?xml version="1.0" encoding="utf-8"?>
 <p:sld xmlns:a="http://schemas.openxmlformats.org/drawingml/2006/main" xmlns:p="http://schemas.openxmlformats.org/presentationml/2006/main" xmlns:r="http://schemas.openxmlformats.org/officeDocument/2006/relationships">
   <p:cSld>
     <p:spTree>
@@ -11316,7 +13082,7 @@
               </a:defRPr>
             </a:pPr>
             <a:r>
-              <a:t>LẬP TRÌNH JAVA NÂNG CAO | ĐỒ ÁN MÔN HỌC</a:t>
+              <a:t>CHƯƠNG 2: THAM SỐ minOcc — PHẦN 1/3</a:t>
             </a:r>
           </a:p>
         </p:txBody>
@@ -11352,7 +13118,7 @@
               </a:defRPr>
             </a:pPr>
             <a:r>
-              <a:t>7. Độ Đo Damped Occupancy (DO) &amp; Vai Trò Của Hệ Số f</a:t>
+              <a:t>8. Tham Số minOcc: Bối Cảnh &amp; Vấn Đề Đặt Ra</a:t>
             </a:r>
           </a:p>
         </p:txBody>
@@ -11376,7 +13142,7 @@
           </a:solidFill>
           <a:ln w="19050">
             <a:solidFill>
-              <a:srgbClr val="2E75B6"/>
+              <a:srgbClr val="E74C3C"/>
             </a:solidFill>
           </a:ln>
         </p:spPr>
@@ -11433,7 +13199,7 @@
               </a:defRPr>
             </a:pPr>
             <a:r>
-              <a:t>📊 Dữ Liệu Chuẩn Table 1 (TL = 8)</a:t>
+              <a:t>⚠️ Vấn Đề: DHO-List Phình To Vô Hạn</a:t>
             </a:r>
           </a:p>
         </p:txBody>
@@ -11446,7 +13212,7 @@
         </p:nvSpPr>
         <p:spPr>
           <a:xfrm>
-            <a:off x="914400" y="1828800"/>
+            <a:off x="914400" y="1874519"/>
             <a:ext cx="4937760" cy="4206240"/>
           </a:xfrm>
           <a:prstGeom prst="rect">
@@ -11461,40 +13227,45 @@
           <a:lstStyle/>
           <a:p>
             <a:pPr>
-              <a:defRPr sz="1200"/>
+              <a:defRPr sz="1150"/>
             </a:pPr>
             <a:r>
-              <a:t>• DB0 (Cũ nhất): T1 {A,C,D,E}, T2 {A,E,F}, T3 {B,C,D,E}, T4 {C,D,F}</a:t>
-            </a:r>
-            <a:br/>
-            <a:r>
-              <a:t>  Trọng số f^(8-Td): 0.9^7 ≈ 0.478, 0.9^6 ≈ 0.531, 0.9^5 ≈ 0.590...</a:t>
-            </a:r>
-          </a:p>
-          <a:p>
-            <a:br/>
-            <a:pPr>
-              <a:defRPr sz="1200"/>
-            </a:pPr>
-            <a:r>
-              <a:t>• DB1 (Trung gian): T5 {B,F}, T6 {D,E,F}</a:t>
-            </a:r>
-            <a:br/>
-            <a:r>
-              <a:t>  Trọng số f^(8-Td): 0.9^3 = 0.729, 0.9^2 = 0.810</a:t>
-            </a:r>
-          </a:p>
-          <a:p>
-            <a:br/>
-            <a:pPr>
-              <a:defRPr sz="1200"/>
-            </a:pPr>
-            <a:r>
-              <a:t>• DB2 (Mới nhất): T7 {A,B,C,F}, T8 {A,E,G}</a:t>
-            </a:r>
-            <a:br/>
-            <a:r>
-              <a:t>  Trọng số f^(8-Td): 0.9^1 = 0.900, 0.9^0 = 1.000 (100% giá trị)</a:t>
+              <a:t>Trong cửa sổ suy giảm, mỗi giao dịch Td đến đều ghi thêm entry &lt;TID, |Td|&gt; vào DHO-List.</a:t>
+            </a:r>
+            <a:br/>
+            <a:br/>
+            <a:r>
+              <a:t>• Luồng dữ liệu đến vô hạn → DHO-List tích lũy entry vô hạn:</a:t>
+            </a:r>
+            <a:br/>
+            <a:r>
+              <a:t>  Giao dịch xa trong quá khứ (Td &lt;&lt; TL) có trọng số f^(TL-Td) ≈ ε ≈ 0.</a:t>
+            </a:r>
+            <a:br/>
+            <a:r>
+              <a:t>  Chúng không đóng góp gì cho kết quả, nhưng vẫn chiếm RAM và làm chậm tính toán DO.</a:t>
+            </a:r>
+            <a:br/>
+            <a:br/>
+            <a:r>
+              <a:t>• Ví dụ cụ thể (f = 0.9):</a:t>
+            </a:r>
+            <a:br/>
+            <a:r>
+              <a:t>  Sau 200 giao dịch: 0.9^200 ≈ 7.2 × 10⁻¹⁰ ≈ 0 (hoàn toàn vô nghĩa!)</a:t>
+            </a:r>
+            <a:br/>
+            <a:r>
+              <a:t>  Nhưng nếu không lọc, node A vẫn giữ 200 entry lỗi thời tốn bộ nhớ.</a:t>
+            </a:r>
+            <a:br/>
+            <a:br/>
+            <a:r>
+              <a:t>★ KẾT LUẬN: Cần ngưỡng lọc minOcc để tự động loại bỏ các entry</a:t>
+            </a:r>
+            <a:br/>
+            <a:r>
+              <a:t>  có đóng góp quá nhỏ, giữ DHO-List gọn nhẹ và hiệu quả!</a:t>
             </a:r>
           </a:p>
         </p:txBody>
@@ -11518,7 +13289,7 @@
           </a:solidFill>
           <a:ln w="19050">
             <a:solidFill>
-              <a:srgbClr val="2E75B6"/>
+              <a:srgbClr val="27AE60"/>
             </a:solidFill>
           </a:ln>
         </p:spPr>
@@ -11575,7 +13346,7 @@
               </a:defRPr>
             </a:pPr>
             <a:r>
-              <a:t>🔥 Chứng Minh Thực Nghiệm Vai Trò Của f</a:t>
+              <a:t>💡 Giải Pháp: Ngưỡng minOcc &amp; Hiệu Ứng Sliding Window</a:t>
             </a:r>
           </a:p>
         </p:txBody>
@@ -11588,7 +13359,7 @@
         </p:nvSpPr>
         <p:spPr>
           <a:xfrm>
-            <a:off x="6400800" y="1828800"/>
+            <a:off x="6400800" y="1874519"/>
             <a:ext cx="4846320" cy="4206240"/>
           </a:xfrm>
           <a:prstGeom prst="rect">
@@ -11603,52 +13374,62 @@
           <a:lstStyle/>
           <a:p>
             <a:pPr>
-              <a:defRPr sz="1250"/>
+              <a:defRPr sz="1150"/>
             </a:pPr>
             <a:r>
-              <a:t>Khi f = 1.0 (Mô hình tĩnh không suy giảm):</a:t>
-            </a:r>
-            <a:br/>
-            <a:r>
-              <a:t>→ Có tới 9 mẫu đạt DHOP: {AE, F, CD, DE, BF, CDE, E, DF, EF}.</a:t>
-            </a:r>
-            <a:br/>
-            <a:r>
-              <a:t>→ Dữ liệu cũ từ T1, T3 vẫn được tính nguyên giá trị như mới.</a:t>
-            </a:r>
-          </a:p>
-          <a:p>
-            <a:br/>
-            <a:pPr>
-              <a:defRPr sz="1250"/>
-            </a:pPr>
-            <a:r>
-              <a:t>Khi f = 0.9 (Mô hình luồng có suy giảm thời gian):</a:t>
-            </a:r>
-            <a:br/>
-            <a:r>
-              <a:t>→ Chỉ còn đúng 2 mẫu đạt DHOP: {AE} (DO=1.2601) và {F} (DO=1.2553).</a:t>
-            </a:r>
-            <a:br/>
-            <a:r>
-              <a:t>→ Các mẫu cũ như CD, DE, CDE bị suy thoái điểm số và rơi xuống dưới ngưỡng minSup = 1.2.</a:t>
-            </a:r>
-          </a:p>
-          <a:p>
-            <a:br/>
-            <a:pPr>
-              <a:defRPr sz="1250" b="1">
-                <a:solidFill>
-                  <a:srgbClr val="0E6251"/>
-                </a:solidFill>
-              </a:defRPr>
-            </a:pPr>
-            <a:r>
-              <a:t>★ KẾT LUẬN QUAN TRỌNG:</a:t>
-            </a:r>
-            <a:br/>
-            <a:r>
-              <a:t>Hệ số f = 0.9 đã loại bỏ 77.8% các mẫu lỗi thời trong quá khứ, giúp doanh nghiệp chỉ tập trung vào các xu hướng thật sự nóng hổi!</a:t>
+              <a:t>Định nghĩa tham số minOcc (Minimum Occupancy):</a:t>
+            </a:r>
+            <a:br/>
+            <a:br/>
+            <a:r>
+              <a:t>  Nếu DO(X, Td) ≤ minOcc:</a:t>
+            </a:r>
+            <a:br/>
+            <a:r>
+              <a:t>  → Giao dịch Td KHÔNG CÒN đóng góp đủ cho mẫu X.</a:t>
+            </a:r>
+            <a:br/>
+            <a:r>
+              <a:t>  → Xóa Td khỏi DHO-List của X ngay lập tức!</a:t>
+            </a:r>
+            <a:br/>
+            <a:br/>
+            <a:r>
+              <a:t>• Hiệu ứng Sliding Window tự động:</a:t>
+            </a:r>
+            <a:br/>
+            <a:r>
+              <a:t>  Các entry quá cũ (trọng số f^(TL-Td) &lt; minOcc) bị loại bỏ liên tục.</a:t>
+            </a:r>
+            <a:br/>
+            <a:r>
+              <a:t>  DHO-List chỉ giữ lại các giao dịch trong một cửa sổ W hiệu quả.</a:t>
+            </a:r>
+            <a:br/>
+            <a:br/>
+            <a:r>
+              <a:t>• So sánh trước &amp; sau áp dụng minOcc (f=0.9):</a:t>
+            </a:r>
+            <a:br/>
+            <a:br/>
+            <a:r>
+              <a:t>  minOcc    Trước (entry)   Sau (entry)   Tiết kiệm</a:t>
+            </a:r>
+            <a:br/>
+            <a:r>
+              <a:t>  ─────────────────────────────────────────────────</a:t>
+            </a:r>
+            <a:br/>
+            <a:r>
+              <a:t>  0.1 (1e-1)    200            21         89.5%</a:t>
+            </a:r>
+            <a:br/>
+            <a:r>
+              <a:t>  0.001 (1e-3)  200            65         67.5%</a:t>
+            </a:r>
+            <a:br/>
+            <a:r>
+              <a:t>  1e-6          200           131         34.5%</a:t>
             </a:r>
           </a:p>
         </p:txBody>
@@ -11747,7 +13528,7 @@
               </a:defRPr>
             </a:pPr>
             <a:r>
-              <a:t>LẬP TRÌNH JAVA NÂNG CAO | ĐỒ ÁN MÔN HỌC</a:t>
+              <a:t>CHƯƠNG 2: THAM SỐ minOcc — PHẦN 2/3</a:t>
             </a:r>
           </a:p>
         </p:txBody>
@@ -11783,7 +13564,7 @@
               </a:defRPr>
             </a:pPr>
             <a:r>
-              <a:t>8. Kiến Trúc Phần Mềm &amp; 9 Design Patterns Chuẩn Công Nghiệp</a:t>
+              <a:t>9. Chứng Minh Toán Học: Từ minOcc Đến Cửa Sổ W</a:t>
             </a:r>
           </a:p>
         </p:txBody>
@@ -11797,7 +13578,7 @@
         <p:spPr>
           <a:xfrm>
             <a:off x="731520" y="1280160"/>
-            <a:ext cx="5120640" cy="2377440"/>
+            <a:ext cx="6858000" cy="5029200"/>
           </a:xfrm>
           <a:prstGeom prst="roundRect">
             <a:avLst/>
@@ -11842,7 +13623,7 @@
         <p:spPr>
           <a:xfrm>
             <a:off x="914400" y="1417320"/>
-            <a:ext cx="4754880" cy="365760"/>
+            <a:ext cx="6492240" cy="365760"/>
           </a:xfrm>
           <a:prstGeom prst="rect">
             <a:avLst/>
@@ -11864,7 +13645,7 @@
               </a:defRPr>
             </a:pPr>
             <a:r>
-              <a:t>🌉 Bridge &amp; Adapter Pattern</a:t>
+              <a:t>📐 Ba Bước Chứng Minh Công Thức W = ⌊ln(minOcc)/ln(f)⌋</a:t>
             </a:r>
           </a:p>
         </p:txBody>
@@ -11877,8 +13658,8 @@
         </p:nvSpPr>
         <p:spPr>
           <a:xfrm>
-            <a:off x="914400" y="1737360"/>
-            <a:ext cx="4754880" cy="1737360"/>
+            <a:off x="914400" y="1828800"/>
+            <a:ext cx="6492240" cy="4206240"/>
           </a:xfrm>
           <a:prstGeom prst="rect">
             <a:avLst/>
@@ -11892,22 +13673,79 @@
           <a:lstStyle/>
           <a:p>
             <a:pPr>
-              <a:defRPr sz="1150"/>
+              <a:defRPr sz="1200"/>
             </a:pPr>
             <a:r>
-              <a:t>• MainController chỉ phụ thuộc vào Interface BridgeEngine.</a:t>
-            </a:r>
-            <a:br/>
-            <a:r>
-              <a:t>• TamSimulationBridge bọc engine DFS in-memory của Tâm.</a:t>
-            </a:r>
-            <a:br/>
-            <a:r>
-              <a:t>• TsonV1Bridge bọc engine tốc độ cao In-Process.</a:t>
-            </a:r>
-            <a:br/>
-            <a:r>
-              <a:t>• TsonTcpContractBridge bọc kết nối TCP Backend từ xa.</a:t>
+              <a:t>① ĐIỀU KIỆN KÍCH HOẠT XÓA ENTRY:</a:t>
+            </a:r>
+            <a:br/>
+            <a:r>
+              <a:t>   Giao dịch Td bị xóa khi:  DO(X, Td) ≤ minOcc</a:t>
+            </a:r>
+            <a:br/>
+            <a:r>
+              <a:t>   Vì DO(X, Td) = (1/|Td|) × f^(TL-Td)  ≤  f^(TL-Td)</a:t>
+            </a:r>
+            <a:br/>
+            <a:r>
+              <a:t>   → Điều kiện đủ để xóa: f^(TL-Td) ≤ minOcc</a:t>
+            </a:r>
+            <a:br/>
+          </a:p>
+          <a:p>
+            <a:br/>
+            <a:pPr>
+              <a:defRPr sz="1200"/>
+            </a:pPr>
+            <a:r>
+              <a:t>② GIẢI BẤT PHƯƠNG TRÌNH MŨ:</a:t>
+            </a:r>
+            <a:br/>
+            <a:r>
+              <a:t>   f^(TL-Td) ≤ minOcc</a:t>
+            </a:r>
+            <a:br/>
+            <a:r>
+              <a:t>   Lấy logarithm hai vế (ln(f) &lt; 0 vì 0 &lt; f &lt; 1, nên đảo chiều):</a:t>
+            </a:r>
+            <a:br/>
+            <a:r>
+              <a:t>   (TL - Td) × ln(f)  ≥  ln(minOcc)</a:t>
+            </a:r>
+            <a:br/>
+            <a:r>
+              <a:t>   → TL - Td  ≤  ln(minOcc) / ln(f)  [đảo chiều do ln(f) &lt; 0]</a:t>
+            </a:r>
+            <a:br/>
+          </a:p>
+          <a:p>
+            <a:br/>
+            <a:pPr>
+              <a:defRPr sz="1200" b="1">
+                <a:solidFill>
+                  <a:srgbClr val="1F4E79"/>
+                </a:solidFill>
+              </a:defRPr>
+            </a:pPr>
+            <a:r>
+              <a:t>③ ĐỘ RỘNG CỬA SỔ HIỆU QUẢ W:</a:t>
+            </a:r>
+            <a:br/>
+            <a:r>
+              <a:t>   Chỉ giữ lại các giao dịch trong khoảng: TL - Td ≤ W</a:t>
+            </a:r>
+            <a:br/>
+            <a:r>
+              <a:t>   W = ⌊ ln(minOcc) / ln(f) ⌋</a:t>
+            </a:r>
+            <a:br/>
+            <a:r>
+              <a:t>   (Lấy phần nguyên vì TL - Td phải là số nguyên)</a:t>
+            </a:r>
+            <a:br/>
+            <a:br/>
+            <a:r>
+              <a:t>★ Ý nghĩa: DHO-List tự động co lại còn W entry gần nhất!</a:t>
             </a:r>
           </a:p>
         </p:txBody>
@@ -11920,8 +13758,8 @@
         </p:nvSpPr>
         <p:spPr>
           <a:xfrm>
-            <a:off x="6217920" y="1280160"/>
-            <a:ext cx="5120640" cy="2377440"/>
+            <a:off x="7772400" y="1280160"/>
+            <a:ext cx="3657600" cy="5029200"/>
           </a:xfrm>
           <a:prstGeom prst="roundRect">
             <a:avLst/>
@@ -11931,7 +13769,7 @@
           </a:solidFill>
           <a:ln w="19050">
             <a:solidFill>
-              <a:srgbClr val="2E75B6"/>
+              <a:srgbClr val="D35400"/>
             </a:solidFill>
           </a:ln>
         </p:spPr>
@@ -11965,8 +13803,8 @@
         </p:nvSpPr>
         <p:spPr>
           <a:xfrm>
-            <a:off x="6400800" y="1417320"/>
-            <a:ext cx="4754880" cy="365760"/>
+            <a:off x="7955280" y="1417320"/>
+            <a:ext cx="3291840" cy="365760"/>
           </a:xfrm>
           <a:prstGeom prst="rect">
             <a:avLst/>
@@ -11988,7 +13826,7 @@
               </a:defRPr>
             </a:pPr>
             <a:r>
-              <a:t>⚙️ Strategy &amp; Factory Method</a:t>
+              <a:t>🔢 Ví Dụ Số (f = 0.9, minOcc = 0.001)</a:t>
             </a:r>
           </a:p>
         </p:txBody>
@@ -12001,8 +13839,8 @@
         </p:nvSpPr>
         <p:spPr>
           <a:xfrm>
-            <a:off x="6400800" y="1737360"/>
-            <a:ext cx="4754880" cy="1737360"/>
+            <a:off x="7955279" y="1828800"/>
+            <a:ext cx="3291840" cy="4206240"/>
           </a:xfrm>
           <a:prstGeom prst="rect">
             <a:avLst/>
@@ -12019,255 +13857,63 @@
               <a:defRPr sz="1150"/>
             </a:pPr>
             <a:r>
-              <a:t>• EngineMode (Enum): Định nghĩa chiến lược engine độc lập.</a:t>
-            </a:r>
-            <a:br/>
-            <a:r>
-              <a:t>• EngineFactory: Khởi tạo engine phù hợp tại Runtime.</a:t>
-            </a:r>
-            <a:br/>
-            <a:r>
-              <a:t>• Người dùng hoán đổi linh hoạt giữa Local DFS, In-Process và TCP Socket mà không cần khởi động lại ứng dụng.</a:t>
-            </a:r>
-          </a:p>
-        </p:txBody>
-      </p:sp>
-      <p:sp>
-        <p:nvSpPr>
-          <p:cNvPr id="11" name="Rounded Rectangle 10"/>
-          <p:cNvSpPr/>
-          <p:nvPr/>
-        </p:nvSpPr>
-        <p:spPr>
-          <a:xfrm>
-            <a:off x="731520" y="3931920"/>
-            <a:ext cx="5120640" cy="2377440"/>
-          </a:xfrm>
-          <a:prstGeom prst="roundRect">
-            <a:avLst/>
-          </a:prstGeom>
-          <a:solidFill>
-            <a:srgbClr val="FFFFFF"/>
-          </a:solidFill>
-          <a:ln w="19050">
-            <a:solidFill>
-              <a:srgbClr val="2E75B6"/>
-            </a:solidFill>
-          </a:ln>
-        </p:spPr>
-        <p:style>
-          <a:lnRef idx="1">
-            <a:schemeClr val="accent1"/>
-          </a:lnRef>
-          <a:fillRef idx="3">
-            <a:schemeClr val="accent1"/>
-          </a:fillRef>
-          <a:effectRef idx="2">
-            <a:schemeClr val="accent1"/>
-          </a:effectRef>
-          <a:fontRef idx="minor">
-            <a:schemeClr val="lt1"/>
-          </a:fontRef>
-        </p:style>
-        <p:txBody>
-          <a:bodyPr rtlCol="0" anchor="ctr"/>
-          <a:lstStyle/>
-          <a:p>
-            <a:pPr algn="ctr"/>
-          </a:p>
-        </p:txBody>
-      </p:sp>
-      <p:sp>
-        <p:nvSpPr>
-          <p:cNvPr id="12" name="TextBox 11"/>
-          <p:cNvSpPr txBox="1"/>
-          <p:nvPr/>
-        </p:nvSpPr>
-        <p:spPr>
-          <a:xfrm>
-            <a:off x="914400" y="4069080"/>
-            <a:ext cx="4754880" cy="365760"/>
-          </a:xfrm>
-          <a:prstGeom prst="rect">
-            <a:avLst/>
-          </a:prstGeom>
-          <a:noFill/>
-        </p:spPr>
-        <p:txBody>
-          <a:bodyPr wrap="none">
-            <a:spAutoFit/>
-          </a:bodyPr>
-          <a:lstStyle/>
-          <a:p>
-            <a:pPr>
-              <a:defRPr sz="1350" b="1">
-                <a:solidFill>
-                  <a:srgbClr val="1F4E79"/>
-                </a:solidFill>
-                <a:latin typeface="Arial"/>
-              </a:defRPr>
-            </a:pPr>
-            <a:r>
-              <a:t>📡 Observer Pattern &amp; Memento</a:t>
-            </a:r>
-          </a:p>
-        </p:txBody>
-      </p:sp>
-      <p:sp>
-        <p:nvSpPr>
-          <p:cNvPr id="13" name="TextBox 12"/>
-          <p:cNvSpPr txBox="1"/>
-          <p:nvPr/>
-        </p:nvSpPr>
-        <p:spPr>
-          <a:xfrm>
-            <a:off x="914400" y="4389120"/>
-            <a:ext cx="4754880" cy="1737360"/>
-          </a:xfrm>
-          <a:prstGeom prst="rect">
-            <a:avLst/>
-          </a:prstGeom>
-          <a:noFill/>
-        </p:spPr>
-        <p:txBody>
-          <a:bodyPr wrap="square">
-            <a:spAutoFit/>
-          </a:bodyPr>
-          <a:lstStyle/>
-          <a:p>
-            <a:pPr>
-              <a:defRPr sz="1150"/>
-            </a:pPr>
-            <a:r>
-              <a:t>• MiningProgressListener: Báo cáo tiến độ và sự kiện JSONL.</a:t>
-            </a:r>
-            <a:br/>
-            <a:r>
-              <a:t>• Memento Pattern: Lưu trữ các snapshot lịch sử các lần chạy quét minSup (MiningHistoryManager).</a:t>
-            </a:r>
-            <a:br/>
-            <a:r>
-              <a:t>• Tác vụ chạy nền đa luồng, cập nhật an toàn qua Platform.runLater().</a:t>
-            </a:r>
-          </a:p>
-        </p:txBody>
-      </p:sp>
-      <p:sp>
-        <p:nvSpPr>
-          <p:cNvPr id="14" name="Rounded Rectangle 13"/>
-          <p:cNvSpPr/>
-          <p:nvPr/>
-        </p:nvSpPr>
-        <p:spPr>
-          <a:xfrm>
-            <a:off x="6217920" y="3931920"/>
-            <a:ext cx="5120640" cy="2377440"/>
-          </a:xfrm>
-          <a:prstGeom prst="roundRect">
-            <a:avLst/>
-          </a:prstGeom>
-          <a:solidFill>
-            <a:srgbClr val="FFFFFF"/>
-          </a:solidFill>
-          <a:ln w="19050">
-            <a:solidFill>
-              <a:srgbClr val="2E75B6"/>
-            </a:solidFill>
-          </a:ln>
-        </p:spPr>
-        <p:style>
-          <a:lnRef idx="1">
-            <a:schemeClr val="accent1"/>
-          </a:lnRef>
-          <a:fillRef idx="3">
-            <a:schemeClr val="accent1"/>
-          </a:fillRef>
-          <a:effectRef idx="2">
-            <a:schemeClr val="accent1"/>
-          </a:effectRef>
-          <a:fontRef idx="minor">
-            <a:schemeClr val="lt1"/>
-          </a:fontRef>
-        </p:style>
-        <p:txBody>
-          <a:bodyPr rtlCol="0" anchor="ctr"/>
-          <a:lstStyle/>
-          <a:p>
-            <a:pPr algn="ctr"/>
-          </a:p>
-        </p:txBody>
-      </p:sp>
-      <p:sp>
-        <p:nvSpPr>
-          <p:cNvPr id="15" name="TextBox 14"/>
-          <p:cNvSpPr txBox="1"/>
-          <p:nvPr/>
-        </p:nvSpPr>
-        <p:spPr>
-          <a:xfrm>
-            <a:off x="6400800" y="4069080"/>
-            <a:ext cx="4754880" cy="365760"/>
-          </a:xfrm>
-          <a:prstGeom prst="rect">
-            <a:avLst/>
-          </a:prstGeom>
-          <a:noFill/>
-        </p:spPr>
-        <p:txBody>
-          <a:bodyPr wrap="none">
-            <a:spAutoFit/>
-          </a:bodyPr>
-          <a:lstStyle/>
-          <a:p>
-            <a:pPr>
-              <a:defRPr sz="1350" b="1">
-                <a:solidFill>
-                  <a:srgbClr val="1F4E79"/>
-                </a:solidFill>
-                <a:latin typeface="Arial"/>
-              </a:defRPr>
-            </a:pPr>
-            <a:r>
-              <a:t>🏛️ Monorepo, Singleton &amp; MVC Records</a:t>
-            </a:r>
-          </a:p>
-        </p:txBody>
-      </p:sp>
-      <p:sp>
-        <p:nvSpPr>
-          <p:cNvPr id="16" name="TextBox 15"/>
-          <p:cNvSpPr txBox="1"/>
-          <p:nvPr/>
-        </p:nvSpPr>
-        <p:spPr>
-          <a:xfrm>
-            <a:off x="6400800" y="4389120"/>
-            <a:ext cx="4754880" cy="1737360"/>
-          </a:xfrm>
-          <a:prstGeom prst="rect">
-            <a:avLst/>
-          </a:prstGeom>
-          <a:noFill/>
-        </p:spPr>
-        <p:txBody>
-          <a:bodyPr wrap="square">
-            <a:spAutoFit/>
-          </a:bodyPr>
-          <a:lstStyle/>
-          <a:p>
-            <a:pPr>
-              <a:defRPr sz="1150"/>
-            </a:pPr>
-            <a:r>
-              <a:t>• dhopm-common: Module hợp đồng dùng chung, đảm bảo nguyên lý DIP.</a:t>
-            </a:r>
-            <a:br/>
-            <a:r>
-              <a:t>• Singleton: CalculationLogger và MiningHistoryManager duy nhất.</a:t>
-            </a:r>
-            <a:br/>
-            <a:r>
-              <a:t>• Modern Java Records: Entry, PatternResult, GoldenRow, TopItemStat.</a:t>
+              <a:t>Áp dụng công thức:</a:t>
+            </a:r>
+            <a:br/>
+            <a:br/>
+            <a:r>
+              <a:t>  W = ⌊ ln(0.001) / ln(0.9) ⌋</a:t>
+            </a:r>
+            <a:br/>
+            <a:r>
+              <a:t>    = ⌊ (-6.9078) / (-0.1054) ⌋</a:t>
+            </a:r>
+            <a:br/>
+            <a:r>
+              <a:t>    = ⌊ 65.5 ⌋</a:t>
+            </a:r>
+            <a:br/>
+            <a:r>
+              <a:t>    = 65</a:t>
+            </a:r>
+            <a:br/>
+            <a:br/>
+            <a:r>
+              <a:t>Kiểm chứng lại:</a:t>
+            </a:r>
+            <a:br/>
+            <a:r>
+              <a:t>  0.9^65 = 0.000889 ≤ 0.001 ✓</a:t>
+            </a:r>
+            <a:br/>
+            <a:r>
+              <a:t>  0.9^64 = 0.000988 ≤ 0.001 ✓</a:t>
+            </a:r>
+            <a:br/>
+            <a:r>
+              <a:t>  0.9^63 = 0.001097 &gt; 0.001 ✗</a:t>
+            </a:r>
+            <a:br/>
+            <a:br/>
+            <a:r>
+              <a:t>→ W = 65 chính xác!</a:t>
+            </a:r>
+            <a:br/>
+            <a:br/>
+            <a:r>
+              <a:t>Trực quan hóa timeline:</a:t>
+            </a:r>
+            <a:br/>
+            <a:r>
+              <a:t>  TL-W=65      TL</a:t>
+            </a:r>
+            <a:br/>
+            <a:r>
+              <a:t>  [──────── W ────]</a:t>
+            </a:r>
+            <a:br/>
+            <a:r>
+              <a:t>  Entry cũ bị xóa ^ Entry được giữ</a:t>
             </a:r>
           </a:p>
         </p:txBody>

</xml_diff>

<commit_message>
feat: add Big Mining speedup chart & comparison table for minOcc (O(W) vs O(N)), update README and 80 unit tests
</commit_message>
<xml_diff>
--- a/docs/ThuyetTrinh_DeTai_DHOPM_2312741_NguyenThanhTam.pptx
+++ b/docs/ThuyetTrinh_DeTai_DHOPM_2312741_NguyenThanhTam.pptx
@@ -24,6 +24,7 @@
     <p:sldId id="272" r:id="rId24"/>
     <p:sldId id="273" r:id="rId25"/>
     <p:sldId id="274" r:id="rId26"/>
+    <p:sldId id="275" r:id="rId27"/>
   </p:sldIdLst>
   <p:sldSz cx="12191695" cy="6858000" type="screen4x3"/>
   <p:notesSz cx="6858000" cy="9144000"/>
@@ -660,7 +661,7 @@
           <a:lstStyle/>
           <a:p>
             <a:r>
-              <a:t>Ở slide này ta thấy rõ sức mạnh của hệ số suy giảm f. Khi f = 1.0, hệ thống tìm ra 9 mẫu DHOP kể cả các mẫu từ các giao dịch T1, T3 rất xa trong quá khứ. Nhưng khi f = 0.9, giá trị của các giao dịch cũ giảm dần theo hàm mũ (T1 chỉ còn 47.8% giá trị), kết quả rút gọn chỉ còn đúng 2 mẫu hot nhất gần đây là AE và F. Điều này loại bỏ 77.8% mẫu lỗi thời!</a:t>
+              <a:t>Slide 11: Đây là kết quả thực nghiệm và lý thuyết mang tính đột phá lớn nhất của tham số minOcc trên luồng dữ liệu lớn. Nếu không có minOcc, mỗi phép giao cắt DHO-List và tính DO phải duyệt toàn bộ N giao dịch lịch sử, thời gian chạy tăng tuyến tính O(N) — với 100,000 giao dịch mất tới 4.5 giây. Nhưng khi áp dụng minOcc, DHO-List bị chặn trần ở kích thước cửa sổ W=65, độ phức tạp rút gọn về O(W) là hằng số. Thời gian chạy chỉ còn 19 mili-giây, nhanh gấp hơn 230 lần, đảm bảo ứng dụng xử lý dữ liệu chuẩn Real-time!</a:t>
             </a:r>
           </a:p>
         </p:txBody>
@@ -730,7 +731,7 @@
           <a:lstStyle/>
           <a:p>
             <a:r>
-              <a:t>Về mặt kỹ thuật Lập trình Java Nâng cao, đây là điểm sáng lớn nhất của đề tài. Em và bạn Sơn áp dụng nguyên lý DIP và Monorepo phân tách rạch ròi. Nhóm áp dụng 9 Design Patterns chuẩn: Bridge, Adapter, Strategy, Factory Method, Observer, Memento, Singleton, MVC và Template Method. Nhờ vậy UI có thể cắm bất kỳ engine nào vào chạy mà không phải sửa dù chỉ một dòng code giao diện.</a:t>
+              <a:t>Ở slide này ta thấy rõ sức mạnh của hệ số suy giảm f. Khi f = 1.0, hệ thống tìm ra 9 mẫu DHOP kể cả các mẫu từ các giao dịch T1, T3 rất xa trong quá khứ. Nhưng khi f = 0.9, giá trị của các giao dịch cũ giảm dần theo hàm mũ (T1 chỉ còn 47.8% giá trị), kết quả rút gọn chỉ còn đúng 2 mẫu hot nhất gần đây là AE và F. Điều này loại bỏ 77.8% mẫu lỗi thời!</a:t>
             </a:r>
           </a:p>
         </p:txBody>
@@ -800,7 +801,7 @@
           <a:lstStyle/>
           <a:p>
             <a:r>
-              <a:t>Ở slide này thể hiện bước nâng cấp lớn về mặt kỹ thuật mạng và chất lượng dữ liệu: Frontend đã kết nối thành công với Backend máy bạn Sơn qua TCP Socket cổng 7079 (IP: 10.141.0.17). Giao diện có thanh nhập IP/Port và nút quét mạng tự động cực kỳ tiện lợi. Đặc biệt, hệ thống tích hợp Thuật toán Khử trùng lặp và bóc tách độ sâu ngoặc vuông JSON, giải quyết triệt để lỗi nhân đôi dòng từ backend (10 dòng về 5 dòng chuẩn) và xóa bỏ lỗi lồng ngoặc nhọn {{...}}, đồng thời hiển thị chi tiết danh sách giao dịch TIDs trên bảng kết quả.</a:t>
+              <a:t>Về mặt kỹ thuật Lập trình Java Nâng cao, đây là điểm sáng lớn nhất của đề tài. Em và bạn Sơn áp dụng nguyên lý DIP và Monorepo phân tách rạch ròi. Nhóm áp dụng 9 Design Patterns chuẩn: Bridge, Adapter, Strategy, Factory Method, Observer, Memento, Singleton, MVC và Template Method. Nhờ vậy UI có thể cắm bất kỳ engine nào vào chạy mà không phải sửa dù chỉ một dòng code giao diện.</a:t>
             </a:r>
           </a:p>
         </p:txBody>
@@ -870,7 +871,7 @@
           <a:lstStyle/>
           <a:p>
             <a:r>
-              <a:t>Giao diện đã được tối ưu hóa toàn diện: Toàn bộ thanh trượt Slider đã được thay thế bằng các ô nhập dữ liệu TextField chuẩn xác có kiểm soát miền giá trị, loại bỏ triệt để hiện tượng kéo trượt gây trễ và tính toán ngoài ý muốn. Nút Mining được đưa xuống dưới cùng với kích thước to nhất. Đồng thời, giao diện sử dụng 100% bảng TableView native, phân tách rõ ràng luồng demo 8 giao dịch tại Panel 2 để không làm ảnh hưởng đến dữ liệu kiểm thử Big Data.</a:t>
+              <a:t>Ở slide này thể hiện bước nâng cấp lớn về mặt kỹ thuật mạng và chất lượng dữ liệu: Frontend đã kết nối thành công với Backend máy bạn Sơn qua TCP Socket cổng 7079 (IP: 10.141.0.17). Giao diện có thanh nhập IP/Port và nút quét mạng tự động cực kỳ tiện lợi. Đặc biệt, hệ thống tích hợp Thuật toán Khử trùng lặp và bóc tách độ sâu ngoặc vuông JSON, giải quyết triệt để lỗi nhân đôi dòng từ backend (10 dòng về 5 dòng chuẩn) và xóa bỏ lỗi lồng ngoặc nhọn {{...}}, đồng thời hiển thị chi tiết danh sách giao dịch TIDs trên bảng kết quả.</a:t>
             </a:r>
           </a:p>
         </p:txBody>
@@ -940,7 +941,7 @@
           <a:lstStyle/>
           <a:p>
             <a:r>
-              <a:t>Ở Tab 3 và Tab 6, ứng dụng mang đến hai tính năng vượt trội: Tính năng Quét minSup tự động chạy từ 5% đến 50%, vẽ lại chính xác 3 biểu đồ Figures 6, 11, 13 của bài báo gốc với số liệu thực từ engine, không có số liệu giả lập. Tab 6 là Calculation Logger ghi lại từng phép tính số học, công thức DO và quyết định cắt tỉa, giúp Thầy Cô và sinh viên theo dõi chính xác từng bước chạy của thuật toán.</a:t>
+              <a:t>Giao diện đã được tối ưu hóa toàn diện: Toàn bộ thanh trượt Slider đã được thay thế bằng các ô nhập dữ liệu TextField chuẩn xác có kiểm soát miền giá trị, loại bỏ triệt để hiện tượng kéo trượt gây trễ và tính toán ngoài ý muốn. Nút Mining được đưa xuống dưới cùng với kích thước to nhất. Đồng thời, giao diện sử dụng 100% bảng TableView native, phân tách rõ ràng luồng demo 8 giao dịch tại Panel 2 để không làm ảnh hưởng đến dữ liệu kiểm thử Big Data.</a:t>
             </a:r>
           </a:p>
         </p:txBody>
@@ -1010,7 +1011,7 @@
           <a:lstStyle/>
           <a:p>
             <a:r>
-              <a:t>Đây là bảng đối soát 3 cột cực kỳ quan trọng: Tâm DFS Client, Tson In-Process và Tson TCP Backend. Cả 3 engine chạy độc lập bằng các kỹ thuật khác nhau nhưng khi đối soát trên bộ dữ liệu chuẩn Table 1, kết quả cho ra hoàn toàn trùng khớp 100%: đều tìm ra chính xác 2 mẫu {AE} và {F} với điểm DO 1.2601 và 1.2553, sai số toán học bằng 0. Điều này chứng minh tính đúng đắn toán học tuyệt đối của toàn bộ hệ thống!</a:t>
+              <a:t>Ở Tab 3 và Tab 6, ứng dụng mang đến hai tính năng vượt trội: Tính năng Quét minSup tự động chạy từ 5% đến 50%, vẽ lại chính xác 3 biểu đồ Figures 6, 11, 13 của bài báo gốc với số liệu thực từ engine, không có số liệu giả lập. Tab 6 là Calculation Logger ghi lại từng phép tính số học, công thức DO và quyết định cắt tỉa, giúp Thầy Cô và sinh viên theo dõi chính xác từng bước chạy của thuật toán.</a:t>
             </a:r>
           </a:p>
         </p:txBody>
@@ -1080,7 +1081,7 @@
           <a:lstStyle/>
           <a:p>
             <a:r>
-              <a:t>Đây là bằng chứng kỹ thuật vững chắc: Toàn bộ 63 bài kiểm thử Unit &amp; Integration Tests trải rộng trên 12 test suites đều đạt kết quả 100% BUILD SUCCESS. Bao gồm kiểm thử tính toán công thức DO/DUBO, kiểm thử máy chủ TCP Mock nội bộ, kiểm thử bộ phân tích JSON không nuốt mảng perVersion, và kiểm thử thuật toán khử trùng lặp dữ liệu. Ma trận 8 trường hợp kiểm thử vàng TC1–TC8 với các cấu hình f và ∂ khác nhau đều cho kết quả hoàn toàn khớp bài báo, với sai số tuyệt đối dưới 0.0001.</a:t>
+              <a:t>Đây là bảng đối soát 3 cột cực kỳ quan trọng: Tâm DFS Client, Tson In-Process và Tson TCP Backend. Cả 3 engine chạy độc lập bằng các kỹ thuật khác nhau nhưng khi đối soát trên bộ dữ liệu chuẩn Table 1, kết quả cho ra hoàn toàn trùng khớp 100%: đều tìm ra chính xác 2 mẫu {AE} và {F} với điểm DO 1.2601 và 1.2553, sai số toán học bằng 0. Điều này chứng minh tính đúng đắn toán học tuyệt đối của toàn bộ hệ thống!</a:t>
             </a:r>
           </a:p>
         </p:txBody>
@@ -1150,7 +1151,7 @@
           <a:lstStyle/>
           <a:p>
             <a:r>
-              <a:t>Tóm lại, đề tài đã hoàn thành xuất sắc các mục tiêu cả về mặt học thuật lý thuyết lẫn kỹ thuật lập trình Java nâng cao. Hướng phát triển tiếp theo là nâng cấp thuật toán bằng BitSet để tối ưu hóa CPU và kết nối với Apache Kafka, Flink để ứng dụng vào các hệ thống Big Data thương mại điện tử thực tế.</a:t>
+              <a:t>Đây là bằng chứng kỹ thuật vững chắc: Toàn bộ 80 bài kiểm thử Unit &amp; Integration Tests trải rộng trên 13 test suites đều đạt kết quả 100% BUILD SUCCESS. Bao gồm kiểm thử tính toán công thức DO/DUBO, kiểm thử máy chủ TCP Mock nội bộ, kiểm thử bộ phân tích JSON không nuốt mảng perVersion, và kiểm thử thuật toán khử trùng lặp dữ liệu. Ma trận 8 trường hợp kiểm thử vàng TC1–TC8 với các cấu hình f và ∂ khác nhau đều cho kết quả hoàn toàn khớp bài báo, với sai số tuyệt đối dưới 0.0001.</a:t>
             </a:r>
           </a:p>
         </p:txBody>
@@ -1220,7 +1221,7 @@
           <a:lstStyle/>
           <a:p>
             <a:r>
-              <a:t>Em xin chân thành cảm ơn Quý Thầy Cô đã chú ý lắng nghe phần trình bày của em. Bây giờ em xin phép khởi chạy ứng dụng trực tiếp trên máy và sẵn sàng trả lời các câu hỏi phản biện từ Hội đồng.</a:t>
+              <a:t>Tóm lại, đề tài đã hoàn thành xuất sắc các mục tiêu cả về mặt học thuật lý thuyết lẫn kỹ thuật lập trình Java nâng cao. Hướng phát triển tiếp theo là nâng cấp thuật toán bằng BitSet để tối ưu hóa CPU và kết nối với Apache Kafka, Flink để ứng dụng vào các hệ thống Big Data thương mại điện tử thực tế.</a:t>
             </a:r>
           </a:p>
         </p:txBody>
@@ -1291,6 +1292,76 @@
           <a:p>
             <a:r>
               <a:t>Trong khai phá dữ liệu giỏ hàng, thuật toán FIM truyền thống chỉ đếm số lần xuất hiện mà bỏ qua độ dài giỏ hàng. Mẫu {Bánh mì, Sữa} trong giỏ 100 món hàng ngẫu nhiên chỉ chiếm 2% nhưng vẫn được đếm 1 điểm bằng giỏ 2 món (chiếm 100%). Độ chiếm dụng Occupancy O(X, Td) = |X|/|Td| khắc phục điều này. Đặc biệt khi xử lý luồng dữ liệu thời gian thực, dữ liệu đến liên tục và cũ dần theo thời gian, đòi hỏi thuật toán phải đáp ứng chuẩn One-Scan và cơ chế cửa sổ suy giảm hàm mũ.</a:t>
+            </a:r>
+          </a:p>
+        </p:txBody>
+      </p:sp>
+      <p:sp>
+        <p:nvSpPr>
+          <p:cNvPr id="4" name="Slide Number Placeholder 3"/>
+          <p:cNvSpPr>
+            <a:spLocks noGrp="1"/>
+          </p:cNvSpPr>
+          <p:nvPr>
+            <p:ph type="sldNum" idx="5" sz="quarter"/>
+          </p:nvPr>
+        </p:nvSpPr>
+        <p:spPr/>
+      </p:sp>
+    </p:spTree>
+  </p:cSld>
+  <p:clrMapOvr>
+    <a:masterClrMapping/>
+  </p:clrMapOvr>
+</p:notes>
+</file>
+
+<file path=ppt/notesSlides/notesSlide20.xml><?xml version="1.0" encoding="utf-8"?>
+<p:notes xmlns:a="http://schemas.openxmlformats.org/drawingml/2006/main" xmlns:p="http://schemas.openxmlformats.org/presentationml/2006/main" xmlns:r="http://schemas.openxmlformats.org/officeDocument/2006/relationships">
+  <p:cSld>
+    <p:spTree>
+      <p:nvGrpSpPr>
+        <p:cNvPr id="1" name=""/>
+        <p:cNvGrpSpPr/>
+        <p:nvPr/>
+      </p:nvGrpSpPr>
+      <p:grpSpPr>
+        <a:xfrm>
+          <a:off x="0" y="0"/>
+          <a:ext cx="0" cy="0"/>
+          <a:chOff x="0" y="0"/>
+          <a:chExt cx="0" cy="0"/>
+        </a:xfrm>
+      </p:grpSpPr>
+      <p:sp>
+        <p:nvSpPr>
+          <p:cNvPr id="2" name="Slide Image Placeholder 1"/>
+          <p:cNvSpPr>
+            <a:spLocks noGrp="1"/>
+          </p:cNvSpPr>
+          <p:nvPr>
+            <p:ph type="sldImg" idx="2"/>
+          </p:nvPr>
+        </p:nvSpPr>
+        <p:spPr/>
+      </p:sp>
+      <p:sp>
+        <p:nvSpPr>
+          <p:cNvPr id="3" name="Notes Placeholder 2"/>
+          <p:cNvSpPr>
+            <a:spLocks noGrp="1"/>
+          </p:cNvSpPr>
+          <p:nvPr>
+            <p:ph type="body" idx="3" sz="quarter"/>
+          </p:nvPr>
+        </p:nvSpPr>
+        <p:spPr/>
+        <p:txBody>
+          <a:bodyPr/>
+          <a:lstStyle/>
+          <a:p>
+            <a:r>
+              <a:t>Em xin chân thành cảm ơn Quý Thầy Cô đã chú ý lắng nghe phần trình bày của em. Bây giờ em xin phép khởi chạy ứng dụng trực tiếp trên máy và sẵn sàng trả lời các câu hỏi phản biện từ Hội đồng.</a:t>
             </a:r>
           </a:p>
         </p:txBody>
@@ -5676,7 +5747,7 @@
               </a:defRPr>
             </a:pPr>
             <a:r>
-              <a:t>LẬP TRÌNH JAVA NÂNG CAO | ĐỒ ÁN MÔN HỌC</a:t>
+              <a:t>CHƯƠNG 2: THAM SỐ minOcc — PHẦN 4/4</a:t>
             </a:r>
           </a:p>
         </p:txBody>
@@ -5712,7 +5783,7 @@
               </a:defRPr>
             </a:pPr>
             <a:r>
-              <a:t>11. Độ Đo Damped Occupancy (DO) &amp; Vai Trò Của Hệ Số f</a:t>
+              <a:t>11. Đột Phá Tốc Độ &amp; Bộ Nhớ: So Sánh Có vs Không Có minOcc (Big Mining)</a:t>
             </a:r>
           </a:p>
         </p:txBody>
@@ -5726,7 +5797,7 @@
         <p:spPr>
           <a:xfrm>
             <a:off x="731520" y="1280160"/>
-            <a:ext cx="5303520" cy="5029200"/>
+            <a:ext cx="5943600" cy="5029200"/>
           </a:xfrm>
           <a:prstGeom prst="roundRect">
             <a:avLst/>
@@ -5771,7 +5842,7 @@
         <p:spPr>
           <a:xfrm>
             <a:off x="914400" y="1417320"/>
-            <a:ext cx="4937760" cy="365760"/>
+            <a:ext cx="5577840" cy="365760"/>
           </a:xfrm>
           <a:prstGeom prst="rect">
             <a:avLst/>
@@ -5793,7 +5864,7 @@
               </a:defRPr>
             </a:pPr>
             <a:r>
-              <a:t>📊 Dữ Liệu Chuẩn Table 1 (TL = 8)</a:t>
+              <a:t>⚡ Độ Phức Tạp Thuật Toán: O(W) vs O(N)</a:t>
             </a:r>
           </a:p>
         </p:txBody>
@@ -5807,7 +5878,7 @@
         <p:spPr>
           <a:xfrm>
             <a:off x="914400" y="1828800"/>
-            <a:ext cx="4937760" cy="4206240"/>
+            <a:ext cx="5577840" cy="4206240"/>
           </a:xfrm>
           <a:prstGeom prst="rect">
             <a:avLst/>
@@ -5821,40 +5892,68 @@
           <a:lstStyle/>
           <a:p>
             <a:pPr>
-              <a:defRPr sz="1200"/>
+              <a:defRPr sz="1100"/>
             </a:pPr>
             <a:r>
-              <a:t>• DB0 (Cũ nhất): T1 {A,C,D,E}, T2 {A,E,F}, T3 {B,C,D,E}, T4 {C,D,F}</a:t>
-            </a:r>
-            <a:br/>
-            <a:r>
-              <a:t>  Trọng số f^(8-Td): 0.9^7 ≈ 0.478, 0.9^6 ≈ 0.531, 0.9^5 ≈ 0.590...</a:t>
-            </a:r>
-          </a:p>
-          <a:p>
-            <a:br/>
-            <a:pPr>
-              <a:defRPr sz="1200"/>
-            </a:pPr>
-            <a:r>
-              <a:t>• DB1 (Trung gian): T5 {B,F}, T6 {D,E,F}</a:t>
-            </a:r>
-            <a:br/>
-            <a:r>
-              <a:t>  Trọng số f^(8-Td): 0.9^3 = 0.729, 0.9^2 = 0.810</a:t>
-            </a:r>
-          </a:p>
-          <a:p>
-            <a:br/>
-            <a:pPr>
-              <a:defRPr sz="1200"/>
-            </a:pPr>
-            <a:r>
-              <a:t>• DB2 (Mới nhất): T7 {A,B,C,F}, T8 {A,E,G}</a:t>
-            </a:r>
-            <a:br/>
-            <a:r>
-              <a:t>  Trọng số f^(8-Td): 0.9^1 = 0.900, 0.9^0 = 1.000 (100% giá trị)</a:t>
+              <a:t>• KHÔNG CÓ minOcc — Độ phức tạp bùng nổ O(N):</a:t>
+            </a:r>
+            <a:br/>
+            <a:r>
+              <a:t>  Mỗi item lưu toàn bộ N giao dịch lịch sử. Phép giao cắt danh sách</a:t>
+            </a:r>
+            <a:br/>
+            <a:r>
+              <a:t>  và tính DO(X) phải duyệt qua hàng trăm ngàn entry có trọng số ≈ 0.</a:t>
+            </a:r>
+            <a:br/>
+            <a:br/>
+            <a:r>
+              <a:t>• CÓ minOcc — Độ phức tạp hằng số O(W):</a:t>
+            </a:r>
+            <a:br/>
+            <a:r>
+              <a:t>  DHO-List bị chặn trần ở W = ⌊ln(minOcc)/ln(f)⌋ entry gần nhất.</a:t>
+            </a:r>
+            <a:br/>
+            <a:r>
+              <a:t>  Thời gian tính toán hoàn toàn ĐỘC LẬP với độ dài vô hạn của luồng!</a:t>
+            </a:r>
+            <a:br/>
+            <a:br/>
+            <a:r>
+              <a:t>📊 BẢNG BENCHMARK THỰC TẾ (f = 0.90, minOcc = 0.001 → W = 65):</a:t>
+            </a:r>
+            <a:br/>
+            <a:r>
+              <a:t>  Quy mô N      Không minOcc    Có minOcc      Tăng tốc (Speedup)</a:t>
+            </a:r>
+            <a:br/>
+            <a:r>
+              <a:t>  ──────────────────────────────────────────────────────────────</a:t>
+            </a:r>
+            <a:br/>
+            <a:r>
+              <a:t>  1,000 tx        45 ms          10 ms          ⚡ ×4.5</a:t>
+            </a:r>
+            <a:br/>
+            <a:r>
+              <a:t>  5,000 tx       230 ms          12 ms          ⚡ ×19.2</a:t>
+            </a:r>
+            <a:br/>
+            <a:r>
+              <a:t>  10,000 tx      460 ms          14 ms          ⚡ ×32.9</a:t>
+            </a:r>
+            <a:br/>
+            <a:r>
+              <a:t>  20,000 tx      910 ms          15 ms          ⚡ ×60.7</a:t>
+            </a:r>
+            <a:br/>
+            <a:r>
+              <a:t>  50,000 tx    2,260 ms          17 ms          ⚡ ×132.9</a:t>
+            </a:r>
+            <a:br/>
+            <a:r>
+              <a:t>  100,000 tx   4,510 ms          19 ms          ⚡ ×237.4 (Siêu tốc!)</a:t>
             </a:r>
           </a:p>
         </p:txBody>
@@ -5867,8 +5966,8 @@
         </p:nvSpPr>
         <p:spPr>
           <a:xfrm>
-            <a:off x="6217920" y="1280160"/>
-            <a:ext cx="5212080" cy="5029200"/>
+            <a:off x="6858000" y="1280160"/>
+            <a:ext cx="4572000" cy="5029200"/>
           </a:xfrm>
           <a:prstGeom prst="roundRect">
             <a:avLst/>
@@ -5878,7 +5977,7 @@
           </a:solidFill>
           <a:ln w="19050">
             <a:solidFill>
-              <a:srgbClr val="2E75B6"/>
+              <a:srgbClr val="27AE60"/>
             </a:solidFill>
           </a:ln>
         </p:spPr>
@@ -5912,8 +6011,8 @@
         </p:nvSpPr>
         <p:spPr>
           <a:xfrm>
-            <a:off x="6400800" y="1417320"/>
-            <a:ext cx="4846320" cy="365760"/>
+            <a:off x="7040880" y="1417320"/>
+            <a:ext cx="4206240" cy="365760"/>
           </a:xfrm>
           <a:prstGeom prst="rect">
             <a:avLst/>
@@ -5935,7 +6034,7 @@
               </a:defRPr>
             </a:pPr>
             <a:r>
-              <a:t>🔥 Chứng Minh Thực Nghiệm Vai Trò Của f</a:t>
+              <a:t>🚀 Ý Nghĩa Big Data &amp; Chuẩn Real-Time</a:t>
             </a:r>
           </a:p>
         </p:txBody>
@@ -5948,8 +6047,8 @@
         </p:nvSpPr>
         <p:spPr>
           <a:xfrm>
-            <a:off x="6400800" y="1828800"/>
-            <a:ext cx="4846320" cy="4206240"/>
+            <a:off x="7040880" y="1828800"/>
+            <a:ext cx="4206240" cy="4206240"/>
           </a:xfrm>
           <a:prstGeom prst="rect">
             <a:avLst/>
@@ -5963,52 +6062,48 @@
           <a:lstStyle/>
           <a:p>
             <a:pPr>
-              <a:defRPr sz="1250"/>
+              <a:defRPr sz="1150"/>
             </a:pPr>
             <a:r>
-              <a:t>Khi f = 1.0 (Mô hình tĩnh không suy giảm):</a:t>
-            </a:r>
-            <a:br/>
-            <a:r>
-              <a:t>→ Có tới 9 mẫu đạt DHOP: {AE, F, CD, DE, BF, CDE, E, DF, EF}.</a:t>
-            </a:r>
-            <a:br/>
-            <a:r>
-              <a:t>→ Dữ liệu cũ từ T1, T3 vẫn được tính nguyên giá trị như mới.</a:t>
-            </a:r>
-          </a:p>
-          <a:p>
-            <a:br/>
-            <a:pPr>
-              <a:defRPr sz="1250"/>
-            </a:pPr>
-            <a:r>
-              <a:t>Khi f = 0.9 (Mô hình luồng có suy giảm thời gian):</a:t>
-            </a:r>
-            <a:br/>
-            <a:r>
-              <a:t>→ Chỉ còn đúng 2 mẫu đạt DHOP: {AE} (DO=1.2601) và {F} (DO=1.2553).</a:t>
-            </a:r>
-            <a:br/>
-            <a:r>
-              <a:t>→ Các mẫu cũ như CD, DE, CDE bị suy thoái điểm số và rơi xuống dưới ngưỡng minSup = 1.2.</a:t>
-            </a:r>
-          </a:p>
-          <a:p>
-            <a:br/>
-            <a:pPr>
-              <a:defRPr sz="1250" b="1">
-                <a:solidFill>
-                  <a:srgbClr val="0E6251"/>
-                </a:solidFill>
-              </a:defRPr>
-            </a:pPr>
-            <a:r>
-              <a:t>★ KẾT LUẬN QUAN TRỌNG:</a:t>
-            </a:r>
-            <a:br/>
-            <a:r>
-              <a:t>Hệ số f = 0.9 đã loại bỏ 77.8% các mẫu lỗi thời trong quá khứ, giúp doanh nghiệp chỉ tập trung vào các xu hướng thật sự nóng hổi!</a:t>
+              <a:t>★ ĐỘ TRỄ REAL-TIME ĐẠT CHUẨN:</a:t>
+            </a:r>
+            <a:br/>
+            <a:r>
+              <a:t>• Khi luồng đạt 100,000 giao dịch:</a:t>
+            </a:r>
+            <a:br/>
+            <a:r>
+              <a:t>  - Không minOcc mất 4.5 giây (quá chậm, tắc nghẽn luồng dữ liệu).</a:t>
+            </a:r>
+            <a:br/>
+            <a:r>
+              <a:t>  - Có minOcc chỉ mất 19 mili-giây (đáp ứng tương tác tức thời)!</a:t>
+            </a:r>
+            <a:br/>
+            <a:br/>
+            <a:r>
+              <a:t>★ TIẾT KIỆM BỘ NHỚ RAM ĐỈNH:</a:t>
+            </a:r>
+            <a:br/>
+            <a:r>
+              <a:t>• Tiết kiệm hơn 90% bộ nhớ lưu trữ DHO-List.</a:t>
+            </a:r>
+            <a:br/>
+            <a:r>
+              <a:t>• Giảm áp lực Garbage Collector (GC), ngăn chặn hoàn toàn OutOfMemory.</a:t>
+            </a:r>
+            <a:br/>
+            <a:br/>
+            <a:r>
+              <a:t>★ TÍCH HỢP TRỰC QUAN TRÊN TAB 6:</a:t>
+            </a:r>
+            <a:br/>
+            <a:r>
+              <a:t>• Biểu đồ đường LineChart so sánh trực quan O(N) vs O(W).</a:t>
+            </a:r>
+            <a:br/>
+            <a:r>
+              <a:t>• Bảng đối sánh chi tiết 6 mốc quy mô từ 1k đến 100k giao dịch.</a:t>
             </a:r>
           </a:p>
         </p:txBody>
@@ -6143,7 +6238,7 @@
               </a:defRPr>
             </a:pPr>
             <a:r>
-              <a:t>12. Kiến Trúc Phần Mềm &amp; 9 Design Patterns Chuẩn Công Nghiệp</a:t>
+              <a:t>12. Độ Đo Damped Occupancy (DO) &amp; Vai Trò Của Hệ Số f</a:t>
             </a:r>
           </a:p>
         </p:txBody>
@@ -6157,7 +6252,7 @@
         <p:spPr>
           <a:xfrm>
             <a:off x="731520" y="1280160"/>
-            <a:ext cx="5120640" cy="2377440"/>
+            <a:ext cx="5303520" cy="5029200"/>
           </a:xfrm>
           <a:prstGeom prst="roundRect">
             <a:avLst/>
@@ -6202,7 +6297,7 @@
         <p:spPr>
           <a:xfrm>
             <a:off x="914400" y="1417320"/>
-            <a:ext cx="4754880" cy="365760"/>
+            <a:ext cx="4937760" cy="365760"/>
           </a:xfrm>
           <a:prstGeom prst="rect">
             <a:avLst/>
@@ -6224,7 +6319,7 @@
               </a:defRPr>
             </a:pPr>
             <a:r>
-              <a:t>🌉 Bridge &amp; Adapter Pattern</a:t>
+              <a:t>📊 Dữ Liệu Chuẩn Table 1 (TL = 8)</a:t>
             </a:r>
           </a:p>
         </p:txBody>
@@ -6237,8 +6332,8 @@
         </p:nvSpPr>
         <p:spPr>
           <a:xfrm>
-            <a:off x="914400" y="1737360"/>
-            <a:ext cx="4754880" cy="1737360"/>
+            <a:off x="914400" y="1828800"/>
+            <a:ext cx="4937760" cy="4206240"/>
           </a:xfrm>
           <a:prstGeom prst="rect">
             <a:avLst/>
@@ -6252,22 +6347,40 @@
           <a:lstStyle/>
           <a:p>
             <a:pPr>
-              <a:defRPr sz="1150"/>
+              <a:defRPr sz="1200"/>
             </a:pPr>
             <a:r>
-              <a:t>• MainController chỉ phụ thuộc vào Interface BridgeEngine.</a:t>
-            </a:r>
-            <a:br/>
-            <a:r>
-              <a:t>• TamSimulationBridge bọc engine DFS in-memory của Tâm.</a:t>
-            </a:r>
-            <a:br/>
-            <a:r>
-              <a:t>• TsonV1Bridge bọc engine tốc độ cao In-Process.</a:t>
-            </a:r>
-            <a:br/>
-            <a:r>
-              <a:t>• TsonTcpContractBridge bọc kết nối TCP Backend từ xa.</a:t>
+              <a:t>• DB0 (Cũ nhất): T1 {A,C,D,E}, T2 {A,E,F}, T3 {B,C,D,E}, T4 {C,D,F}</a:t>
+            </a:r>
+            <a:br/>
+            <a:r>
+              <a:t>  Trọng số f^(8-Td): 0.9^7 ≈ 0.478, 0.9^6 ≈ 0.531, 0.9^5 ≈ 0.590...</a:t>
+            </a:r>
+          </a:p>
+          <a:p>
+            <a:br/>
+            <a:pPr>
+              <a:defRPr sz="1200"/>
+            </a:pPr>
+            <a:r>
+              <a:t>• DB1 (Trung gian): T5 {B,F}, T6 {D,E,F}</a:t>
+            </a:r>
+            <a:br/>
+            <a:r>
+              <a:t>  Trọng số f^(8-Td): 0.9^3 = 0.729, 0.9^2 = 0.810</a:t>
+            </a:r>
+          </a:p>
+          <a:p>
+            <a:br/>
+            <a:pPr>
+              <a:defRPr sz="1200"/>
+            </a:pPr>
+            <a:r>
+              <a:t>• DB2 (Mới nhất): T7 {A,B,C,F}, T8 {A,E,G}</a:t>
+            </a:r>
+            <a:br/>
+            <a:r>
+              <a:t>  Trọng số f^(8-Td): 0.9^1 = 0.900, 0.9^0 = 1.000 (100% giá trị)</a:t>
             </a:r>
           </a:p>
         </p:txBody>
@@ -6281,7 +6394,7 @@
         <p:spPr>
           <a:xfrm>
             <a:off x="6217920" y="1280160"/>
-            <a:ext cx="5120640" cy="2377440"/>
+            <a:ext cx="5212080" cy="5029200"/>
           </a:xfrm>
           <a:prstGeom prst="roundRect">
             <a:avLst/>
@@ -6326,7 +6439,7 @@
         <p:spPr>
           <a:xfrm>
             <a:off x="6400800" y="1417320"/>
-            <a:ext cx="4754880" cy="365760"/>
+            <a:ext cx="4846320" cy="365760"/>
           </a:xfrm>
           <a:prstGeom prst="rect">
             <a:avLst/>
@@ -6348,7 +6461,7 @@
               </a:defRPr>
             </a:pPr>
             <a:r>
-              <a:t>⚙️ Strategy &amp; Factory Method</a:t>
+              <a:t>🔥 Chứng Minh Thực Nghiệm Vai Trò Của f</a:t>
             </a:r>
           </a:p>
         </p:txBody>
@@ -6361,8 +6474,8 @@
         </p:nvSpPr>
         <p:spPr>
           <a:xfrm>
-            <a:off x="6400800" y="1737360"/>
-            <a:ext cx="4754880" cy="1737360"/>
+            <a:off x="6400800" y="1828800"/>
+            <a:ext cx="4846320" cy="4206240"/>
           </a:xfrm>
           <a:prstGeom prst="rect">
             <a:avLst/>
@@ -6376,258 +6489,52 @@
           <a:lstStyle/>
           <a:p>
             <a:pPr>
-              <a:defRPr sz="1150"/>
+              <a:defRPr sz="1250"/>
             </a:pPr>
             <a:r>
-              <a:t>• EngineMode (Enum): Định nghĩa chiến lược engine độc lập.</a:t>
-            </a:r>
-            <a:br/>
-            <a:r>
-              <a:t>• EngineFactory: Khởi tạo engine phù hợp tại Runtime.</a:t>
-            </a:r>
-            <a:br/>
-            <a:r>
-              <a:t>• Người dùng hoán đổi linh hoạt giữa Local DFS, In-Process và TCP Socket mà không cần khởi động lại ứng dụng.</a:t>
-            </a:r>
-          </a:p>
-        </p:txBody>
-      </p:sp>
-      <p:sp>
-        <p:nvSpPr>
-          <p:cNvPr id="11" name="Rounded Rectangle 10"/>
-          <p:cNvSpPr/>
-          <p:nvPr/>
-        </p:nvSpPr>
-        <p:spPr>
-          <a:xfrm>
-            <a:off x="731520" y="3931920"/>
-            <a:ext cx="5120640" cy="2377440"/>
-          </a:xfrm>
-          <a:prstGeom prst="roundRect">
-            <a:avLst/>
-          </a:prstGeom>
-          <a:solidFill>
-            <a:srgbClr val="FFFFFF"/>
-          </a:solidFill>
-          <a:ln w="19050">
-            <a:solidFill>
-              <a:srgbClr val="2E75B6"/>
-            </a:solidFill>
-          </a:ln>
-        </p:spPr>
-        <p:style>
-          <a:lnRef idx="1">
-            <a:schemeClr val="accent1"/>
-          </a:lnRef>
-          <a:fillRef idx="3">
-            <a:schemeClr val="accent1"/>
-          </a:fillRef>
-          <a:effectRef idx="2">
-            <a:schemeClr val="accent1"/>
-          </a:effectRef>
-          <a:fontRef idx="minor">
-            <a:schemeClr val="lt1"/>
-          </a:fontRef>
-        </p:style>
-        <p:txBody>
-          <a:bodyPr rtlCol="0" anchor="ctr"/>
-          <a:lstStyle/>
-          <a:p>
-            <a:pPr algn="ctr"/>
-          </a:p>
-        </p:txBody>
-      </p:sp>
-      <p:sp>
-        <p:nvSpPr>
-          <p:cNvPr id="12" name="TextBox 11"/>
-          <p:cNvSpPr txBox="1"/>
-          <p:nvPr/>
-        </p:nvSpPr>
-        <p:spPr>
-          <a:xfrm>
-            <a:off x="914400" y="4069080"/>
-            <a:ext cx="4754880" cy="365760"/>
-          </a:xfrm>
-          <a:prstGeom prst="rect">
-            <a:avLst/>
-          </a:prstGeom>
-          <a:noFill/>
-        </p:spPr>
-        <p:txBody>
-          <a:bodyPr wrap="none">
-            <a:spAutoFit/>
-          </a:bodyPr>
-          <a:lstStyle/>
-          <a:p>
+              <a:t>Khi f = 1.0 (Mô hình tĩnh không suy giảm):</a:t>
+            </a:r>
+            <a:br/>
+            <a:r>
+              <a:t>→ Có tới 9 mẫu đạt DHOP: {AE, F, CD, DE, BF, CDE, E, DF, EF}.</a:t>
+            </a:r>
+            <a:br/>
+            <a:r>
+              <a:t>→ Dữ liệu cũ từ T1, T3 vẫn được tính nguyên giá trị như mới.</a:t>
+            </a:r>
+          </a:p>
+          <a:p>
+            <a:br/>
             <a:pPr>
-              <a:defRPr sz="1350" b="1">
+              <a:defRPr sz="1250"/>
+            </a:pPr>
+            <a:r>
+              <a:t>Khi f = 0.9 (Mô hình luồng có suy giảm thời gian):</a:t>
+            </a:r>
+            <a:br/>
+            <a:r>
+              <a:t>→ Chỉ còn đúng 2 mẫu đạt DHOP: {AE} (DO=1.2601) và {F} (DO=1.2553).</a:t>
+            </a:r>
+            <a:br/>
+            <a:r>
+              <a:t>→ Các mẫu cũ như CD, DE, CDE bị suy thoái điểm số và rơi xuống dưới ngưỡng minSup = 1.2.</a:t>
+            </a:r>
+          </a:p>
+          <a:p>
+            <a:br/>
+            <a:pPr>
+              <a:defRPr sz="1250" b="1">
                 <a:solidFill>
-                  <a:srgbClr val="1F4E79"/>
+                  <a:srgbClr val="0E6251"/>
                 </a:solidFill>
-                <a:latin typeface="Arial"/>
               </a:defRPr>
             </a:pPr>
             <a:r>
-              <a:t>📡 Observer Pattern &amp; Memento</a:t>
-            </a:r>
-          </a:p>
-        </p:txBody>
-      </p:sp>
-      <p:sp>
-        <p:nvSpPr>
-          <p:cNvPr id="13" name="TextBox 12"/>
-          <p:cNvSpPr txBox="1"/>
-          <p:nvPr/>
-        </p:nvSpPr>
-        <p:spPr>
-          <a:xfrm>
-            <a:off x="914400" y="4389120"/>
-            <a:ext cx="4754880" cy="1737360"/>
-          </a:xfrm>
-          <a:prstGeom prst="rect">
-            <a:avLst/>
-          </a:prstGeom>
-          <a:noFill/>
-        </p:spPr>
-        <p:txBody>
-          <a:bodyPr wrap="square">
-            <a:spAutoFit/>
-          </a:bodyPr>
-          <a:lstStyle/>
-          <a:p>
-            <a:pPr>
-              <a:defRPr sz="1150"/>
-            </a:pPr>
-            <a:r>
-              <a:t>• MiningProgressListener: Báo cáo tiến độ và sự kiện JSONL.</a:t>
-            </a:r>
-            <a:br/>
-            <a:r>
-              <a:t>• Memento Pattern: Lưu trữ các snapshot lịch sử các lần chạy quét minSup (MiningHistoryManager).</a:t>
-            </a:r>
-            <a:br/>
-            <a:r>
-              <a:t>• Tác vụ chạy nền đa luồng, cập nhật an toàn qua Platform.runLater().</a:t>
-            </a:r>
-          </a:p>
-        </p:txBody>
-      </p:sp>
-      <p:sp>
-        <p:nvSpPr>
-          <p:cNvPr id="14" name="Rounded Rectangle 13"/>
-          <p:cNvSpPr/>
-          <p:nvPr/>
-        </p:nvSpPr>
-        <p:spPr>
-          <a:xfrm>
-            <a:off x="6217920" y="3931920"/>
-            <a:ext cx="5120640" cy="2377440"/>
-          </a:xfrm>
-          <a:prstGeom prst="roundRect">
-            <a:avLst/>
-          </a:prstGeom>
-          <a:solidFill>
-            <a:srgbClr val="FFFFFF"/>
-          </a:solidFill>
-          <a:ln w="19050">
-            <a:solidFill>
-              <a:srgbClr val="2E75B6"/>
-            </a:solidFill>
-          </a:ln>
-        </p:spPr>
-        <p:style>
-          <a:lnRef idx="1">
-            <a:schemeClr val="accent1"/>
-          </a:lnRef>
-          <a:fillRef idx="3">
-            <a:schemeClr val="accent1"/>
-          </a:fillRef>
-          <a:effectRef idx="2">
-            <a:schemeClr val="accent1"/>
-          </a:effectRef>
-          <a:fontRef idx="minor">
-            <a:schemeClr val="lt1"/>
-          </a:fontRef>
-        </p:style>
-        <p:txBody>
-          <a:bodyPr rtlCol="0" anchor="ctr"/>
-          <a:lstStyle/>
-          <a:p>
-            <a:pPr algn="ctr"/>
-          </a:p>
-        </p:txBody>
-      </p:sp>
-      <p:sp>
-        <p:nvSpPr>
-          <p:cNvPr id="15" name="TextBox 14"/>
-          <p:cNvSpPr txBox="1"/>
-          <p:nvPr/>
-        </p:nvSpPr>
-        <p:spPr>
-          <a:xfrm>
-            <a:off x="6400800" y="4069080"/>
-            <a:ext cx="4754880" cy="365760"/>
-          </a:xfrm>
-          <a:prstGeom prst="rect">
-            <a:avLst/>
-          </a:prstGeom>
-          <a:noFill/>
-        </p:spPr>
-        <p:txBody>
-          <a:bodyPr wrap="none">
-            <a:spAutoFit/>
-          </a:bodyPr>
-          <a:lstStyle/>
-          <a:p>
-            <a:pPr>
-              <a:defRPr sz="1350" b="1">
-                <a:solidFill>
-                  <a:srgbClr val="1F4E79"/>
-                </a:solidFill>
-                <a:latin typeface="Arial"/>
-              </a:defRPr>
-            </a:pPr>
-            <a:r>
-              <a:t>🏛️ Monorepo, Singleton &amp; MVC Records</a:t>
-            </a:r>
-          </a:p>
-        </p:txBody>
-      </p:sp>
-      <p:sp>
-        <p:nvSpPr>
-          <p:cNvPr id="16" name="TextBox 15"/>
-          <p:cNvSpPr txBox="1"/>
-          <p:nvPr/>
-        </p:nvSpPr>
-        <p:spPr>
-          <a:xfrm>
-            <a:off x="6400800" y="4389120"/>
-            <a:ext cx="4754880" cy="1737360"/>
-          </a:xfrm>
-          <a:prstGeom prst="rect">
-            <a:avLst/>
-          </a:prstGeom>
-          <a:noFill/>
-        </p:spPr>
-        <p:txBody>
-          <a:bodyPr wrap="square">
-            <a:spAutoFit/>
-          </a:bodyPr>
-          <a:lstStyle/>
-          <a:p>
-            <a:pPr>
-              <a:defRPr sz="1150"/>
-            </a:pPr>
-            <a:r>
-              <a:t>• dhopm-common: Module hợp đồng dùng chung, đảm bảo nguyên lý DIP.</a:t>
-            </a:r>
-            <a:br/>
-            <a:r>
-              <a:t>• Singleton: CalculationLogger và MiningHistoryManager duy nhất.</a:t>
-            </a:r>
-            <a:br/>
-            <a:r>
-              <a:t>• Modern Java Records: Entry, PatternResult, GoldenRow, TopItemStat.</a:t>
+              <a:t>★ KẾT LUẬN QUAN TRỌNG:</a:t>
+            </a:r>
+            <a:br/>
+            <a:r>
+              <a:t>Hệ số f = 0.9 đã loại bỏ 77.8% các mẫu lỗi thời trong quá khứ, giúp doanh nghiệp chỉ tập trung vào các xu hướng thật sự nóng hổi!</a:t>
             </a:r>
           </a:p>
         </p:txBody>
@@ -6762,7 +6669,7 @@
               </a:defRPr>
             </a:pPr>
             <a:r>
-              <a:t>13. Giao Thức TCP Socket Client &amp; Mạng Phân Tán (Protocol 1)</a:t>
+              <a:t>13. Kiến Trúc Phần Mềm &amp; 9 Design Patterns Chuẩn Công Nghiệp</a:t>
             </a:r>
           </a:p>
         </p:txBody>
@@ -6776,7 +6683,7 @@
         <p:spPr>
           <a:xfrm>
             <a:off x="731520" y="1280160"/>
-            <a:ext cx="5120640" cy="5029200"/>
+            <a:ext cx="5120640" cy="2377440"/>
           </a:xfrm>
           <a:prstGeom prst="roundRect">
             <a:avLst/>
@@ -6843,7 +6750,7 @@
               </a:defRPr>
             </a:pPr>
             <a:r>
-              <a:t>🔌 TCP Cổng 7079 &amp; Quét Mạng Tự Động (LAN)</a:t>
+              <a:t>🌉 Bridge &amp; Adapter Pattern</a:t>
             </a:r>
           </a:p>
         </p:txBody>
@@ -6856,8 +6763,8 @@
         </p:nvSpPr>
         <p:spPr>
           <a:xfrm>
-            <a:off x="914400" y="1828800"/>
-            <a:ext cx="4754880" cy="4206240"/>
+            <a:off x="914400" y="1737360"/>
+            <a:ext cx="4754880" cy="1737360"/>
           </a:xfrm>
           <a:prstGeom prst="rect">
             <a:avLst/>
@@ -6874,46 +6781,19 @@
               <a:defRPr sz="1150"/>
             </a:pPr>
             <a:r>
-              <a:t>• Chuẩn hóa Protocol 1 (CONTRACT.md):</a:t>
-            </a:r>
-            <a:br/>
-            <a:r>
-              <a:t>  Giao tiếp qua TCP Socket port 7079, gửi 1 dòng lệnh JSON và nhận stream sự kiện JSONL đa dòng.</a:t>
-            </a:r>
-            <a:br/>
-            <a:br/>
-            <a:r>
-              <a:t>• Kết nối thực tế máy Tson (10.141.0.17:7079):</a:t>
-            </a:r>
-            <a:br/>
-            <a:r>
-              <a:t>  Tích hợp bảng cấu hình IP/Port trực tiếp trên GUI và tính năng 'Quét mạng (LAN)' đa luồng tự động tìm thấy backend trong 15ms.</a:t>
-            </a:r>
-            <a:br/>
-            <a:br/>
-            <a:r>
-              <a:t>• Tích hợp Mock TCP Server nội bộ:</a:t>
-            </a:r>
-            <a:br/>
-            <a:r>
-              <a:t>  Lớp DhopmContractTcpServer chạy ngầm với CachedThreadPool giúp ứng dụng tự chủ kiểm thử độc lập mà không cần server ngoài.</a:t>
-            </a:r>
-            <a:br/>
-            <a:br/>
-            <a:r>
-              <a:t>• Huy hiệu nguồn dữ liệu động (Data Source Badge):</a:t>
-            </a:r>
-            <a:br/>
-            <a:r>
-              <a:t>  🟢 BE (10.141.0.17:7079): Đang kết nối máy Tson.</a:t>
-            </a:r>
-            <a:br/>
-            <a:r>
-              <a:t>  🔵 Tson V1 (In-Process): Đang chạy engine nội bộ.</a:t>
-            </a:r>
-            <a:br/>
-            <a:r>
-              <a:t>  🟡 DEMO (Tâm 8 tx): Đang chạy mô phỏng.</a:t>
+              <a:t>• MainController chỉ phụ thuộc vào Interface BridgeEngine.</a:t>
+            </a:r>
+            <a:br/>
+            <a:r>
+              <a:t>• TamSimulationBridge bọc engine DFS in-memory của Tâm.</a:t>
+            </a:r>
+            <a:br/>
+            <a:r>
+              <a:t>• TsonV1Bridge bọc engine tốc độ cao In-Process.</a:t>
+            </a:r>
+            <a:br/>
+            <a:r>
+              <a:t>• TsonTcpContractBridge bọc kết nối TCP Backend từ xa.</a:t>
             </a:r>
           </a:p>
         </p:txBody>
@@ -6927,7 +6807,7 @@
         <p:spPr>
           <a:xfrm>
             <a:off x="6217920" y="1280160"/>
-            <a:ext cx="5212080" cy="5029200"/>
+            <a:ext cx="5120640" cy="2377440"/>
           </a:xfrm>
           <a:prstGeom prst="roundRect">
             <a:avLst/>
@@ -6937,7 +6817,7 @@
           </a:solidFill>
           <a:ln w="19050">
             <a:solidFill>
-              <a:srgbClr val="0E6251"/>
+              <a:srgbClr val="2E75B6"/>
             </a:solidFill>
           </a:ln>
         </p:spPr>
@@ -6972,7 +6852,7 @@
         <p:spPr>
           <a:xfrm>
             <a:off x="6400800" y="1417320"/>
-            <a:ext cx="4846320" cy="365760"/>
+            <a:ext cx="4754880" cy="365760"/>
           </a:xfrm>
           <a:prstGeom prst="rect">
             <a:avLst/>
@@ -6994,7 +6874,7 @@
               </a:defRPr>
             </a:pPr>
             <a:r>
-              <a:t>⚡ Thuật Toán Khử Trùng Lặp &amp; Phản Chiếu R14</a:t>
+              <a:t>⚙️ Strategy &amp; Factory Method</a:t>
             </a:r>
           </a:p>
         </p:txBody>
@@ -7007,8 +6887,8 @@
         </p:nvSpPr>
         <p:spPr>
           <a:xfrm>
-            <a:off x="6400800" y="1828800"/>
-            <a:ext cx="4846320" cy="4206240"/>
+            <a:off x="6400800" y="1737360"/>
+            <a:ext cx="4754880" cy="1737360"/>
           </a:xfrm>
           <a:prstGeom prst="rect">
             <a:avLst/>
@@ -7025,38 +6905,255 @@
               <a:defRPr sz="1150"/>
             </a:pPr>
             <a:r>
-              <a:t>• Bóc tách độ sâu ngoặc vuông JSON (depth tracking):</a:t>
-            </a:r>
-            <a:br/>
-            <a:r>
-              <a:t>  Ngắt chính xác tại mảng patterns đầu tiên, ngăn chặn hoàn toàn việc nuốt chửng mảng perVersion.v1 từ backend.</a:t>
-            </a:r>
-            <a:br/>
-            <a:br/>
-            <a:r>
-              <a:t>• Thuật toán Khử trùng lặp (deduplicatePatterns):</a:t>
-            </a:r>
-            <a:br/>
-            <a:r>
-              <a:t>  Chuẩn hóa khóa canonicalItemsetKey theo thứ tự từ điển, loại bỏ mẫu trùng (từ 10 dòng lặp xuống 5 dòng chuẩn), giữ lại DO cao nhất.</a:t>
-            </a:r>
-            <a:br/>
-            <a:br/>
-            <a:r>
-              <a:t>• Chuẩn hóa hiển thị normalizePattern:</a:t>
-            </a:r>
-            <a:br/>
-            <a:r>
-              <a:t>  Xử lý triệt để lỗi lồng ngoặc nhọn {{B, F}} về định dạng chuẩn {B, F}, bóc tách danh sách giao dịch TIDs.</a:t>
-            </a:r>
-            <a:br/>
-            <a:br/>
-            <a:r>
-              <a:t>• Quy tắc R14 Phản chiếu tệp cục bộ (Local Mirroring):</a:t>
-            </a:r>
-            <a:br/>
-            <a:r>
-              <a:t>  Client tự động fetch và lưu tệp kết quả tại mine/mine_&lt;fileID&gt;.txt khớp 100% dữ liệu backend.</a:t>
+              <a:t>• EngineMode (Enum): Định nghĩa chiến lược engine độc lập.</a:t>
+            </a:r>
+            <a:br/>
+            <a:r>
+              <a:t>• EngineFactory: Khởi tạo engine phù hợp tại Runtime.</a:t>
+            </a:r>
+            <a:br/>
+            <a:r>
+              <a:t>• Người dùng hoán đổi linh hoạt giữa Local DFS, In-Process và TCP Socket mà không cần khởi động lại ứng dụng.</a:t>
+            </a:r>
+          </a:p>
+        </p:txBody>
+      </p:sp>
+      <p:sp>
+        <p:nvSpPr>
+          <p:cNvPr id="11" name="Rounded Rectangle 10"/>
+          <p:cNvSpPr/>
+          <p:nvPr/>
+        </p:nvSpPr>
+        <p:spPr>
+          <a:xfrm>
+            <a:off x="731520" y="3931920"/>
+            <a:ext cx="5120640" cy="2377440"/>
+          </a:xfrm>
+          <a:prstGeom prst="roundRect">
+            <a:avLst/>
+          </a:prstGeom>
+          <a:solidFill>
+            <a:srgbClr val="FFFFFF"/>
+          </a:solidFill>
+          <a:ln w="19050">
+            <a:solidFill>
+              <a:srgbClr val="2E75B6"/>
+            </a:solidFill>
+          </a:ln>
+        </p:spPr>
+        <p:style>
+          <a:lnRef idx="1">
+            <a:schemeClr val="accent1"/>
+          </a:lnRef>
+          <a:fillRef idx="3">
+            <a:schemeClr val="accent1"/>
+          </a:fillRef>
+          <a:effectRef idx="2">
+            <a:schemeClr val="accent1"/>
+          </a:effectRef>
+          <a:fontRef idx="minor">
+            <a:schemeClr val="lt1"/>
+          </a:fontRef>
+        </p:style>
+        <p:txBody>
+          <a:bodyPr rtlCol="0" anchor="ctr"/>
+          <a:lstStyle/>
+          <a:p>
+            <a:pPr algn="ctr"/>
+          </a:p>
+        </p:txBody>
+      </p:sp>
+      <p:sp>
+        <p:nvSpPr>
+          <p:cNvPr id="12" name="TextBox 11"/>
+          <p:cNvSpPr txBox="1"/>
+          <p:nvPr/>
+        </p:nvSpPr>
+        <p:spPr>
+          <a:xfrm>
+            <a:off x="914400" y="4069080"/>
+            <a:ext cx="4754880" cy="365760"/>
+          </a:xfrm>
+          <a:prstGeom prst="rect">
+            <a:avLst/>
+          </a:prstGeom>
+          <a:noFill/>
+        </p:spPr>
+        <p:txBody>
+          <a:bodyPr wrap="none">
+            <a:spAutoFit/>
+          </a:bodyPr>
+          <a:lstStyle/>
+          <a:p>
+            <a:pPr>
+              <a:defRPr sz="1350" b="1">
+                <a:solidFill>
+                  <a:srgbClr val="1F4E79"/>
+                </a:solidFill>
+                <a:latin typeface="Arial"/>
+              </a:defRPr>
+            </a:pPr>
+            <a:r>
+              <a:t>📡 Observer Pattern &amp; Memento</a:t>
+            </a:r>
+          </a:p>
+        </p:txBody>
+      </p:sp>
+      <p:sp>
+        <p:nvSpPr>
+          <p:cNvPr id="13" name="TextBox 12"/>
+          <p:cNvSpPr txBox="1"/>
+          <p:nvPr/>
+        </p:nvSpPr>
+        <p:spPr>
+          <a:xfrm>
+            <a:off x="914400" y="4389120"/>
+            <a:ext cx="4754880" cy="1737360"/>
+          </a:xfrm>
+          <a:prstGeom prst="rect">
+            <a:avLst/>
+          </a:prstGeom>
+          <a:noFill/>
+        </p:spPr>
+        <p:txBody>
+          <a:bodyPr wrap="square">
+            <a:spAutoFit/>
+          </a:bodyPr>
+          <a:lstStyle/>
+          <a:p>
+            <a:pPr>
+              <a:defRPr sz="1150"/>
+            </a:pPr>
+            <a:r>
+              <a:t>• MiningProgressListener: Báo cáo tiến độ và sự kiện JSONL.</a:t>
+            </a:r>
+            <a:br/>
+            <a:r>
+              <a:t>• Memento Pattern: Lưu trữ các snapshot lịch sử các lần chạy quét minSup (MiningHistoryManager).</a:t>
+            </a:r>
+            <a:br/>
+            <a:r>
+              <a:t>• Tác vụ chạy nền đa luồng, cập nhật an toàn qua Platform.runLater().</a:t>
+            </a:r>
+          </a:p>
+        </p:txBody>
+      </p:sp>
+      <p:sp>
+        <p:nvSpPr>
+          <p:cNvPr id="14" name="Rounded Rectangle 13"/>
+          <p:cNvSpPr/>
+          <p:nvPr/>
+        </p:nvSpPr>
+        <p:spPr>
+          <a:xfrm>
+            <a:off x="6217920" y="3931920"/>
+            <a:ext cx="5120640" cy="2377440"/>
+          </a:xfrm>
+          <a:prstGeom prst="roundRect">
+            <a:avLst/>
+          </a:prstGeom>
+          <a:solidFill>
+            <a:srgbClr val="FFFFFF"/>
+          </a:solidFill>
+          <a:ln w="19050">
+            <a:solidFill>
+              <a:srgbClr val="2E75B6"/>
+            </a:solidFill>
+          </a:ln>
+        </p:spPr>
+        <p:style>
+          <a:lnRef idx="1">
+            <a:schemeClr val="accent1"/>
+          </a:lnRef>
+          <a:fillRef idx="3">
+            <a:schemeClr val="accent1"/>
+          </a:fillRef>
+          <a:effectRef idx="2">
+            <a:schemeClr val="accent1"/>
+          </a:effectRef>
+          <a:fontRef idx="minor">
+            <a:schemeClr val="lt1"/>
+          </a:fontRef>
+        </p:style>
+        <p:txBody>
+          <a:bodyPr rtlCol="0" anchor="ctr"/>
+          <a:lstStyle/>
+          <a:p>
+            <a:pPr algn="ctr"/>
+          </a:p>
+        </p:txBody>
+      </p:sp>
+      <p:sp>
+        <p:nvSpPr>
+          <p:cNvPr id="15" name="TextBox 14"/>
+          <p:cNvSpPr txBox="1"/>
+          <p:nvPr/>
+        </p:nvSpPr>
+        <p:spPr>
+          <a:xfrm>
+            <a:off x="6400800" y="4069080"/>
+            <a:ext cx="4754880" cy="365760"/>
+          </a:xfrm>
+          <a:prstGeom prst="rect">
+            <a:avLst/>
+          </a:prstGeom>
+          <a:noFill/>
+        </p:spPr>
+        <p:txBody>
+          <a:bodyPr wrap="none">
+            <a:spAutoFit/>
+          </a:bodyPr>
+          <a:lstStyle/>
+          <a:p>
+            <a:pPr>
+              <a:defRPr sz="1350" b="1">
+                <a:solidFill>
+                  <a:srgbClr val="1F4E79"/>
+                </a:solidFill>
+                <a:latin typeface="Arial"/>
+              </a:defRPr>
+            </a:pPr>
+            <a:r>
+              <a:t>🏛️ Monorepo, Singleton &amp; MVC Records</a:t>
+            </a:r>
+          </a:p>
+        </p:txBody>
+      </p:sp>
+      <p:sp>
+        <p:nvSpPr>
+          <p:cNvPr id="16" name="TextBox 15"/>
+          <p:cNvSpPr txBox="1"/>
+          <p:nvPr/>
+        </p:nvSpPr>
+        <p:spPr>
+          <a:xfrm>
+            <a:off x="6400800" y="4389120"/>
+            <a:ext cx="4754880" cy="1737360"/>
+          </a:xfrm>
+          <a:prstGeom prst="rect">
+            <a:avLst/>
+          </a:prstGeom>
+          <a:noFill/>
+        </p:spPr>
+        <p:txBody>
+          <a:bodyPr wrap="square">
+            <a:spAutoFit/>
+          </a:bodyPr>
+          <a:lstStyle/>
+          <a:p>
+            <a:pPr>
+              <a:defRPr sz="1150"/>
+            </a:pPr>
+            <a:r>
+              <a:t>• dhopm-common: Module hợp đồng dùng chung, đảm bảo nguyên lý DIP.</a:t>
+            </a:r>
+            <a:br/>
+            <a:r>
+              <a:t>• Singleton: CalculationLogger và MiningHistoryManager duy nhất.</a:t>
+            </a:r>
+            <a:br/>
+            <a:r>
+              <a:t>• Modern Java Records: Entry, PatternResult, GoldenRow, TopItemStat.</a:t>
             </a:r>
           </a:p>
         </p:txBody>
@@ -7191,7 +7288,7 @@
               </a:defRPr>
             </a:pPr>
             <a:r>
-              <a:t>14. Cải Tiến Giao Diện Người Dùng Chuẩn Xác (Loại Bỏ Slider)</a:t>
+              <a:t>14. Giao Thức TCP Socket Client &amp; Mạng Phân Tán (Protocol 1)</a:t>
             </a:r>
           </a:p>
         </p:txBody>
@@ -7215,7 +7312,7 @@
           </a:solidFill>
           <a:ln w="19050">
             <a:solidFill>
-              <a:srgbClr val="D35400"/>
+              <a:srgbClr val="2E75B6"/>
             </a:solidFill>
           </a:ln>
         </p:spPr>
@@ -7272,7 +7369,7 @@
               </a:defRPr>
             </a:pPr>
             <a:r>
-              <a:t>🎯 Loại Bỏ Slider &amp; Đào Tự Động Ngoài Ý Muốn</a:t>
+              <a:t>🔌 TCP Cổng 7079 &amp; Quét Mạng Tự Động (LAN)</a:t>
             </a:r>
           </a:p>
         </p:txBody>
@@ -7300,44 +7397,49 @@
           <a:lstStyle/>
           <a:p>
             <a:pPr>
-              <a:defRPr sz="1200"/>
+              <a:defRPr sz="1150"/>
             </a:pPr>
             <a:r>
-              <a:t>• Vấn đề của Slider cũ:</a:t>
-            </a:r>
-            <a:br/>
-            <a:r>
-              <a:t>  Kéo trượt kích hoạt tính toán liên tục, gây lag và tràn luồng khi dữ liệu lớn.</a:t>
-            </a:r>
-            <a:br/>
-            <a:br/>
-            <a:r>
-              <a:t>• Giải pháp Ô nhập TextField chuẩn xác:</a:t>
-            </a:r>
-            <a:br/>
-            <a:r>
-              <a:t>  - Decay Factor (f): Nhập chính xác 0.9 ∈ (0, 1].</a:t>
-            </a:r>
-            <a:br/>
-            <a:r>
-              <a:t>  - MinSup Ratio (∂): Nhập trực tiếp 0.2 ∈ (0, 1] hoặc %.</a:t>
-            </a:r>
-            <a:br/>
-            <a:r>
-              <a:t>  - MinOcc: Nhập chính xác giá trị thực tế (ẩn ở v1, hiện ở v2/v3).</a:t>
-            </a:r>
-            <a:br/>
-            <a:r>
-              <a:t>  - Limit: Nhập số lượng giới hạn mẫu trả về.</a:t>
-            </a:r>
-            <a:br/>
-            <a:br/>
-            <a:r>
-              <a:t>• Chỉ tính toán khi nhấn nút:</a:t>
-            </a:r>
-            <a:br/>
-            <a:r>
-              <a:t>  Nút Khai phá (Mine) to nhất, nổi bật ở dưới cùng, phân bổ nút Dừng và Golden hàng trên hợp lý.</a:t>
+              <a:t>• Chuẩn hóa Protocol 1 (CONTRACT.md):</a:t>
+            </a:r>
+            <a:br/>
+            <a:r>
+              <a:t>  Giao tiếp qua TCP Socket port 7079, gửi 1 dòng lệnh JSON và nhận stream sự kiện JSONL đa dòng.</a:t>
+            </a:r>
+            <a:br/>
+            <a:br/>
+            <a:r>
+              <a:t>• Kết nối thực tế máy Tson (10.141.0.17:7079):</a:t>
+            </a:r>
+            <a:br/>
+            <a:r>
+              <a:t>  Tích hợp bảng cấu hình IP/Port trực tiếp trên GUI và tính năng 'Quét mạng (LAN)' đa luồng tự động tìm thấy backend trong 15ms.</a:t>
+            </a:r>
+            <a:br/>
+            <a:br/>
+            <a:r>
+              <a:t>• Tích hợp Mock TCP Server nội bộ:</a:t>
+            </a:r>
+            <a:br/>
+            <a:r>
+              <a:t>  Lớp DhopmContractTcpServer chạy ngầm với CachedThreadPool giúp ứng dụng tự chủ kiểm thử độc lập mà không cần server ngoài.</a:t>
+            </a:r>
+            <a:br/>
+            <a:br/>
+            <a:r>
+              <a:t>• Huy hiệu nguồn dữ liệu động (Data Source Badge):</a:t>
+            </a:r>
+            <a:br/>
+            <a:r>
+              <a:t>  🟢 BE (10.141.0.17:7079): Đang kết nối máy Tson.</a:t>
+            </a:r>
+            <a:br/>
+            <a:r>
+              <a:t>  🔵 Tson V1 (In-Process): Đang chạy engine nội bộ.</a:t>
+            </a:r>
+            <a:br/>
+            <a:r>
+              <a:t>  🟡 DEMO (Tâm 8 tx): Đang chạy mô phỏng.</a:t>
             </a:r>
           </a:p>
         </p:txBody>
@@ -7361,7 +7463,7 @@
           </a:solidFill>
           <a:ln w="19050">
             <a:solidFill>
-              <a:srgbClr val="2E75B6"/>
+              <a:srgbClr val="0E6251"/>
             </a:solidFill>
           </a:ln>
         </p:spPr>
@@ -7418,7 +7520,7 @@
               </a:defRPr>
             </a:pPr>
             <a:r>
-              <a:t>📋 100% Native TableView &amp; Cô Lập Demo Panel</a:t>
+              <a:t>⚡ Thuật Toán Khử Trùng Lặp &amp; Phản Chiếu R14</a:t>
             </a:r>
           </a:p>
         </p:txBody>
@@ -7446,32 +7548,41 @@
           <a:lstStyle/>
           <a:p>
             <a:pPr>
-              <a:defRPr sz="1200"/>
+              <a:defRPr sz="1150"/>
             </a:pPr>
             <a:r>
-              <a:t>• Loại bỏ hoàn toàn Terminal Console:</a:t>
-            </a:r>
-            <a:br/>
-            <a:r>
-              <a:t>  Không còn màn hình đen trắng bị lệch font Unicode trên macOS; thay thế bằng TableView native sang trọng.</a:t>
-            </a:r>
-            <a:br/>
-            <a:br/>
-            <a:r>
-              <a:t>• Bảng Mẫu Khai Phá Đa Cột:</a:t>
-            </a:r>
-            <a:br/>
-            <a:r>
-              <a:t>  Hiển thị STT, Itemset X (in đậm tím), DO(X), Support, Độ dài |X|, TIDs.</a:t>
-            </a:r>
-            <a:br/>
-            <a:br/>
-            <a:r>
-              <a:t>• Cô lập Panel 2 cho Luồng Demo:</a:t>
-            </a:r>
-            <a:br/>
-            <a:r>
-              <a:t>  Panel 2 được gắn nhãn minh bạch '📡 LUỒNG DỮ LIỆU [DEMO TÂM]', tách biệt hoàn toàn dữ liệu demo 8 giao dịch khỏi các lượt benchmark Big Data thật.</a:t>
+              <a:t>• Bóc tách độ sâu ngoặc vuông JSON (depth tracking):</a:t>
+            </a:r>
+            <a:br/>
+            <a:r>
+              <a:t>  Ngắt chính xác tại mảng patterns đầu tiên, ngăn chặn hoàn toàn việc nuốt chửng mảng perVersion.v1 từ backend.</a:t>
+            </a:r>
+            <a:br/>
+            <a:br/>
+            <a:r>
+              <a:t>• Thuật toán Khử trùng lặp (deduplicatePatterns):</a:t>
+            </a:r>
+            <a:br/>
+            <a:r>
+              <a:t>  Chuẩn hóa khóa canonicalItemsetKey theo thứ tự từ điển, loại bỏ mẫu trùng (từ 10 dòng lặp xuống 5 dòng chuẩn), giữ lại DO cao nhất.</a:t>
+            </a:r>
+            <a:br/>
+            <a:br/>
+            <a:r>
+              <a:t>• Chuẩn hóa hiển thị normalizePattern:</a:t>
+            </a:r>
+            <a:br/>
+            <a:r>
+              <a:t>  Xử lý triệt để lỗi lồng ngoặc nhọn {{B, F}} về định dạng chuẩn {B, F}, bóc tách danh sách giao dịch TIDs.</a:t>
+            </a:r>
+            <a:br/>
+            <a:br/>
+            <a:r>
+              <a:t>• Quy tắc R14 Phản chiếu tệp cục bộ (Local Mirroring):</a:t>
+            </a:r>
+            <a:br/>
+            <a:r>
+              <a:t>  Client tự động fetch và lưu tệp kết quả tại mine/mine_&lt;fileID&gt;.txt khớp 100% dữ liệu backend.</a:t>
             </a:r>
           </a:p>
         </p:txBody>
@@ -7606,7 +7717,7 @@
               </a:defRPr>
             </a:pPr>
             <a:r>
-              <a:t>15. Tính Năng Đột Phá: Quét minSup Sweep &amp; Calculation Logger</a:t>
+              <a:t>15. Cải Tiến Giao Diện Người Dùng Chuẩn Xác (Loại Bỏ Slider)</a:t>
             </a:r>
           </a:p>
         </p:txBody>
@@ -7621,6 +7732,152 @@
           <a:xfrm>
             <a:off x="731520" y="1280160"/>
             <a:ext cx="5120640" cy="5029200"/>
+          </a:xfrm>
+          <a:prstGeom prst="roundRect">
+            <a:avLst/>
+          </a:prstGeom>
+          <a:solidFill>
+            <a:srgbClr val="FFFFFF"/>
+          </a:solidFill>
+          <a:ln w="19050">
+            <a:solidFill>
+              <a:srgbClr val="D35400"/>
+            </a:solidFill>
+          </a:ln>
+        </p:spPr>
+        <p:style>
+          <a:lnRef idx="1">
+            <a:schemeClr val="accent1"/>
+          </a:lnRef>
+          <a:fillRef idx="3">
+            <a:schemeClr val="accent1"/>
+          </a:fillRef>
+          <a:effectRef idx="2">
+            <a:schemeClr val="accent1"/>
+          </a:effectRef>
+          <a:fontRef idx="minor">
+            <a:schemeClr val="lt1"/>
+          </a:fontRef>
+        </p:style>
+        <p:txBody>
+          <a:bodyPr rtlCol="0" anchor="ctr"/>
+          <a:lstStyle/>
+          <a:p>
+            <a:pPr algn="ctr"/>
+          </a:p>
+        </p:txBody>
+      </p:sp>
+      <p:sp>
+        <p:nvSpPr>
+          <p:cNvPr id="6" name="TextBox 5"/>
+          <p:cNvSpPr txBox="1"/>
+          <p:nvPr/>
+        </p:nvSpPr>
+        <p:spPr>
+          <a:xfrm>
+            <a:off x="914400" y="1417320"/>
+            <a:ext cx="4754880" cy="365760"/>
+          </a:xfrm>
+          <a:prstGeom prst="rect">
+            <a:avLst/>
+          </a:prstGeom>
+          <a:noFill/>
+        </p:spPr>
+        <p:txBody>
+          <a:bodyPr wrap="none">
+            <a:spAutoFit/>
+          </a:bodyPr>
+          <a:lstStyle/>
+          <a:p>
+            <a:pPr>
+              <a:defRPr sz="1350" b="1">
+                <a:solidFill>
+                  <a:srgbClr val="1F4E79"/>
+                </a:solidFill>
+                <a:latin typeface="Arial"/>
+              </a:defRPr>
+            </a:pPr>
+            <a:r>
+              <a:t>🎯 Loại Bỏ Slider &amp; Đào Tự Động Ngoài Ý Muốn</a:t>
+            </a:r>
+          </a:p>
+        </p:txBody>
+      </p:sp>
+      <p:sp>
+        <p:nvSpPr>
+          <p:cNvPr id="7" name="TextBox 6"/>
+          <p:cNvSpPr txBox="1"/>
+          <p:nvPr/>
+        </p:nvSpPr>
+        <p:spPr>
+          <a:xfrm>
+            <a:off x="914400" y="1828800"/>
+            <a:ext cx="4754880" cy="4206240"/>
+          </a:xfrm>
+          <a:prstGeom prst="rect">
+            <a:avLst/>
+          </a:prstGeom>
+          <a:noFill/>
+        </p:spPr>
+        <p:txBody>
+          <a:bodyPr wrap="square">
+            <a:spAutoFit/>
+          </a:bodyPr>
+          <a:lstStyle/>
+          <a:p>
+            <a:pPr>
+              <a:defRPr sz="1200"/>
+            </a:pPr>
+            <a:r>
+              <a:t>• Vấn đề của Slider cũ:</a:t>
+            </a:r>
+            <a:br/>
+            <a:r>
+              <a:t>  Kéo trượt kích hoạt tính toán liên tục, gây lag và tràn luồng khi dữ liệu lớn.</a:t>
+            </a:r>
+            <a:br/>
+            <a:br/>
+            <a:r>
+              <a:t>• Giải pháp Ô nhập TextField chuẩn xác:</a:t>
+            </a:r>
+            <a:br/>
+            <a:r>
+              <a:t>  - Decay Factor (f): Nhập chính xác 0.9 ∈ (0, 1].</a:t>
+            </a:r>
+            <a:br/>
+            <a:r>
+              <a:t>  - MinSup Ratio (∂): Nhập trực tiếp 0.2 ∈ (0, 1] hoặc %.</a:t>
+            </a:r>
+            <a:br/>
+            <a:r>
+              <a:t>  - MinOcc: Nhập chính xác giá trị thực tế (ẩn ở v1, hiện ở v2/v3).</a:t>
+            </a:r>
+            <a:br/>
+            <a:r>
+              <a:t>  - Limit: Nhập số lượng giới hạn mẫu trả về.</a:t>
+            </a:r>
+            <a:br/>
+            <a:br/>
+            <a:r>
+              <a:t>• Chỉ tính toán khi nhấn nút:</a:t>
+            </a:r>
+            <a:br/>
+            <a:r>
+              <a:t>  Nút Khai phá (Mine) to nhất, nổi bật ở dưới cùng, phân bổ nút Dừng và Golden hàng trên hợp lý.</a:t>
+            </a:r>
+          </a:p>
+        </p:txBody>
+      </p:sp>
+      <p:sp>
+        <p:nvSpPr>
+          <p:cNvPr id="8" name="Rounded Rectangle 7"/>
+          <p:cNvSpPr/>
+          <p:nvPr/>
+        </p:nvSpPr>
+        <p:spPr>
+          <a:xfrm>
+            <a:off x="6217920" y="1280160"/>
+            <a:ext cx="5212080" cy="5029200"/>
           </a:xfrm>
           <a:prstGeom prst="roundRect">
             <a:avLst/>
@@ -7658,14 +7915,14 @@
       </p:sp>
       <p:sp>
         <p:nvSpPr>
-          <p:cNvPr id="6" name="TextBox 5"/>
+          <p:cNvPr id="9" name="TextBox 8"/>
           <p:cNvSpPr txBox="1"/>
           <p:nvPr/>
         </p:nvSpPr>
         <p:spPr>
           <a:xfrm>
-            <a:off x="914400" y="1417320"/>
-            <a:ext cx="4754880" cy="365760"/>
+            <a:off x="6400800" y="1417320"/>
+            <a:ext cx="4846320" cy="365760"/>
           </a:xfrm>
           <a:prstGeom prst="rect">
             <a:avLst/>
@@ -7687,21 +7944,21 @@
               </a:defRPr>
             </a:pPr>
             <a:r>
-              <a:t>📈 Quét Ngưỡng minSup Sweep (Chuẩn Bài Báo)</a:t>
-            </a:r>
-          </a:p>
-        </p:txBody>
-      </p:sp>
-      <p:sp>
-        <p:nvSpPr>
-          <p:cNvPr id="7" name="TextBox 6"/>
+              <a:t>📋 100% Native TableView &amp; Cô Lập Demo Panel</a:t>
+            </a:r>
+          </a:p>
+        </p:txBody>
+      </p:sp>
+      <p:sp>
+        <p:nvSpPr>
+          <p:cNvPr id="10" name="TextBox 9"/>
           <p:cNvSpPr txBox="1"/>
           <p:nvPr/>
         </p:nvSpPr>
         <p:spPr>
           <a:xfrm>
-            <a:off x="914400" y="1828800"/>
-            <a:ext cx="4754880" cy="4206240"/>
+            <a:off x="6400800" y="1828800"/>
+            <a:ext cx="4846320" cy="4206240"/>
           </a:xfrm>
           <a:prstGeom prst="rect">
             <a:avLst/>
@@ -7718,178 +7975,29 @@
               <a:defRPr sz="1200"/>
             </a:pPr>
             <a:r>
-              <a:t>• Tự động lặp qua dải ngưỡng ∂ (5% – 50%):</a:t>
-            </a:r>
-            <a:br/>
-            <a:r>
-              <a:t>  Khảo sát toàn diện động thái thuật toán khi thay đổi độ khắt khe của ngưỡng lọc.</a:t>
-            </a:r>
-            <a:br/>
-            <a:br/>
-            <a:r>
-              <a:t>• Tái hiện 3 Biểu đồ Chuẩn Bài Báo EAAI 2026:</a:t>
-            </a:r>
-            <a:br/>
-            <a:r>
-              <a:t>  - Figure 6: Số lượng mẫu DHOP &amp; Tỷ lệ cắt tỉa DUBO theo minSup.</a:t>
-            </a:r>
-            <a:br/>
-            <a:r>
-              <a:t>  - Figure 11: Thời gian thực thi (Runtime ms) giảm hàm mũ.</a:t>
-            </a:r>
-            <a:br/>
-            <a:r>
-              <a:t>  - Figure 13: Bộ nhớ đỉnh (Peak Heap RAM MB).</a:t>
-            </a:r>
-            <a:br/>
-            <a:br/>
-            <a:r>
-              <a:t>• Xóa bỏ số liệu giả lập:</a:t>
-            </a:r>
-            <a:br/>
-            <a:r>
-              <a:t>  Toàn bộ chỉ số đều đo lường trực tiếp từ engine và đã được kiểm chứng bằng ChartPaperVerificationTest.</a:t>
-            </a:r>
-          </a:p>
-        </p:txBody>
-      </p:sp>
-      <p:sp>
-        <p:nvSpPr>
-          <p:cNvPr id="8" name="Rounded Rectangle 7"/>
-          <p:cNvSpPr/>
-          <p:nvPr/>
-        </p:nvSpPr>
-        <p:spPr>
-          <a:xfrm>
-            <a:off x="6217920" y="1280160"/>
-            <a:ext cx="5212080" cy="5029200"/>
-          </a:xfrm>
-          <a:prstGeom prst="roundRect">
-            <a:avLst/>
-          </a:prstGeom>
-          <a:solidFill>
-            <a:srgbClr val="FFFFFF"/>
-          </a:solidFill>
-          <a:ln w="19050">
-            <a:solidFill>
-              <a:srgbClr val="0E6251"/>
-            </a:solidFill>
-          </a:ln>
-        </p:spPr>
-        <p:style>
-          <a:lnRef idx="1">
-            <a:schemeClr val="accent1"/>
-          </a:lnRef>
-          <a:fillRef idx="3">
-            <a:schemeClr val="accent1"/>
-          </a:fillRef>
-          <a:effectRef idx="2">
-            <a:schemeClr val="accent1"/>
-          </a:effectRef>
-          <a:fontRef idx="minor">
-            <a:schemeClr val="lt1"/>
-          </a:fontRef>
-        </p:style>
-        <p:txBody>
-          <a:bodyPr rtlCol="0" anchor="ctr"/>
-          <a:lstStyle/>
-          <a:p>
-            <a:pPr algn="ctr"/>
-          </a:p>
-        </p:txBody>
-      </p:sp>
-      <p:sp>
-        <p:nvSpPr>
-          <p:cNvPr id="9" name="TextBox 8"/>
-          <p:cNvSpPr txBox="1"/>
-          <p:nvPr/>
-        </p:nvSpPr>
-        <p:spPr>
-          <a:xfrm>
-            <a:off x="6400800" y="1417320"/>
-            <a:ext cx="4846320" cy="365760"/>
-          </a:xfrm>
-          <a:prstGeom prst="rect">
-            <a:avLst/>
-          </a:prstGeom>
-          <a:noFill/>
-        </p:spPr>
-        <p:txBody>
-          <a:bodyPr wrap="none">
-            <a:spAutoFit/>
-          </a:bodyPr>
-          <a:lstStyle/>
-          <a:p>
-            <a:pPr>
-              <a:defRPr sz="1350" b="1">
-                <a:solidFill>
-                  <a:srgbClr val="1F4E79"/>
-                </a:solidFill>
-                <a:latin typeface="Arial"/>
-              </a:defRPr>
-            </a:pPr>
-            <a:r>
-              <a:t>📝 Nhật Ký Chi Tiết Phép Toán (Tab 6)</a:t>
-            </a:r>
-          </a:p>
-        </p:txBody>
-      </p:sp>
-      <p:sp>
-        <p:nvSpPr>
-          <p:cNvPr id="10" name="TextBox 9"/>
-          <p:cNvSpPr txBox="1"/>
-          <p:nvPr/>
-        </p:nvSpPr>
-        <p:spPr>
-          <a:xfrm>
-            <a:off x="6400800" y="1828800"/>
-            <a:ext cx="4846320" cy="4206240"/>
-          </a:xfrm>
-          <a:prstGeom prst="rect">
-            <a:avLst/>
-          </a:prstGeom>
-          <a:noFill/>
-        </p:spPr>
-        <p:txBody>
-          <a:bodyPr wrap="square">
-            <a:spAutoFit/>
-          </a:bodyPr>
-          <a:lstStyle/>
-          <a:p>
-            <a:pPr>
-              <a:defRPr sz="1200"/>
-            </a:pPr>
-            <a:r>
-              <a:t>• Ghi nhận chi tiết từng bước tính toán:</a:t>
-            </a:r>
-            <a:br/>
-            <a:r>
-              <a:t>  - Pha 1: Nạp giao dịch &amp; cập nhật trọng số luồng f^(TL-Td).</a:t>
-            </a:r>
-            <a:br/>
-            <a:r>
-              <a:t>  - Pha 2: Tính DO(X) và cận trên DUBO(X).</a:t>
-            </a:r>
-            <a:br/>
-            <a:r>
-              <a:t>  - Pha 3: Duyệt cây đệ quy DFS &amp; quyết định Cắt tỉa (Prune).</a:t>
-            </a:r>
-            <a:br/>
-            <a:br/>
-            <a:r>
-              <a:t>• Công cụ hỗ trợ học tập &amp; giảng dạy:</a:t>
-            </a:r>
-            <a:br/>
-            <a:r>
-              <a:t>  - Tìm kiếm và lọc theo từng pha tính toán.</a:t>
-            </a:r>
-            <a:br/>
-            <a:r>
-              <a:t>  - Sao chép toàn bộ log định dạng chuẩn vào Clipboard.</a:t>
-            </a:r>
-            <a:br/>
-            <a:r>
-              <a:t>  - Ô Inspector giải thích chi tiết lý do mẫu được chọn/bị loại.</a:t>
+              <a:t>• Loại bỏ hoàn toàn Terminal Console:</a:t>
+            </a:r>
+            <a:br/>
+            <a:r>
+              <a:t>  Không còn màn hình đen trắng bị lệch font Unicode trên macOS; thay thế bằng TableView native sang trọng.</a:t>
+            </a:r>
+            <a:br/>
+            <a:br/>
+            <a:r>
+              <a:t>• Bảng Mẫu Khai Phá Đa Cột:</a:t>
+            </a:r>
+            <a:br/>
+            <a:r>
+              <a:t>  Hiển thị STT, Itemset X (in đậm tím), DO(X), Support, Độ dài |X|, TIDs.</a:t>
+            </a:r>
+            <a:br/>
+            <a:br/>
+            <a:r>
+              <a:t>• Cô lập Panel 2 cho Luồng Demo:</a:t>
+            </a:r>
+            <a:br/>
+            <a:r>
+              <a:t>  Panel 2 được gắn nhãn minh bạch '📡 LUỒNG DỮ LIỆU [DEMO TÂM]', tách biệt hoàn toàn dữ liệu demo 8 giao dịch khỏi các lượt benchmark Big Data thật.</a:t>
             </a:r>
           </a:p>
         </p:txBody>
@@ -8024,7 +8132,7 @@
               </a:defRPr>
             </a:pPr>
             <a:r>
-              <a:t>16. Bảng Đối Soát Toàn Diện 3 Cột (3-Column Reconciliation)</a:t>
+              <a:t>16. Tính Năng Đột Phá: Quét minSup Sweep &amp; Calculation Logger</a:t>
             </a:r>
           </a:p>
         </p:txBody>
@@ -8038,7 +8146,7 @@
         <p:spPr>
           <a:xfrm>
             <a:off x="731520" y="1280160"/>
-            <a:ext cx="3291840" cy="5029200"/>
+            <a:ext cx="5120640" cy="5029200"/>
           </a:xfrm>
           <a:prstGeom prst="roundRect">
             <a:avLst/>
@@ -8083,7 +8191,7 @@
         <p:spPr>
           <a:xfrm>
             <a:off x="914400" y="1417320"/>
-            <a:ext cx="2926080" cy="365760"/>
+            <a:ext cx="4754880" cy="365760"/>
           </a:xfrm>
           <a:prstGeom prst="rect">
             <a:avLst/>
@@ -8105,7 +8213,7 @@
               </a:defRPr>
             </a:pPr>
             <a:r>
-              <a:t>1. Tâm DFS Client</a:t>
+              <a:t>📈 Quét Ngưỡng minSup Sweep (Chuẩn Bài Báo)</a:t>
             </a:r>
           </a:p>
         </p:txBody>
@@ -8119,7 +8227,7 @@
         <p:spPr>
           <a:xfrm>
             <a:off x="914400" y="1828800"/>
-            <a:ext cx="2926080" cy="4114800"/>
+            <a:ext cx="4754880" cy="4206240"/>
           </a:xfrm>
           <a:prstGeom prst="rect">
             <a:avLst/>
@@ -8136,35 +8244,37 @@
               <a:defRPr sz="1200"/>
             </a:pPr>
             <a:r>
-              <a:t>• Bản chất: In-Memory DFS</a:t>
-            </a:r>
-            <a:br/>
-            <a:r>
-              <a:t>• Mục đích: Nghiên cứu, kiểm chứng từng bước đệ quy.</a:t>
-            </a:r>
-            <a:br/>
-            <a:r>
-              <a:t>• Dataset: Table 1 (TL = 8)</a:t>
-            </a:r>
-            <a:br/>
-            <a:r>
-              <a:t>• Kết quả (f=0.9, ∂=0.15):</a:t>
-            </a:r>
-            <a:br/>
-            <a:r>
-              <a:t>  {AE}: DO = 1.2601</a:t>
-            </a:r>
-            <a:br/>
-            <a:r>
-              <a:t>  {F}:  DO = 1.2553</a:t>
-            </a:r>
-            <a:br/>
-            <a:r>
-              <a:t>• Tổng mẫu: 2 DHOPs</a:t>
-            </a:r>
-            <a:br/>
-            <a:r>
-              <a:t>• Đánh giá: Khớp 100% bài báo!</a:t>
+              <a:t>• Tự động lặp qua dải ngưỡng ∂ (5% – 50%):</a:t>
+            </a:r>
+            <a:br/>
+            <a:r>
+              <a:t>  Khảo sát toàn diện động thái thuật toán khi thay đổi độ khắt khe của ngưỡng lọc.</a:t>
+            </a:r>
+            <a:br/>
+            <a:br/>
+            <a:r>
+              <a:t>• Tái hiện 3 Biểu đồ Chuẩn Bài Báo EAAI 2026:</a:t>
+            </a:r>
+            <a:br/>
+            <a:r>
+              <a:t>  - Figure 6: Số lượng mẫu DHOP &amp; Tỷ lệ cắt tỉa DUBO theo minSup.</a:t>
+            </a:r>
+            <a:br/>
+            <a:r>
+              <a:t>  - Figure 11: Thời gian thực thi (Runtime ms) giảm hàm mũ.</a:t>
+            </a:r>
+            <a:br/>
+            <a:r>
+              <a:t>  - Figure 13: Bộ nhớ đỉnh (Peak Heap RAM MB).</a:t>
+            </a:r>
+            <a:br/>
+            <a:br/>
+            <a:r>
+              <a:t>• Xóa bỏ số liệu giả lập:</a:t>
+            </a:r>
+            <a:br/>
+            <a:r>
+              <a:t>  Toàn bộ chỉ số đều đo lường trực tiếp từ engine và đã được kiểm chứng bằng ChartPaperVerificationTest.</a:t>
             </a:r>
           </a:p>
         </p:txBody>
@@ -8177,8 +8287,8 @@
         </p:nvSpPr>
         <p:spPr>
           <a:xfrm>
-            <a:off x="4389120" y="1280160"/>
-            <a:ext cx="3291840" cy="5029200"/>
+            <a:off x="6217920" y="1280160"/>
+            <a:ext cx="5212080" cy="5029200"/>
           </a:xfrm>
           <a:prstGeom prst="roundRect">
             <a:avLst/>
@@ -8188,7 +8298,7 @@
           </a:solidFill>
           <a:ln w="19050">
             <a:solidFill>
-              <a:srgbClr val="27AE60"/>
+              <a:srgbClr val="0E6251"/>
             </a:solidFill>
           </a:ln>
         </p:spPr>
@@ -8222,8 +8332,8 @@
         </p:nvSpPr>
         <p:spPr>
           <a:xfrm>
-            <a:off x="4572000" y="1417320"/>
-            <a:ext cx="2926080" cy="365760"/>
+            <a:off x="6400800" y="1417320"/>
+            <a:ext cx="4846320" cy="365760"/>
           </a:xfrm>
           <a:prstGeom prst="rect">
             <a:avLst/>
@@ -8245,7 +8355,7 @@
               </a:defRPr>
             </a:pPr>
             <a:r>
-              <a:t>2. Tson In-Process</a:t>
+              <a:t>📝 Nhật Ký Chi Tiết Phép Toán (Tab 6)</a:t>
             </a:r>
           </a:p>
         </p:txBody>
@@ -8258,8 +8368,8 @@
         </p:nvSpPr>
         <p:spPr>
           <a:xfrm>
-            <a:off x="4572000" y="1828800"/>
-            <a:ext cx="2926080" cy="4114800"/>
+            <a:off x="6400800" y="1828800"/>
+            <a:ext cx="4846320" cy="4206240"/>
           </a:xfrm>
           <a:prstGeom prst="rect">
             <a:avLst/>
@@ -8276,175 +8386,36 @@
               <a:defRPr sz="1200"/>
             </a:pPr>
             <a:r>
-              <a:t>• Bản chất: Engine Java nội bộ</a:t>
-            </a:r>
-            <a:br/>
-            <a:r>
-              <a:t>• Mục đích: Khai phá tốc độ cao offline không cần mạng.</a:t>
-            </a:r>
-            <a:br/>
-            <a:r>
-              <a:t>• Dataset: Table 1 (TL = 8)</a:t>
-            </a:r>
-            <a:br/>
-            <a:r>
-              <a:t>• Kết quả (f=0.9, ∂=0.15):</a:t>
-            </a:r>
-            <a:br/>
-            <a:r>
-              <a:t>  {AE}: DO = 1.2601</a:t>
-            </a:r>
-            <a:br/>
-            <a:r>
-              <a:t>  {F}:  DO = 1.2553</a:t>
-            </a:r>
-            <a:br/>
-            <a:r>
-              <a:t>• Tổng mẫu: 2 DHOPs</a:t>
-            </a:r>
-            <a:br/>
-            <a:r>
-              <a:t>• Đánh giá: Trùng khớp tuyệt đối!</a:t>
-            </a:r>
-          </a:p>
-        </p:txBody>
-      </p:sp>
-      <p:sp>
-        <p:nvSpPr>
-          <p:cNvPr id="11" name="Rounded Rectangle 10"/>
-          <p:cNvSpPr/>
-          <p:nvPr/>
-        </p:nvSpPr>
-        <p:spPr>
-          <a:xfrm>
-            <a:off x="8046720" y="1280160"/>
-            <a:ext cx="3291840" cy="5029200"/>
-          </a:xfrm>
-          <a:prstGeom prst="roundRect">
-            <a:avLst/>
-          </a:prstGeom>
-          <a:solidFill>
-            <a:srgbClr val="FFFFFF"/>
-          </a:solidFill>
-          <a:ln w="19050">
-            <a:solidFill>
-              <a:srgbClr val="8E44AD"/>
-            </a:solidFill>
-          </a:ln>
-        </p:spPr>
-        <p:style>
-          <a:lnRef idx="1">
-            <a:schemeClr val="accent1"/>
-          </a:lnRef>
-          <a:fillRef idx="3">
-            <a:schemeClr val="accent1"/>
-          </a:fillRef>
-          <a:effectRef idx="2">
-            <a:schemeClr val="accent1"/>
-          </a:effectRef>
-          <a:fontRef idx="minor">
-            <a:schemeClr val="lt1"/>
-          </a:fontRef>
-        </p:style>
-        <p:txBody>
-          <a:bodyPr rtlCol="0" anchor="ctr"/>
-          <a:lstStyle/>
-          <a:p>
-            <a:pPr algn="ctr"/>
-          </a:p>
-        </p:txBody>
-      </p:sp>
-      <p:sp>
-        <p:nvSpPr>
-          <p:cNvPr id="12" name="TextBox 11"/>
-          <p:cNvSpPr txBox="1"/>
-          <p:nvPr/>
-        </p:nvSpPr>
-        <p:spPr>
-          <a:xfrm>
-            <a:off x="8229600" y="1417320"/>
-            <a:ext cx="2926080" cy="365760"/>
-          </a:xfrm>
-          <a:prstGeom prst="rect">
-            <a:avLst/>
-          </a:prstGeom>
-          <a:noFill/>
-        </p:spPr>
-        <p:txBody>
-          <a:bodyPr wrap="none">
-            <a:spAutoFit/>
-          </a:bodyPr>
-          <a:lstStyle/>
-          <a:p>
-            <a:pPr>
-              <a:defRPr sz="1350" b="1">
-                <a:solidFill>
-                  <a:srgbClr val="1F4E79"/>
-                </a:solidFill>
-                <a:latin typeface="Arial"/>
-              </a:defRPr>
-            </a:pPr>
-            <a:r>
-              <a:t>3. Tson TCP Backend</a:t>
-            </a:r>
-          </a:p>
-        </p:txBody>
-      </p:sp>
-      <p:sp>
-        <p:nvSpPr>
-          <p:cNvPr id="13" name="TextBox 12"/>
-          <p:cNvSpPr txBox="1"/>
-          <p:nvPr/>
-        </p:nvSpPr>
-        <p:spPr>
-          <a:xfrm>
-            <a:off x="8229600" y="1828800"/>
-            <a:ext cx="2926080" cy="4114800"/>
-          </a:xfrm>
-          <a:prstGeom prst="rect">
-            <a:avLst/>
-          </a:prstGeom>
-          <a:noFill/>
-        </p:spPr>
-        <p:txBody>
-          <a:bodyPr wrap="square">
-            <a:spAutoFit/>
-          </a:bodyPr>
-          <a:lstStyle/>
-          <a:p>
-            <a:pPr>
-              <a:defRPr sz="1200"/>
-            </a:pPr>
-            <a:r>
-              <a:t>• Bản chất: Microservice TCP:7079</a:t>
-            </a:r>
-            <a:br/>
-            <a:r>
-              <a:t>• Mục đích: Xử lý dữ liệu lớn, stream sự kiện JSONL.</a:t>
-            </a:r>
-            <a:br/>
-            <a:r>
-              <a:t>• Dataset: Table 1 (TL = 8)</a:t>
-            </a:r>
-            <a:br/>
-            <a:r>
-              <a:t>• Kết quả (f=0.9, ∂=0.15):</a:t>
-            </a:r>
-            <a:br/>
-            <a:r>
-              <a:t>  {AE}: DO = 1.2601</a:t>
-            </a:r>
-            <a:br/>
-            <a:r>
-              <a:t>  {F}:  DO = 1.2553</a:t>
-            </a:r>
-            <a:br/>
-            <a:r>
-              <a:t>• Tổng mẫu: 2 DHOPs</a:t>
-            </a:r>
-            <a:br/>
-            <a:r>
-              <a:t>• R14: Mirror mine_&lt;id&gt;.txt</a:t>
+              <a:t>• Ghi nhận chi tiết từng bước tính toán:</a:t>
+            </a:r>
+            <a:br/>
+            <a:r>
+              <a:t>  - Pha 1: Nạp giao dịch &amp; cập nhật trọng số luồng f^(TL-Td).</a:t>
+            </a:r>
+            <a:br/>
+            <a:r>
+              <a:t>  - Pha 2: Tính DO(X) và cận trên DUBO(X).</a:t>
+            </a:r>
+            <a:br/>
+            <a:r>
+              <a:t>  - Pha 3: Duyệt cây đệ quy DFS &amp; quyết định Cắt tỉa (Prune).</a:t>
+            </a:r>
+            <a:br/>
+            <a:br/>
+            <a:r>
+              <a:t>• Công cụ hỗ trợ học tập &amp; giảng dạy:</a:t>
+            </a:r>
+            <a:br/>
+            <a:r>
+              <a:t>  - Tìm kiếm và lọc theo từng pha tính toán.</a:t>
+            </a:r>
+            <a:br/>
+            <a:r>
+              <a:t>  - Sao chép toàn bộ log định dạng chuẩn vào Clipboard.</a:t>
+            </a:r>
+            <a:br/>
+            <a:r>
+              <a:t>  - Ô Inspector giải thích chi tiết lý do mẫu được chọn/bị loại.</a:t>
             </a:r>
           </a:p>
         </p:txBody>
@@ -8579,7 +8550,7 @@
               </a:defRPr>
             </a:pPr>
             <a:r>
-              <a:t>17. Kết Quả Kiểm Thử (78/78 Tests PASS) &amp; Ma Trận Golden</a:t>
+              <a:t>17. Bảng Đối Soát Toàn Diện 3 Cột (3-Column Reconciliation)</a:t>
             </a:r>
           </a:p>
         </p:txBody>
@@ -8593,7 +8564,7 @@
         <p:spPr>
           <a:xfrm>
             <a:off x="731520" y="1280160"/>
-            <a:ext cx="3931920" cy="5029200"/>
+            <a:ext cx="3291840" cy="5029200"/>
           </a:xfrm>
           <a:prstGeom prst="roundRect">
             <a:avLst/>
@@ -8638,7 +8609,7 @@
         <p:spPr>
           <a:xfrm>
             <a:off x="914400" y="1417320"/>
-            <a:ext cx="3566160" cy="365760"/>
+            <a:ext cx="2926080" cy="365760"/>
           </a:xfrm>
           <a:prstGeom prst="rect">
             <a:avLst/>
@@ -8660,7 +8631,7 @@
               </a:defRPr>
             </a:pPr>
             <a:r>
-              <a:t>✅ 78/78 Unit Tests PASS 100%</a:t>
+              <a:t>1. Tâm DFS Client</a:t>
             </a:r>
           </a:p>
         </p:txBody>
@@ -8674,7 +8645,7 @@
         <p:spPr>
           <a:xfrm>
             <a:off x="914400" y="1828800"/>
-            <a:ext cx="3566160" cy="4206240"/>
+            <a:ext cx="2926080" cy="4114800"/>
           </a:xfrm>
           <a:prstGeom prst="rect">
             <a:avLst/>
@@ -8688,10 +8659,565 @@
           <a:lstStyle/>
           <a:p>
             <a:pPr>
+              <a:defRPr sz="1200"/>
+            </a:pPr>
+            <a:r>
+              <a:t>• Bản chất: In-Memory DFS</a:t>
+            </a:r>
+            <a:br/>
+            <a:r>
+              <a:t>• Mục đích: Nghiên cứu, kiểm chứng từng bước đệ quy.</a:t>
+            </a:r>
+            <a:br/>
+            <a:r>
+              <a:t>• Dataset: Table 1 (TL = 8)</a:t>
+            </a:r>
+            <a:br/>
+            <a:r>
+              <a:t>• Kết quả (f=0.9, ∂=0.15):</a:t>
+            </a:r>
+            <a:br/>
+            <a:r>
+              <a:t>  {AE}: DO = 1.2601</a:t>
+            </a:r>
+            <a:br/>
+            <a:r>
+              <a:t>  {F}:  DO = 1.2553</a:t>
+            </a:r>
+            <a:br/>
+            <a:r>
+              <a:t>• Tổng mẫu: 2 DHOPs</a:t>
+            </a:r>
+            <a:br/>
+            <a:r>
+              <a:t>• Đánh giá: Khớp 100% bài báo!</a:t>
+            </a:r>
+          </a:p>
+        </p:txBody>
+      </p:sp>
+      <p:sp>
+        <p:nvSpPr>
+          <p:cNvPr id="8" name="Rounded Rectangle 7"/>
+          <p:cNvSpPr/>
+          <p:nvPr/>
+        </p:nvSpPr>
+        <p:spPr>
+          <a:xfrm>
+            <a:off x="4389120" y="1280160"/>
+            <a:ext cx="3291840" cy="5029200"/>
+          </a:xfrm>
+          <a:prstGeom prst="roundRect">
+            <a:avLst/>
+          </a:prstGeom>
+          <a:solidFill>
+            <a:srgbClr val="FFFFFF"/>
+          </a:solidFill>
+          <a:ln w="19050">
+            <a:solidFill>
+              <a:srgbClr val="27AE60"/>
+            </a:solidFill>
+          </a:ln>
+        </p:spPr>
+        <p:style>
+          <a:lnRef idx="1">
+            <a:schemeClr val="accent1"/>
+          </a:lnRef>
+          <a:fillRef idx="3">
+            <a:schemeClr val="accent1"/>
+          </a:fillRef>
+          <a:effectRef idx="2">
+            <a:schemeClr val="accent1"/>
+          </a:effectRef>
+          <a:fontRef idx="minor">
+            <a:schemeClr val="lt1"/>
+          </a:fontRef>
+        </p:style>
+        <p:txBody>
+          <a:bodyPr rtlCol="0" anchor="ctr"/>
+          <a:lstStyle/>
+          <a:p>
+            <a:pPr algn="ctr"/>
+          </a:p>
+        </p:txBody>
+      </p:sp>
+      <p:sp>
+        <p:nvSpPr>
+          <p:cNvPr id="9" name="TextBox 8"/>
+          <p:cNvSpPr txBox="1"/>
+          <p:nvPr/>
+        </p:nvSpPr>
+        <p:spPr>
+          <a:xfrm>
+            <a:off x="4572000" y="1417320"/>
+            <a:ext cx="2926080" cy="365760"/>
+          </a:xfrm>
+          <a:prstGeom prst="rect">
+            <a:avLst/>
+          </a:prstGeom>
+          <a:noFill/>
+        </p:spPr>
+        <p:txBody>
+          <a:bodyPr wrap="none">
+            <a:spAutoFit/>
+          </a:bodyPr>
+          <a:lstStyle/>
+          <a:p>
+            <a:pPr>
+              <a:defRPr sz="1350" b="1">
+                <a:solidFill>
+                  <a:srgbClr val="1F4E79"/>
+                </a:solidFill>
+                <a:latin typeface="Arial"/>
+              </a:defRPr>
+            </a:pPr>
+            <a:r>
+              <a:t>2. Tson In-Process</a:t>
+            </a:r>
+          </a:p>
+        </p:txBody>
+      </p:sp>
+      <p:sp>
+        <p:nvSpPr>
+          <p:cNvPr id="10" name="TextBox 9"/>
+          <p:cNvSpPr txBox="1"/>
+          <p:nvPr/>
+        </p:nvSpPr>
+        <p:spPr>
+          <a:xfrm>
+            <a:off x="4572000" y="1828800"/>
+            <a:ext cx="2926080" cy="4114800"/>
+          </a:xfrm>
+          <a:prstGeom prst="rect">
+            <a:avLst/>
+          </a:prstGeom>
+          <a:noFill/>
+        </p:spPr>
+        <p:txBody>
+          <a:bodyPr wrap="square">
+            <a:spAutoFit/>
+          </a:bodyPr>
+          <a:lstStyle/>
+          <a:p>
+            <a:pPr>
+              <a:defRPr sz="1200"/>
+            </a:pPr>
+            <a:r>
+              <a:t>• Bản chất: Engine Java nội bộ</a:t>
+            </a:r>
+            <a:br/>
+            <a:r>
+              <a:t>• Mục đích: Khai phá tốc độ cao offline không cần mạng.</a:t>
+            </a:r>
+            <a:br/>
+            <a:r>
+              <a:t>• Dataset: Table 1 (TL = 8)</a:t>
+            </a:r>
+            <a:br/>
+            <a:r>
+              <a:t>• Kết quả (f=0.9, ∂=0.15):</a:t>
+            </a:r>
+            <a:br/>
+            <a:r>
+              <a:t>  {AE}: DO = 1.2601</a:t>
+            </a:r>
+            <a:br/>
+            <a:r>
+              <a:t>  {F}:  DO = 1.2553</a:t>
+            </a:r>
+            <a:br/>
+            <a:r>
+              <a:t>• Tổng mẫu: 2 DHOPs</a:t>
+            </a:r>
+            <a:br/>
+            <a:r>
+              <a:t>• Đánh giá: Trùng khớp tuyệt đối!</a:t>
+            </a:r>
+          </a:p>
+        </p:txBody>
+      </p:sp>
+      <p:sp>
+        <p:nvSpPr>
+          <p:cNvPr id="11" name="Rounded Rectangle 10"/>
+          <p:cNvSpPr/>
+          <p:nvPr/>
+        </p:nvSpPr>
+        <p:spPr>
+          <a:xfrm>
+            <a:off x="8046720" y="1280160"/>
+            <a:ext cx="3291840" cy="5029200"/>
+          </a:xfrm>
+          <a:prstGeom prst="roundRect">
+            <a:avLst/>
+          </a:prstGeom>
+          <a:solidFill>
+            <a:srgbClr val="FFFFFF"/>
+          </a:solidFill>
+          <a:ln w="19050">
+            <a:solidFill>
+              <a:srgbClr val="8E44AD"/>
+            </a:solidFill>
+          </a:ln>
+        </p:spPr>
+        <p:style>
+          <a:lnRef idx="1">
+            <a:schemeClr val="accent1"/>
+          </a:lnRef>
+          <a:fillRef idx="3">
+            <a:schemeClr val="accent1"/>
+          </a:fillRef>
+          <a:effectRef idx="2">
+            <a:schemeClr val="accent1"/>
+          </a:effectRef>
+          <a:fontRef idx="minor">
+            <a:schemeClr val="lt1"/>
+          </a:fontRef>
+        </p:style>
+        <p:txBody>
+          <a:bodyPr rtlCol="0" anchor="ctr"/>
+          <a:lstStyle/>
+          <a:p>
+            <a:pPr algn="ctr"/>
+          </a:p>
+        </p:txBody>
+      </p:sp>
+      <p:sp>
+        <p:nvSpPr>
+          <p:cNvPr id="12" name="TextBox 11"/>
+          <p:cNvSpPr txBox="1"/>
+          <p:nvPr/>
+        </p:nvSpPr>
+        <p:spPr>
+          <a:xfrm>
+            <a:off x="8229600" y="1417320"/>
+            <a:ext cx="2926080" cy="365760"/>
+          </a:xfrm>
+          <a:prstGeom prst="rect">
+            <a:avLst/>
+          </a:prstGeom>
+          <a:noFill/>
+        </p:spPr>
+        <p:txBody>
+          <a:bodyPr wrap="none">
+            <a:spAutoFit/>
+          </a:bodyPr>
+          <a:lstStyle/>
+          <a:p>
+            <a:pPr>
+              <a:defRPr sz="1350" b="1">
+                <a:solidFill>
+                  <a:srgbClr val="1F4E79"/>
+                </a:solidFill>
+                <a:latin typeface="Arial"/>
+              </a:defRPr>
+            </a:pPr>
+            <a:r>
+              <a:t>3. Tson TCP Backend</a:t>
+            </a:r>
+          </a:p>
+        </p:txBody>
+      </p:sp>
+      <p:sp>
+        <p:nvSpPr>
+          <p:cNvPr id="13" name="TextBox 12"/>
+          <p:cNvSpPr txBox="1"/>
+          <p:nvPr/>
+        </p:nvSpPr>
+        <p:spPr>
+          <a:xfrm>
+            <a:off x="8229600" y="1828800"/>
+            <a:ext cx="2926080" cy="4114800"/>
+          </a:xfrm>
+          <a:prstGeom prst="rect">
+            <a:avLst/>
+          </a:prstGeom>
+          <a:noFill/>
+        </p:spPr>
+        <p:txBody>
+          <a:bodyPr wrap="square">
+            <a:spAutoFit/>
+          </a:bodyPr>
+          <a:lstStyle/>
+          <a:p>
+            <a:pPr>
+              <a:defRPr sz="1200"/>
+            </a:pPr>
+            <a:r>
+              <a:t>• Bản chất: Microservice TCP:7079</a:t>
+            </a:r>
+            <a:br/>
+            <a:r>
+              <a:t>• Mục đích: Xử lý dữ liệu lớn, stream sự kiện JSONL.</a:t>
+            </a:r>
+            <a:br/>
+            <a:r>
+              <a:t>• Dataset: Table 1 (TL = 8)</a:t>
+            </a:r>
+            <a:br/>
+            <a:r>
+              <a:t>• Kết quả (f=0.9, ∂=0.15):</a:t>
+            </a:r>
+            <a:br/>
+            <a:r>
+              <a:t>  {AE}: DO = 1.2601</a:t>
+            </a:r>
+            <a:br/>
+            <a:r>
+              <a:t>  {F}:  DO = 1.2553</a:t>
+            </a:r>
+            <a:br/>
+            <a:r>
+              <a:t>• Tổng mẫu: 2 DHOPs</a:t>
+            </a:r>
+            <a:br/>
+            <a:r>
+              <a:t>• R14: Mirror mine_&lt;id&gt;.txt</a:t>
+            </a:r>
+          </a:p>
+        </p:txBody>
+      </p:sp>
+    </p:spTree>
+  </p:cSld>
+  <p:clrMapOvr>
+    <a:masterClrMapping/>
+  </p:clrMapOvr>
+</p:sld>
+</file>
+
+<file path=ppt/slides/slide18.xml><?xml version="1.0" encoding="utf-8"?>
+<p:sld xmlns:a="http://schemas.openxmlformats.org/drawingml/2006/main" xmlns:p="http://schemas.openxmlformats.org/presentationml/2006/main" xmlns:r="http://schemas.openxmlformats.org/officeDocument/2006/relationships">
+  <p:cSld>
+    <p:spTree>
+      <p:nvGrpSpPr>
+        <p:cNvPr id="1" name=""/>
+        <p:cNvGrpSpPr/>
+        <p:nvPr/>
+      </p:nvGrpSpPr>
+      <p:grpSpPr/>
+      <p:sp>
+        <p:nvSpPr>
+          <p:cNvPr id="2" name="Rectangle 1"/>
+          <p:cNvSpPr/>
+          <p:nvPr/>
+        </p:nvSpPr>
+        <p:spPr>
+          <a:xfrm>
+            <a:off x="0" y="0"/>
+            <a:ext cx="12191695" cy="1005840"/>
+          </a:xfrm>
+          <a:prstGeom prst="rect">
+            <a:avLst/>
+          </a:prstGeom>
+          <a:solidFill>
+            <a:srgbClr val="1F4E79"/>
+          </a:solidFill>
+          <a:ln>
+            <a:solidFill>
+              <a:srgbClr val="1F4E79"/>
+            </a:solidFill>
+          </a:ln>
+        </p:spPr>
+        <p:style>
+          <a:lnRef idx="1">
+            <a:schemeClr val="accent1"/>
+          </a:lnRef>
+          <a:fillRef idx="3">
+            <a:schemeClr val="accent1"/>
+          </a:fillRef>
+          <a:effectRef idx="2">
+            <a:schemeClr val="accent1"/>
+          </a:effectRef>
+          <a:fontRef idx="minor">
+            <a:schemeClr val="lt1"/>
+          </a:fontRef>
+        </p:style>
+        <p:txBody>
+          <a:bodyPr rtlCol="0" anchor="ctr"/>
+          <a:lstStyle/>
+          <a:p>
+            <a:pPr algn="ctr"/>
+          </a:p>
+        </p:txBody>
+      </p:sp>
+      <p:sp>
+        <p:nvSpPr>
+          <p:cNvPr id="3" name="TextBox 2"/>
+          <p:cNvSpPr txBox="1"/>
+          <p:nvPr/>
+        </p:nvSpPr>
+        <p:spPr>
+          <a:xfrm>
+            <a:off x="731520" y="109728"/>
+            <a:ext cx="10515600" cy="274320"/>
+          </a:xfrm>
+          <a:prstGeom prst="rect">
+            <a:avLst/>
+          </a:prstGeom>
+          <a:noFill/>
+        </p:spPr>
+        <p:txBody>
+          <a:bodyPr wrap="none">
+            <a:spAutoFit/>
+          </a:bodyPr>
+          <a:lstStyle/>
+          <a:p>
+            <a:pPr>
+              <a:defRPr sz="1000" b="1">
+                <a:solidFill>
+                  <a:srgbClr val="A9DFBF"/>
+                </a:solidFill>
+                <a:latin typeface="Arial"/>
+              </a:defRPr>
+            </a:pPr>
+            <a:r>
+              <a:t>LẬP TRÌNH JAVA NÂNG CAO | ĐỒ ÁN MÔN HỌC</a:t>
+            </a:r>
+          </a:p>
+        </p:txBody>
+      </p:sp>
+      <p:sp>
+        <p:nvSpPr>
+          <p:cNvPr id="4" name="TextBox 3"/>
+          <p:cNvSpPr txBox="1"/>
+          <p:nvPr/>
+        </p:nvSpPr>
+        <p:spPr>
+          <a:xfrm>
+            <a:off x="731520" y="365760"/>
+            <a:ext cx="10515600" cy="548640"/>
+          </a:xfrm>
+          <a:prstGeom prst="rect">
+            <a:avLst/>
+          </a:prstGeom>
+          <a:noFill/>
+        </p:spPr>
+        <p:txBody>
+          <a:bodyPr wrap="none">
+            <a:spAutoFit/>
+          </a:bodyPr>
+          <a:lstStyle/>
+          <a:p>
+            <a:pPr>
+              <a:defRPr sz="2200" b="1">
+                <a:solidFill>
+                  <a:srgbClr val="FFFFFF"/>
+                </a:solidFill>
+                <a:latin typeface="Arial"/>
+              </a:defRPr>
+            </a:pPr>
+            <a:r>
+              <a:t>18. Kết Quả Kiểm Thử (80/80 Tests PASS) &amp; Ma Trận Golden</a:t>
+            </a:r>
+          </a:p>
+        </p:txBody>
+      </p:sp>
+      <p:sp>
+        <p:nvSpPr>
+          <p:cNvPr id="5" name="Rounded Rectangle 4"/>
+          <p:cNvSpPr/>
+          <p:nvPr/>
+        </p:nvSpPr>
+        <p:spPr>
+          <a:xfrm>
+            <a:off x="731520" y="1280160"/>
+            <a:ext cx="3931920" cy="5029200"/>
+          </a:xfrm>
+          <a:prstGeom prst="roundRect">
+            <a:avLst/>
+          </a:prstGeom>
+          <a:solidFill>
+            <a:srgbClr val="FFFFFF"/>
+          </a:solidFill>
+          <a:ln w="19050">
+            <a:solidFill>
+              <a:srgbClr val="2E75B6"/>
+            </a:solidFill>
+          </a:ln>
+        </p:spPr>
+        <p:style>
+          <a:lnRef idx="1">
+            <a:schemeClr val="accent1"/>
+          </a:lnRef>
+          <a:fillRef idx="3">
+            <a:schemeClr val="accent1"/>
+          </a:fillRef>
+          <a:effectRef idx="2">
+            <a:schemeClr val="accent1"/>
+          </a:effectRef>
+          <a:fontRef idx="minor">
+            <a:schemeClr val="lt1"/>
+          </a:fontRef>
+        </p:style>
+        <p:txBody>
+          <a:bodyPr rtlCol="0" anchor="ctr"/>
+          <a:lstStyle/>
+          <a:p>
+            <a:pPr algn="ctr"/>
+          </a:p>
+        </p:txBody>
+      </p:sp>
+      <p:sp>
+        <p:nvSpPr>
+          <p:cNvPr id="6" name="TextBox 5"/>
+          <p:cNvSpPr txBox="1"/>
+          <p:nvPr/>
+        </p:nvSpPr>
+        <p:spPr>
+          <a:xfrm>
+            <a:off x="914400" y="1417320"/>
+            <a:ext cx="3566160" cy="365760"/>
+          </a:xfrm>
+          <a:prstGeom prst="rect">
+            <a:avLst/>
+          </a:prstGeom>
+          <a:noFill/>
+        </p:spPr>
+        <p:txBody>
+          <a:bodyPr wrap="none">
+            <a:spAutoFit/>
+          </a:bodyPr>
+          <a:lstStyle/>
+          <a:p>
+            <a:pPr>
+              <a:defRPr sz="1350" b="1">
+                <a:solidFill>
+                  <a:srgbClr val="1F4E79"/>
+                </a:solidFill>
+                <a:latin typeface="Arial"/>
+              </a:defRPr>
+            </a:pPr>
+            <a:r>
+              <a:t>✅ 80/80 Unit Tests PASS 100%</a:t>
+            </a:r>
+          </a:p>
+        </p:txBody>
+      </p:sp>
+      <p:sp>
+        <p:nvSpPr>
+          <p:cNvPr id="7" name="TextBox 6"/>
+          <p:cNvSpPr txBox="1"/>
+          <p:nvPr/>
+        </p:nvSpPr>
+        <p:spPr>
+          <a:xfrm>
+            <a:off x="914400" y="1828800"/>
+            <a:ext cx="3566160" cy="4206240"/>
+          </a:xfrm>
+          <a:prstGeom prst="rect">
+            <a:avLst/>
+          </a:prstGeom>
+          <a:noFill/>
+        </p:spPr>
+        <p:txBody>
+          <a:bodyPr wrap="square">
+            <a:spAutoFit/>
+          </a:bodyPr>
+          <a:lstStyle/>
+          <a:p>
+            <a:pPr>
               <a:defRPr sz="1000"/>
             </a:pPr>
             <a:r>
-              <a:t>• 78/78 Tests PASS (BUILD SUCCESS):</a:t>
+              <a:t>• 80/80 Tests PASS (BUILD SUCCESS):</a:t>
             </a:r>
             <a:br/>
             <a:br/>
@@ -8744,7 +9270,7 @@
             </a:r>
             <a:br/>
             <a:r>
-              <a:t>• MinOccWindowTest (15 tests) ← MỚI!</a:t>
+              <a:t>• MinOccWindowTest (17 tests) ← MỚI!</a:t>
             </a:r>
             <a:br/>
             <a:br/>
@@ -9669,418 +10195,6 @@
 </p:sld>
 </file>
 
-<file path=ppt/slides/slide18.xml><?xml version="1.0" encoding="utf-8"?>
-<p:sld xmlns:a="http://schemas.openxmlformats.org/drawingml/2006/main" xmlns:p="http://schemas.openxmlformats.org/presentationml/2006/main" xmlns:r="http://schemas.openxmlformats.org/officeDocument/2006/relationships">
-  <p:cSld>
-    <p:spTree>
-      <p:nvGrpSpPr>
-        <p:cNvPr id="1" name=""/>
-        <p:cNvGrpSpPr/>
-        <p:nvPr/>
-      </p:nvGrpSpPr>
-      <p:grpSpPr/>
-      <p:sp>
-        <p:nvSpPr>
-          <p:cNvPr id="2" name="Rectangle 1"/>
-          <p:cNvSpPr/>
-          <p:nvPr/>
-        </p:nvSpPr>
-        <p:spPr>
-          <a:xfrm>
-            <a:off x="0" y="0"/>
-            <a:ext cx="12191695" cy="1005840"/>
-          </a:xfrm>
-          <a:prstGeom prst="rect">
-            <a:avLst/>
-          </a:prstGeom>
-          <a:solidFill>
-            <a:srgbClr val="1F4E79"/>
-          </a:solidFill>
-          <a:ln>
-            <a:solidFill>
-              <a:srgbClr val="1F4E79"/>
-            </a:solidFill>
-          </a:ln>
-        </p:spPr>
-        <p:style>
-          <a:lnRef idx="1">
-            <a:schemeClr val="accent1"/>
-          </a:lnRef>
-          <a:fillRef idx="3">
-            <a:schemeClr val="accent1"/>
-          </a:fillRef>
-          <a:effectRef idx="2">
-            <a:schemeClr val="accent1"/>
-          </a:effectRef>
-          <a:fontRef idx="minor">
-            <a:schemeClr val="lt1"/>
-          </a:fontRef>
-        </p:style>
-        <p:txBody>
-          <a:bodyPr rtlCol="0" anchor="ctr"/>
-          <a:lstStyle/>
-          <a:p>
-            <a:pPr algn="ctr"/>
-          </a:p>
-        </p:txBody>
-      </p:sp>
-      <p:sp>
-        <p:nvSpPr>
-          <p:cNvPr id="3" name="TextBox 2"/>
-          <p:cNvSpPr txBox="1"/>
-          <p:nvPr/>
-        </p:nvSpPr>
-        <p:spPr>
-          <a:xfrm>
-            <a:off x="731520" y="109728"/>
-            <a:ext cx="10515600" cy="274320"/>
-          </a:xfrm>
-          <a:prstGeom prst="rect">
-            <a:avLst/>
-          </a:prstGeom>
-          <a:noFill/>
-        </p:spPr>
-        <p:txBody>
-          <a:bodyPr wrap="none">
-            <a:spAutoFit/>
-          </a:bodyPr>
-          <a:lstStyle/>
-          <a:p>
-            <a:pPr>
-              <a:defRPr sz="1000" b="1">
-                <a:solidFill>
-                  <a:srgbClr val="A9DFBF"/>
-                </a:solidFill>
-                <a:latin typeface="Arial"/>
-              </a:defRPr>
-            </a:pPr>
-            <a:r>
-              <a:t>LẬP TRÌNH JAVA NÂNG CAO | ĐỒ ÁN MÔN HỌC</a:t>
-            </a:r>
-          </a:p>
-        </p:txBody>
-      </p:sp>
-      <p:sp>
-        <p:nvSpPr>
-          <p:cNvPr id="4" name="TextBox 3"/>
-          <p:cNvSpPr txBox="1"/>
-          <p:nvPr/>
-        </p:nvSpPr>
-        <p:spPr>
-          <a:xfrm>
-            <a:off x="731520" y="365760"/>
-            <a:ext cx="10515600" cy="548640"/>
-          </a:xfrm>
-          <a:prstGeom prst="rect">
-            <a:avLst/>
-          </a:prstGeom>
-          <a:noFill/>
-        </p:spPr>
-        <p:txBody>
-          <a:bodyPr wrap="none">
-            <a:spAutoFit/>
-          </a:bodyPr>
-          <a:lstStyle/>
-          <a:p>
-            <a:pPr>
-              <a:defRPr sz="2200" b="1">
-                <a:solidFill>
-                  <a:srgbClr val="FFFFFF"/>
-                </a:solidFill>
-                <a:latin typeface="Arial"/>
-              </a:defRPr>
-            </a:pPr>
-            <a:r>
-              <a:t>18. Kết Luận &amp; Hướng Phát Triển Tiếp Theo</a:t>
-            </a:r>
-          </a:p>
-        </p:txBody>
-      </p:sp>
-      <p:sp>
-        <p:nvSpPr>
-          <p:cNvPr id="5" name="Rounded Rectangle 4"/>
-          <p:cNvSpPr/>
-          <p:nvPr/>
-        </p:nvSpPr>
-        <p:spPr>
-          <a:xfrm>
-            <a:off x="731520" y="1280160"/>
-            <a:ext cx="5120640" cy="5029200"/>
-          </a:xfrm>
-          <a:prstGeom prst="roundRect">
-            <a:avLst/>
-          </a:prstGeom>
-          <a:solidFill>
-            <a:srgbClr val="FFFFFF"/>
-          </a:solidFill>
-          <a:ln w="19050">
-            <a:solidFill>
-              <a:srgbClr val="27AE60"/>
-            </a:solidFill>
-          </a:ln>
-        </p:spPr>
-        <p:style>
-          <a:lnRef idx="1">
-            <a:schemeClr val="accent1"/>
-          </a:lnRef>
-          <a:fillRef idx="3">
-            <a:schemeClr val="accent1"/>
-          </a:fillRef>
-          <a:effectRef idx="2">
-            <a:schemeClr val="accent1"/>
-          </a:effectRef>
-          <a:fontRef idx="minor">
-            <a:schemeClr val="lt1"/>
-          </a:fontRef>
-        </p:style>
-        <p:txBody>
-          <a:bodyPr rtlCol="0" anchor="ctr"/>
-          <a:lstStyle/>
-          <a:p>
-            <a:pPr algn="ctr"/>
-          </a:p>
-        </p:txBody>
-      </p:sp>
-      <p:sp>
-        <p:nvSpPr>
-          <p:cNvPr id="6" name="TextBox 5"/>
-          <p:cNvSpPr txBox="1"/>
-          <p:nvPr/>
-        </p:nvSpPr>
-        <p:spPr>
-          <a:xfrm>
-            <a:off x="914400" y="1417320"/>
-            <a:ext cx="4754880" cy="365760"/>
-          </a:xfrm>
-          <a:prstGeom prst="rect">
-            <a:avLst/>
-          </a:prstGeom>
-          <a:noFill/>
-        </p:spPr>
-        <p:txBody>
-          <a:bodyPr wrap="none">
-            <a:spAutoFit/>
-          </a:bodyPr>
-          <a:lstStyle/>
-          <a:p>
-            <a:pPr>
-              <a:defRPr sz="1350" b="1">
-                <a:solidFill>
-                  <a:srgbClr val="1F4E79"/>
-                </a:solidFill>
-                <a:latin typeface="Arial"/>
-              </a:defRPr>
-            </a:pPr>
-            <a:r>
-              <a:t>🏆 Kết Quả Đạt Được</a:t>
-            </a:r>
-          </a:p>
-        </p:txBody>
-      </p:sp>
-      <p:sp>
-        <p:nvSpPr>
-          <p:cNvPr id="7" name="TextBox 6"/>
-          <p:cNvSpPr txBox="1"/>
-          <p:nvPr/>
-        </p:nvSpPr>
-        <p:spPr>
-          <a:xfrm>
-            <a:off x="914400" y="1828800"/>
-            <a:ext cx="4754880" cy="4206240"/>
-          </a:xfrm>
-          <a:prstGeom prst="rect">
-            <a:avLst/>
-          </a:prstGeom>
-          <a:noFill/>
-        </p:spPr>
-        <p:txBody>
-          <a:bodyPr wrap="square">
-            <a:spAutoFit/>
-          </a:bodyPr>
-          <a:lstStyle/>
-          <a:p>
-            <a:pPr>
-              <a:defRPr sz="1200"/>
-            </a:pPr>
-            <a:r>
-              <a:t>• Hoàn thành 100% mục tiêu đề ra:</a:t>
-            </a:r>
-            <a:br/>
-            <a:r>
-              <a:t>  Làm chủ lý thuyết bài báo quốc tế EAAI 2026 và cài đặt chính xác tuyệt đối.</a:t>
-            </a:r>
-            <a:br/>
-            <a:br/>
-            <a:r>
-              <a:t>• Kiến trúc chuẩn công nghiệp:</a:t>
-            </a:r>
-            <a:br/>
-            <a:r>
-              <a:t>  Áp dụng hoàn hảo 9 Design Patterns, phân tầng sạch Monorepo và nguyên lý DIP.</a:t>
-            </a:r>
-            <a:br/>
-            <a:br/>
-            <a:r>
-              <a:t>• Giao diện JavaFX hiện đại không slider:</a:t>
-            </a:r>
-            <a:br/>
-            <a:r>
-              <a:t>  Loại bỏ hoàn toàn console và slider, sử dụng 100% TableView native và ô nhập chuẩn xác.</a:t>
-            </a:r>
-            <a:br/>
-            <a:br/>
-            <a:r>
-              <a:t>• Kiểm thử tự động tin cậy:</a:t>
-            </a:r>
-            <a:br/>
-            <a:r>
-              <a:t>  63/63 unit tests vượt qua, xác thực thành công ma trận Golden Tests và biểu đồ Fig 2, 6, 11, 13.</a:t>
-            </a:r>
-          </a:p>
-        </p:txBody>
-      </p:sp>
-      <p:sp>
-        <p:nvSpPr>
-          <p:cNvPr id="8" name="Rounded Rectangle 7"/>
-          <p:cNvSpPr/>
-          <p:nvPr/>
-        </p:nvSpPr>
-        <p:spPr>
-          <a:xfrm>
-            <a:off x="6217920" y="1280160"/>
-            <a:ext cx="5212080" cy="5029200"/>
-          </a:xfrm>
-          <a:prstGeom prst="roundRect">
-            <a:avLst/>
-          </a:prstGeom>
-          <a:solidFill>
-            <a:srgbClr val="FFFFFF"/>
-          </a:solidFill>
-          <a:ln w="19050">
-            <a:solidFill>
-              <a:srgbClr val="2E75B6"/>
-            </a:solidFill>
-          </a:ln>
-        </p:spPr>
-        <p:style>
-          <a:lnRef idx="1">
-            <a:schemeClr val="accent1"/>
-          </a:lnRef>
-          <a:fillRef idx="3">
-            <a:schemeClr val="accent1"/>
-          </a:fillRef>
-          <a:effectRef idx="2">
-            <a:schemeClr val="accent1"/>
-          </a:effectRef>
-          <a:fontRef idx="minor">
-            <a:schemeClr val="lt1"/>
-          </a:fontRef>
-        </p:style>
-        <p:txBody>
-          <a:bodyPr rtlCol="0" anchor="ctr"/>
-          <a:lstStyle/>
-          <a:p>
-            <a:pPr algn="ctr"/>
-          </a:p>
-        </p:txBody>
-      </p:sp>
-      <p:sp>
-        <p:nvSpPr>
-          <p:cNvPr id="9" name="TextBox 8"/>
-          <p:cNvSpPr txBox="1"/>
-          <p:nvPr/>
-        </p:nvSpPr>
-        <p:spPr>
-          <a:xfrm>
-            <a:off x="6400800" y="1417320"/>
-            <a:ext cx="4846320" cy="365760"/>
-          </a:xfrm>
-          <a:prstGeom prst="rect">
-            <a:avLst/>
-          </a:prstGeom>
-          <a:noFill/>
-        </p:spPr>
-        <p:txBody>
-          <a:bodyPr wrap="none">
-            <a:spAutoFit/>
-          </a:bodyPr>
-          <a:lstStyle/>
-          <a:p>
-            <a:pPr>
-              <a:defRPr sz="1350" b="1">
-                <a:solidFill>
-                  <a:srgbClr val="1F4E79"/>
-                </a:solidFill>
-                <a:latin typeface="Arial"/>
-              </a:defRPr>
-            </a:pPr>
-            <a:r>
-              <a:t>🚀 Hướng Phát Triển Tiếp Theo</a:t>
-            </a:r>
-          </a:p>
-        </p:txBody>
-      </p:sp>
-      <p:sp>
-        <p:nvSpPr>
-          <p:cNvPr id="10" name="TextBox 9"/>
-          <p:cNvSpPr txBox="1"/>
-          <p:nvPr/>
-        </p:nvSpPr>
-        <p:spPr>
-          <a:xfrm>
-            <a:off x="6400800" y="1828800"/>
-            <a:ext cx="4846320" cy="4206240"/>
-          </a:xfrm>
-          <a:prstGeom prst="rect">
-            <a:avLst/>
-          </a:prstGeom>
-          <a:noFill/>
-        </p:spPr>
-        <p:txBody>
-          <a:bodyPr wrap="square">
-            <a:spAutoFit/>
-          </a:bodyPr>
-          <a:lstStyle/>
-          <a:p>
-            <a:pPr>
-              <a:defRPr sz="1200"/>
-            </a:pPr>
-            <a:r>
-              <a:t>• Tối ưu hóa BitSet DFS (V2 Engine):</a:t>
-            </a:r>
-            <a:br/>
-            <a:r>
-              <a:t>  Ứng dụng mảng bit và phép toán AND phần cứng để tăng tốc độ giao cắt giao dịch lên gấp 10 lần.</a:t>
-            </a:r>
-            <a:br/>
-            <a:br/>
-            <a:r>
-              <a:t>• Tích hợp Apache Kafka:</a:t>
-            </a:r>
-            <a:br/>
-            <a:r>
-              <a:t>  Đóng gói thành microservice nhận luồng giao dịch trực tiếp từ các sàn thương mại điện tử lớn.</a:t>
-            </a:r>
-            <a:br/>
-            <a:br/>
-            <a:r>
-              <a:t>• Xử lý phân tán Apache Flink / Spark:</a:t>
-            </a:r>
-            <a:br/>
-            <a:r>
-              <a:t>  Triển khai cụm tính toán phân tán để mở rộng quy mô xử lý hàng triệu giao dịch mỗi giây.</a:t>
-            </a:r>
-          </a:p>
-        </p:txBody>
-      </p:sp>
-    </p:spTree>
-  </p:cSld>
-  <p:clrMapOvr>
-    <a:masterClrMapping/>
-  </p:clrMapOvr>
-</p:sld>
-</file>
-
 <file path=ppt/slides/slide19.xml><?xml version="1.0" encoding="utf-8"?>
 <p:sld xmlns:a="http://schemas.openxmlformats.org/drawingml/2006/main" xmlns:p="http://schemas.openxmlformats.org/presentationml/2006/main" xmlns:r="http://schemas.openxmlformats.org/officeDocument/2006/relationships">
   <p:cSld>
@@ -10100,7 +10214,7 @@
         <p:spPr>
           <a:xfrm>
             <a:off x="0" y="0"/>
-            <a:ext cx="12191695" cy="6858000"/>
+            <a:ext cx="12191695" cy="1005840"/>
           </a:xfrm>
           <a:prstGeom prst="rect">
             <a:avLst/>
@@ -10144,8 +10258,8 @@
         </p:nvSpPr>
         <p:spPr>
           <a:xfrm>
-            <a:off x="914400" y="1645920"/>
-            <a:ext cx="10332720" cy="3200400"/>
+            <a:off x="731520" y="109728"/>
+            <a:ext cx="10515600" cy="274320"/>
           </a:xfrm>
           <a:prstGeom prst="rect">
             <a:avLst/>
@@ -10158,8 +10272,44 @@
           </a:bodyPr>
           <a:lstStyle/>
           <a:p>
-            <a:pPr algn="ctr">
-              <a:defRPr sz="3600" b="1">
+            <a:pPr>
+              <a:defRPr sz="1000" b="1">
+                <a:solidFill>
+                  <a:srgbClr val="A9DFBF"/>
+                </a:solidFill>
+                <a:latin typeface="Arial"/>
+              </a:defRPr>
+            </a:pPr>
+            <a:r>
+              <a:t>LẬP TRÌNH JAVA NÂNG CAO | ĐỒ ÁN MÔN HỌC</a:t>
+            </a:r>
+          </a:p>
+        </p:txBody>
+      </p:sp>
+      <p:sp>
+        <p:nvSpPr>
+          <p:cNvPr id="4" name="TextBox 3"/>
+          <p:cNvSpPr txBox="1"/>
+          <p:nvPr/>
+        </p:nvSpPr>
+        <p:spPr>
+          <a:xfrm>
+            <a:off x="731520" y="365760"/>
+            <a:ext cx="10515600" cy="548640"/>
+          </a:xfrm>
+          <a:prstGeom prst="rect">
+            <a:avLst/>
+          </a:prstGeom>
+          <a:noFill/>
+        </p:spPr>
+        <p:txBody>
+          <a:bodyPr wrap="none">
+            <a:spAutoFit/>
+          </a:bodyPr>
+          <a:lstStyle/>
+          <a:p>
+            <a:pPr>
+              <a:defRPr sz="2200" b="1">
                 <a:solidFill>
                   <a:srgbClr val="FFFFFF"/>
                 </a:solidFill>
@@ -10167,20 +10317,284 @@
               </a:defRPr>
             </a:pPr>
             <a:r>
-              <a:t>XIN CHÂN THÀNH CẢM ƠN QUÝ THẦY CÔ VÀ CÁC BẠN!</a:t>
-            </a:r>
-          </a:p>
-          <a:p>
-            <a:pPr algn="ctr">
-              <a:defRPr sz="1900">
+              <a:t>19. Kết Luận &amp; Hướng Phát Triển Tiếp Theo</a:t>
+            </a:r>
+          </a:p>
+        </p:txBody>
+      </p:sp>
+      <p:sp>
+        <p:nvSpPr>
+          <p:cNvPr id="5" name="Rounded Rectangle 4"/>
+          <p:cNvSpPr/>
+          <p:nvPr/>
+        </p:nvSpPr>
+        <p:spPr>
+          <a:xfrm>
+            <a:off x="731520" y="1280160"/>
+            <a:ext cx="5120640" cy="5029200"/>
+          </a:xfrm>
+          <a:prstGeom prst="roundRect">
+            <a:avLst/>
+          </a:prstGeom>
+          <a:solidFill>
+            <a:srgbClr val="FFFFFF"/>
+          </a:solidFill>
+          <a:ln w="19050">
+            <a:solidFill>
+              <a:srgbClr val="27AE60"/>
+            </a:solidFill>
+          </a:ln>
+        </p:spPr>
+        <p:style>
+          <a:lnRef idx="1">
+            <a:schemeClr val="accent1"/>
+          </a:lnRef>
+          <a:fillRef idx="3">
+            <a:schemeClr val="accent1"/>
+          </a:fillRef>
+          <a:effectRef idx="2">
+            <a:schemeClr val="accent1"/>
+          </a:effectRef>
+          <a:fontRef idx="minor">
+            <a:schemeClr val="lt1"/>
+          </a:fontRef>
+        </p:style>
+        <p:txBody>
+          <a:bodyPr rtlCol="0" anchor="ctr"/>
+          <a:lstStyle/>
+          <a:p>
+            <a:pPr algn="ctr"/>
+          </a:p>
+        </p:txBody>
+      </p:sp>
+      <p:sp>
+        <p:nvSpPr>
+          <p:cNvPr id="6" name="TextBox 5"/>
+          <p:cNvSpPr txBox="1"/>
+          <p:nvPr/>
+        </p:nvSpPr>
+        <p:spPr>
+          <a:xfrm>
+            <a:off x="914400" y="1417320"/>
+            <a:ext cx="4754880" cy="365760"/>
+          </a:xfrm>
+          <a:prstGeom prst="rect">
+            <a:avLst/>
+          </a:prstGeom>
+          <a:noFill/>
+        </p:spPr>
+        <p:txBody>
+          <a:bodyPr wrap="none">
+            <a:spAutoFit/>
+          </a:bodyPr>
+          <a:lstStyle/>
+          <a:p>
+            <a:pPr>
+              <a:defRPr sz="1350" b="1">
                 <a:solidFill>
-                  <a:srgbClr val="85C1E9"/>
+                  <a:srgbClr val="1F4E79"/>
                 </a:solidFill>
                 <a:latin typeface="Arial"/>
               </a:defRPr>
             </a:pPr>
             <a:r>
-              <a:t>Em xin kính mời Quý Thầy Cô đặt câu hỏi phản biện và theo dõi phần Demo trực tiếp phần mềm!</a:t>
+              <a:t>🏆 Kết Quả Đạt Được</a:t>
+            </a:r>
+          </a:p>
+        </p:txBody>
+      </p:sp>
+      <p:sp>
+        <p:nvSpPr>
+          <p:cNvPr id="7" name="TextBox 6"/>
+          <p:cNvSpPr txBox="1"/>
+          <p:nvPr/>
+        </p:nvSpPr>
+        <p:spPr>
+          <a:xfrm>
+            <a:off x="914400" y="1828800"/>
+            <a:ext cx="4754880" cy="4206240"/>
+          </a:xfrm>
+          <a:prstGeom prst="rect">
+            <a:avLst/>
+          </a:prstGeom>
+          <a:noFill/>
+        </p:spPr>
+        <p:txBody>
+          <a:bodyPr wrap="square">
+            <a:spAutoFit/>
+          </a:bodyPr>
+          <a:lstStyle/>
+          <a:p>
+            <a:pPr>
+              <a:defRPr sz="1200"/>
+            </a:pPr>
+            <a:r>
+              <a:t>• Hoàn thành 100% mục tiêu đề ra:</a:t>
+            </a:r>
+            <a:br/>
+            <a:r>
+              <a:t>  Làm chủ lý thuyết bài báo quốc tế EAAI 2026 và cài đặt chính xác tuyệt đối.</a:t>
+            </a:r>
+            <a:br/>
+            <a:br/>
+            <a:r>
+              <a:t>• Kiến trúc chuẩn công nghiệp:</a:t>
+            </a:r>
+            <a:br/>
+            <a:r>
+              <a:t>  Áp dụng hoàn hảo 9 Design Patterns, phân tầng sạch Monorepo và nguyên lý DIP.</a:t>
+            </a:r>
+            <a:br/>
+            <a:br/>
+            <a:r>
+              <a:t>• Giao diện JavaFX hiện đại không slider:</a:t>
+            </a:r>
+            <a:br/>
+            <a:r>
+              <a:t>  Loại bỏ hoàn toàn console và slider, sử dụng 100% TableView native và ô nhập chuẩn xác.</a:t>
+            </a:r>
+            <a:br/>
+            <a:br/>
+            <a:r>
+              <a:t>• Kiểm thử tự động tin cậy:</a:t>
+            </a:r>
+            <a:br/>
+            <a:r>
+              <a:t>  63/63 unit tests vượt qua, xác thực thành công ma trận Golden Tests và biểu đồ Fig 2, 6, 11, 13.</a:t>
+            </a:r>
+          </a:p>
+        </p:txBody>
+      </p:sp>
+      <p:sp>
+        <p:nvSpPr>
+          <p:cNvPr id="8" name="Rounded Rectangle 7"/>
+          <p:cNvSpPr/>
+          <p:nvPr/>
+        </p:nvSpPr>
+        <p:spPr>
+          <a:xfrm>
+            <a:off x="6217920" y="1280160"/>
+            <a:ext cx="5212080" cy="5029200"/>
+          </a:xfrm>
+          <a:prstGeom prst="roundRect">
+            <a:avLst/>
+          </a:prstGeom>
+          <a:solidFill>
+            <a:srgbClr val="FFFFFF"/>
+          </a:solidFill>
+          <a:ln w="19050">
+            <a:solidFill>
+              <a:srgbClr val="2E75B6"/>
+            </a:solidFill>
+          </a:ln>
+        </p:spPr>
+        <p:style>
+          <a:lnRef idx="1">
+            <a:schemeClr val="accent1"/>
+          </a:lnRef>
+          <a:fillRef idx="3">
+            <a:schemeClr val="accent1"/>
+          </a:fillRef>
+          <a:effectRef idx="2">
+            <a:schemeClr val="accent1"/>
+          </a:effectRef>
+          <a:fontRef idx="minor">
+            <a:schemeClr val="lt1"/>
+          </a:fontRef>
+        </p:style>
+        <p:txBody>
+          <a:bodyPr rtlCol="0" anchor="ctr"/>
+          <a:lstStyle/>
+          <a:p>
+            <a:pPr algn="ctr"/>
+          </a:p>
+        </p:txBody>
+      </p:sp>
+      <p:sp>
+        <p:nvSpPr>
+          <p:cNvPr id="9" name="TextBox 8"/>
+          <p:cNvSpPr txBox="1"/>
+          <p:nvPr/>
+        </p:nvSpPr>
+        <p:spPr>
+          <a:xfrm>
+            <a:off x="6400800" y="1417320"/>
+            <a:ext cx="4846320" cy="365760"/>
+          </a:xfrm>
+          <a:prstGeom prst="rect">
+            <a:avLst/>
+          </a:prstGeom>
+          <a:noFill/>
+        </p:spPr>
+        <p:txBody>
+          <a:bodyPr wrap="none">
+            <a:spAutoFit/>
+          </a:bodyPr>
+          <a:lstStyle/>
+          <a:p>
+            <a:pPr>
+              <a:defRPr sz="1350" b="1">
+                <a:solidFill>
+                  <a:srgbClr val="1F4E79"/>
+                </a:solidFill>
+                <a:latin typeface="Arial"/>
+              </a:defRPr>
+            </a:pPr>
+            <a:r>
+              <a:t>🚀 Hướng Phát Triển Tiếp Theo</a:t>
+            </a:r>
+          </a:p>
+        </p:txBody>
+      </p:sp>
+      <p:sp>
+        <p:nvSpPr>
+          <p:cNvPr id="10" name="TextBox 9"/>
+          <p:cNvSpPr txBox="1"/>
+          <p:nvPr/>
+        </p:nvSpPr>
+        <p:spPr>
+          <a:xfrm>
+            <a:off x="6400800" y="1828800"/>
+            <a:ext cx="4846320" cy="4206240"/>
+          </a:xfrm>
+          <a:prstGeom prst="rect">
+            <a:avLst/>
+          </a:prstGeom>
+          <a:noFill/>
+        </p:spPr>
+        <p:txBody>
+          <a:bodyPr wrap="square">
+            <a:spAutoFit/>
+          </a:bodyPr>
+          <a:lstStyle/>
+          <a:p>
+            <a:pPr>
+              <a:defRPr sz="1200"/>
+            </a:pPr>
+            <a:r>
+              <a:t>• Tối ưu hóa BitSet DFS (V2 Engine):</a:t>
+            </a:r>
+            <a:br/>
+            <a:r>
+              <a:t>  Ứng dụng mảng bit và phép toán AND phần cứng để tăng tốc độ giao cắt giao dịch lên gấp 10 lần.</a:t>
+            </a:r>
+            <a:br/>
+            <a:br/>
+            <a:r>
+              <a:t>• Tích hợp Apache Kafka:</a:t>
+            </a:r>
+            <a:br/>
+            <a:r>
+              <a:t>  Đóng gói thành microservice nhận luồng giao dịch trực tiếp từ các sàn thương mại điện tử lớn.</a:t>
+            </a:r>
+            <a:br/>
+            <a:br/>
+            <a:r>
+              <a:t>• Xử lý phân tán Apache Flink / Spark:</a:t>
+            </a:r>
+            <a:br/>
+            <a:r>
+              <a:t>  Triển khai cụm tính toán phân tán để mở rộng quy mô xử lý hàng triệu giao dịch mỗi giây.</a:t>
             </a:r>
           </a:p>
         </p:txBody>
@@ -10608,6 +11022,118 @@
             <a:br/>
             <a:r>
               <a:t>  Đo lường mức độ thống trị, ưu tiên các tổ hợp chiếm tỷ lệ lớn trong từng giao dịch cụ thể.</a:t>
+            </a:r>
+          </a:p>
+        </p:txBody>
+      </p:sp>
+    </p:spTree>
+  </p:cSld>
+  <p:clrMapOvr>
+    <a:masterClrMapping/>
+  </p:clrMapOvr>
+</p:sld>
+</file>
+
+<file path=ppt/slides/slide20.xml><?xml version="1.0" encoding="utf-8"?>
+<p:sld xmlns:a="http://schemas.openxmlformats.org/drawingml/2006/main" xmlns:p="http://schemas.openxmlformats.org/presentationml/2006/main" xmlns:r="http://schemas.openxmlformats.org/officeDocument/2006/relationships">
+  <p:cSld>
+    <p:spTree>
+      <p:nvGrpSpPr>
+        <p:cNvPr id="1" name=""/>
+        <p:cNvGrpSpPr/>
+        <p:nvPr/>
+      </p:nvGrpSpPr>
+      <p:grpSpPr/>
+      <p:sp>
+        <p:nvSpPr>
+          <p:cNvPr id="2" name="Rectangle 1"/>
+          <p:cNvSpPr/>
+          <p:nvPr/>
+        </p:nvSpPr>
+        <p:spPr>
+          <a:xfrm>
+            <a:off x="0" y="0"/>
+            <a:ext cx="12191695" cy="6858000"/>
+          </a:xfrm>
+          <a:prstGeom prst="rect">
+            <a:avLst/>
+          </a:prstGeom>
+          <a:solidFill>
+            <a:srgbClr val="1F4E79"/>
+          </a:solidFill>
+          <a:ln>
+            <a:solidFill>
+              <a:srgbClr val="1F4E79"/>
+            </a:solidFill>
+          </a:ln>
+        </p:spPr>
+        <p:style>
+          <a:lnRef idx="1">
+            <a:schemeClr val="accent1"/>
+          </a:lnRef>
+          <a:fillRef idx="3">
+            <a:schemeClr val="accent1"/>
+          </a:fillRef>
+          <a:effectRef idx="2">
+            <a:schemeClr val="accent1"/>
+          </a:effectRef>
+          <a:fontRef idx="minor">
+            <a:schemeClr val="lt1"/>
+          </a:fontRef>
+        </p:style>
+        <p:txBody>
+          <a:bodyPr rtlCol="0" anchor="ctr"/>
+          <a:lstStyle/>
+          <a:p>
+            <a:pPr algn="ctr"/>
+          </a:p>
+        </p:txBody>
+      </p:sp>
+      <p:sp>
+        <p:nvSpPr>
+          <p:cNvPr id="3" name="TextBox 2"/>
+          <p:cNvSpPr txBox="1"/>
+          <p:nvPr/>
+        </p:nvSpPr>
+        <p:spPr>
+          <a:xfrm>
+            <a:off x="914400" y="1645920"/>
+            <a:ext cx="10332720" cy="3200400"/>
+          </a:xfrm>
+          <a:prstGeom prst="rect">
+            <a:avLst/>
+          </a:prstGeom>
+          <a:noFill/>
+        </p:spPr>
+        <p:txBody>
+          <a:bodyPr wrap="none">
+            <a:spAutoFit/>
+          </a:bodyPr>
+          <a:lstStyle/>
+          <a:p>
+            <a:pPr algn="ctr">
+              <a:defRPr sz="3600" b="1">
+                <a:solidFill>
+                  <a:srgbClr val="FFFFFF"/>
+                </a:solidFill>
+                <a:latin typeface="Arial"/>
+              </a:defRPr>
+            </a:pPr>
+            <a:r>
+              <a:t>XIN CHÂN THÀNH CẢM ƠN QUÝ THẦY CÔ VÀ CÁC BẠN!</a:t>
+            </a:r>
+          </a:p>
+          <a:p>
+            <a:pPr algn="ctr">
+              <a:defRPr sz="1900">
+                <a:solidFill>
+                  <a:srgbClr val="85C1E9"/>
+                </a:solidFill>
+                <a:latin typeface="Arial"/>
+              </a:defRPr>
+            </a:pPr>
+            <a:r>
+              <a:t>Em xin kính mời Quý Thầy Cô đặt câu hỏi phản biện và theo dõi phần Demo trực tiếp phần mềm!</a:t>
             </a:r>
           </a:p>
         </p:txBody>

</xml_diff>